<commit_message>
style(presentations): harmonize slide backgrounds to consistent executive corporate light palette
</commit_message>
<xml_diff>
--- a/presentations/Executive_Presentation.pptx
+++ b/presentations/Executive_Presentation.pptx
@@ -3111,7 +3111,7 @@
             <a:avLst/>
           </a:prstGeom>
           <a:solidFill>
-            <a:srgbClr val="0F172A"/>
+            <a:srgbClr val="F8FAFC"/>
           </a:solidFill>
           <a:ln>
             <a:noFill/>
@@ -3141,14 +3141,59 @@
       </p:sp>
       <p:sp>
         <p:nvSpPr>
-          <p:cNvPr id="3" name="Rectangle 2"/>
+          <p:cNvPr id="3" name="Rounded Rectangle 2"/>
           <p:cNvSpPr/>
           <p:nvPr/>
         </p:nvSpPr>
         <p:spPr>
           <a:xfrm>
-            <a:off x="914400" y="1645920"/>
-            <a:ext cx="1097280" cy="73152"/>
+            <a:off x="731520" y="731520"/>
+            <a:ext cx="10725912" cy="5394960"/>
+          </a:xfrm>
+          <a:prstGeom prst="roundRect">
+            <a:avLst/>
+          </a:prstGeom>
+          <a:solidFill>
+            <a:srgbClr val="FFFFFF"/>
+          </a:solidFill>
+          <a:ln w="12700">
+            <a:solidFill>
+              <a:srgbClr val="E2E8F0"/>
+            </a:solidFill>
+          </a:ln>
+        </p:spPr>
+        <p:style>
+          <a:lnRef idx="1">
+            <a:schemeClr val="accent1"/>
+          </a:lnRef>
+          <a:fillRef idx="3">
+            <a:schemeClr val="accent1"/>
+          </a:fillRef>
+          <a:effectRef idx="2">
+            <a:schemeClr val="accent1"/>
+          </a:effectRef>
+          <a:fontRef idx="minor">
+            <a:schemeClr val="lt1"/>
+          </a:fontRef>
+        </p:style>
+        <p:txBody>
+          <a:bodyPr rtlCol="0" anchor="ctr"/>
+          <a:lstStyle/>
+          <a:p>
+            <a:pPr algn="ctr"/>
+          </a:p>
+        </p:txBody>
+      </p:sp>
+      <p:sp>
+        <p:nvSpPr>
+          <p:cNvPr id="4" name="Rectangle 3"/>
+          <p:cNvSpPr/>
+          <p:nvPr/>
+        </p:nvSpPr>
+        <p:spPr>
+          <a:xfrm>
+            <a:off x="731520" y="731520"/>
+            <a:ext cx="10725912" cy="109728"/>
           </a:xfrm>
           <a:prstGeom prst="rect">
             <a:avLst/>
@@ -3184,14 +3229,14 @@
       </p:sp>
       <p:sp>
         <p:nvSpPr>
-          <p:cNvPr id="4" name="TextBox 3"/>
+          <p:cNvPr id="5" name="TextBox 4"/>
           <p:cNvSpPr txBox="1"/>
           <p:nvPr/>
         </p:nvSpPr>
         <p:spPr>
           <a:xfrm>
-            <a:off x="914400" y="1828800"/>
-            <a:ext cx="10332720" cy="3474720"/>
+            <a:off x="1188720" y="1188720"/>
+            <a:ext cx="9784080" cy="2926080"/>
           </a:xfrm>
           <a:prstGeom prst="rect">
             <a:avLst/>
@@ -3208,9 +3253,9 @@
               <a:spcAft>
                 <a:spcPts val="800"/>
               </a:spcAft>
-              <a:defRPr sz="1300" b="1">
-                <a:solidFill>
-                  <a:srgbClr val="F2C811"/>
+              <a:defRPr sz="1200" b="1">
+                <a:solidFill>
+                  <a:srgbClr val="0284C7"/>
                 </a:solidFill>
                 <a:latin typeface="Segoe UI"/>
               </a:defRPr>
@@ -3222,11 +3267,11 @@
           <a:p>
             <a:pPr>
               <a:spcAft>
-                <a:spcPts val="1200"/>
+                <a:spcPts val="1000"/>
               </a:spcAft>
               <a:defRPr sz="4000" b="1">
                 <a:solidFill>
-                  <a:srgbClr val="FFFFFF"/>
+                  <a:srgbClr val="0F172A"/>
                 </a:solidFill>
                 <a:latin typeface="Segoe UI"/>
               </a:defRPr>
@@ -3238,11 +3283,11 @@
           <a:p>
             <a:pPr>
               <a:spcAft>
-                <a:spcPts val="2400"/>
+                <a:spcPts val="2000"/>
               </a:spcAft>
               <a:defRPr sz="1600">
                 <a:solidFill>
-                  <a:srgbClr val="CBD5E1"/>
+                  <a:srgbClr val="64748B"/>
                 </a:solidFill>
                 <a:latin typeface="Segoe UI"/>
               </a:defRPr>
@@ -3259,14 +3304,59 @@
       </p:sp>
       <p:sp>
         <p:nvSpPr>
-          <p:cNvPr id="5" name="TextBox 4"/>
+          <p:cNvPr id="6" name="Rounded Rectangle 5"/>
+          <p:cNvSpPr/>
+          <p:nvPr/>
+        </p:nvSpPr>
+        <p:spPr>
+          <a:xfrm>
+            <a:off x="1188720" y="4023360"/>
+            <a:ext cx="2240280" cy="914400"/>
+          </a:xfrm>
+          <a:prstGeom prst="roundRect">
+            <a:avLst/>
+          </a:prstGeom>
+          <a:solidFill>
+            <a:srgbClr val="F1F5F9"/>
+          </a:solidFill>
+          <a:ln w="12700">
+            <a:solidFill>
+              <a:srgbClr val="E2E8F0"/>
+            </a:solidFill>
+          </a:ln>
+        </p:spPr>
+        <p:style>
+          <a:lnRef idx="1">
+            <a:schemeClr val="accent1"/>
+          </a:lnRef>
+          <a:fillRef idx="3">
+            <a:schemeClr val="accent1"/>
+          </a:fillRef>
+          <a:effectRef idx="2">
+            <a:schemeClr val="accent1"/>
+          </a:effectRef>
+          <a:fontRef idx="minor">
+            <a:schemeClr val="lt1"/>
+          </a:fontRef>
+        </p:style>
+        <p:txBody>
+          <a:bodyPr rtlCol="0" anchor="ctr"/>
+          <a:lstStyle/>
+          <a:p>
+            <a:pPr algn="ctr"/>
+          </a:p>
+        </p:txBody>
+      </p:sp>
+      <p:sp>
+        <p:nvSpPr>
+          <p:cNvPr id="7" name="TextBox 6"/>
           <p:cNvSpPr txBox="1"/>
           <p:nvPr/>
         </p:nvSpPr>
         <p:spPr>
           <a:xfrm>
-            <a:off x="914400" y="5120640"/>
-            <a:ext cx="10332720" cy="1097280"/>
+            <a:off x="1280160" y="4114800"/>
+            <a:ext cx="2057400" cy="731520"/>
           </a:xfrm>
           <a:prstGeom prst="rect">
             <a:avLst/>
@@ -3279,21 +3369,21 @@
           </a:bodyPr>
           <a:lstStyle/>
           <a:p>
-            <a:pPr>
-              <a:defRPr sz="1200" b="1">
-                <a:solidFill>
-                  <a:srgbClr val="FFFFFF"/>
-                </a:solidFill>
-                <a:latin typeface="Segoe UI"/>
-              </a:defRPr>
-            </a:pPr>
-            <a:r>
-              <a:t>Autor: Emmanuel Rodríguez Mendoza  |  HR Tech &amp; People Analytics Specialist</a:t>
-            </a:r>
-          </a:p>
-          <a:p>
-            <a:pPr>
-              <a:defRPr sz="1100">
+            <a:pPr algn="ctr">
+              <a:defRPr sz="1600" b="1">
+                <a:solidFill>
+                  <a:srgbClr val="E11D48"/>
+                </a:solidFill>
+                <a:latin typeface="Segoe UI"/>
+              </a:defRPr>
+            </a:pPr>
+            <a:r>
+              <a:t>$6.44M USD</a:t>
+            </a:r>
+          </a:p>
+          <a:p>
+            <a:pPr algn="ctr">
+              <a:defRPr sz="950">
                 <a:solidFill>
                   <a:srgbClr val="64748B"/>
                 </a:solidFill>
@@ -3301,7 +3391,325 @@
               </a:defRPr>
             </a:pPr>
             <a:r>
-              <a:t>Caso de Estudio: MedTech Global Solutions (4,500 Colaboradores  |  5 Países)  •  Release Oficial v1.0.0</a:t>
+              <a:t>Exposición P&amp;L</a:t>
+            </a:r>
+          </a:p>
+        </p:txBody>
+      </p:sp>
+      <p:sp>
+        <p:nvSpPr>
+          <p:cNvPr id="8" name="Rounded Rectangle 7"/>
+          <p:cNvSpPr/>
+          <p:nvPr/>
+        </p:nvSpPr>
+        <p:spPr>
+          <a:xfrm>
+            <a:off x="3657600" y="4023360"/>
+            <a:ext cx="2240280" cy="914400"/>
+          </a:xfrm>
+          <a:prstGeom prst="roundRect">
+            <a:avLst/>
+          </a:prstGeom>
+          <a:solidFill>
+            <a:srgbClr val="F1F5F9"/>
+          </a:solidFill>
+          <a:ln w="12700">
+            <a:solidFill>
+              <a:srgbClr val="E2E8F0"/>
+            </a:solidFill>
+          </a:ln>
+        </p:spPr>
+        <p:style>
+          <a:lnRef idx="1">
+            <a:schemeClr val="accent1"/>
+          </a:lnRef>
+          <a:fillRef idx="3">
+            <a:schemeClr val="accent1"/>
+          </a:fillRef>
+          <a:effectRef idx="2">
+            <a:schemeClr val="accent1"/>
+          </a:effectRef>
+          <a:fontRef idx="minor">
+            <a:schemeClr val="lt1"/>
+          </a:fontRef>
+        </p:style>
+        <p:txBody>
+          <a:bodyPr rtlCol="0" anchor="ctr"/>
+          <a:lstStyle/>
+          <a:p>
+            <a:pPr algn="ctr"/>
+          </a:p>
+        </p:txBody>
+      </p:sp>
+      <p:sp>
+        <p:nvSpPr>
+          <p:cNvPr id="9" name="TextBox 8"/>
+          <p:cNvSpPr txBox="1"/>
+          <p:nvPr/>
+        </p:nvSpPr>
+        <p:spPr>
+          <a:xfrm>
+            <a:off x="3749039" y="4114800"/>
+            <a:ext cx="2057400" cy="731520"/>
+          </a:xfrm>
+          <a:prstGeom prst="rect">
+            <a:avLst/>
+          </a:prstGeom>
+          <a:noFill/>
+        </p:spPr>
+        <p:txBody>
+          <a:bodyPr wrap="square" lIns="0" tIns="0" rIns="0" bIns="0">
+            <a:spAutoFit/>
+          </a:bodyPr>
+          <a:lstStyle/>
+          <a:p>
+            <a:pPr algn="ctr">
+              <a:defRPr sz="1600" b="1">
+                <a:solidFill>
+                  <a:srgbClr val="0284C7"/>
+                </a:solidFill>
+                <a:latin typeface="Segoe UI"/>
+              </a:defRPr>
+            </a:pPr>
+            <a:r>
+              <a:t>4,500</a:t>
+            </a:r>
+          </a:p>
+          <a:p>
+            <a:pPr algn="ctr">
+              <a:defRPr sz="950">
+                <a:solidFill>
+                  <a:srgbClr val="64748B"/>
+                </a:solidFill>
+                <a:latin typeface="Segoe UI"/>
+              </a:defRPr>
+            </a:pPr>
+            <a:r>
+              <a:t>Colaboradores</a:t>
+            </a:r>
+          </a:p>
+        </p:txBody>
+      </p:sp>
+      <p:sp>
+        <p:nvSpPr>
+          <p:cNvPr id="10" name="Rounded Rectangle 9"/>
+          <p:cNvSpPr/>
+          <p:nvPr/>
+        </p:nvSpPr>
+        <p:spPr>
+          <a:xfrm>
+            <a:off x="6126480" y="4023360"/>
+            <a:ext cx="2240280" cy="914400"/>
+          </a:xfrm>
+          <a:prstGeom prst="roundRect">
+            <a:avLst/>
+          </a:prstGeom>
+          <a:solidFill>
+            <a:srgbClr val="F1F5F9"/>
+          </a:solidFill>
+          <a:ln w="12700">
+            <a:solidFill>
+              <a:srgbClr val="E2E8F0"/>
+            </a:solidFill>
+          </a:ln>
+        </p:spPr>
+        <p:style>
+          <a:lnRef idx="1">
+            <a:schemeClr val="accent1"/>
+          </a:lnRef>
+          <a:fillRef idx="3">
+            <a:schemeClr val="accent1"/>
+          </a:fillRef>
+          <a:effectRef idx="2">
+            <a:schemeClr val="accent1"/>
+          </a:effectRef>
+          <a:fontRef idx="minor">
+            <a:schemeClr val="lt1"/>
+          </a:fontRef>
+        </p:style>
+        <p:txBody>
+          <a:bodyPr rtlCol="0" anchor="ctr"/>
+          <a:lstStyle/>
+          <a:p>
+            <a:pPr algn="ctr"/>
+          </a:p>
+        </p:txBody>
+      </p:sp>
+      <p:sp>
+        <p:nvSpPr>
+          <p:cNvPr id="11" name="TextBox 10"/>
+          <p:cNvSpPr txBox="1"/>
+          <p:nvPr/>
+        </p:nvSpPr>
+        <p:spPr>
+          <a:xfrm>
+            <a:off x="6217920" y="4114800"/>
+            <a:ext cx="2057400" cy="731520"/>
+          </a:xfrm>
+          <a:prstGeom prst="rect">
+            <a:avLst/>
+          </a:prstGeom>
+          <a:noFill/>
+        </p:spPr>
+        <p:txBody>
+          <a:bodyPr wrap="square" lIns="0" tIns="0" rIns="0" bIns="0">
+            <a:spAutoFit/>
+          </a:bodyPr>
+          <a:lstStyle/>
+          <a:p>
+            <a:pPr algn="ctr">
+              <a:defRPr sz="1600" b="1">
+                <a:solidFill>
+                  <a:srgbClr val="10B981"/>
+                </a:solidFill>
+                <a:latin typeface="Segoe UI"/>
+              </a:defRPr>
+            </a:pPr>
+            <a:r>
+              <a:t>535%</a:t>
+            </a:r>
+          </a:p>
+          <a:p>
+            <a:pPr algn="ctr">
+              <a:defRPr sz="950">
+                <a:solidFill>
+                  <a:srgbClr val="64748B"/>
+                </a:solidFill>
+                <a:latin typeface="Segoe UI"/>
+              </a:defRPr>
+            </a:pPr>
+            <a:r>
+              <a:t>ROI Proyectado</a:t>
+            </a:r>
+          </a:p>
+        </p:txBody>
+      </p:sp>
+      <p:sp>
+        <p:nvSpPr>
+          <p:cNvPr id="12" name="Rounded Rectangle 11"/>
+          <p:cNvSpPr/>
+          <p:nvPr/>
+        </p:nvSpPr>
+        <p:spPr>
+          <a:xfrm>
+            <a:off x="8595360" y="4023360"/>
+            <a:ext cx="2240280" cy="914400"/>
+          </a:xfrm>
+          <a:prstGeom prst="roundRect">
+            <a:avLst/>
+          </a:prstGeom>
+          <a:solidFill>
+            <a:srgbClr val="F1F5F9"/>
+          </a:solidFill>
+          <a:ln w="12700">
+            <a:solidFill>
+              <a:srgbClr val="E2E8F0"/>
+            </a:solidFill>
+          </a:ln>
+        </p:spPr>
+        <p:style>
+          <a:lnRef idx="1">
+            <a:schemeClr val="accent1"/>
+          </a:lnRef>
+          <a:fillRef idx="3">
+            <a:schemeClr val="accent1"/>
+          </a:fillRef>
+          <a:effectRef idx="2">
+            <a:schemeClr val="accent1"/>
+          </a:effectRef>
+          <a:fontRef idx="minor">
+            <a:schemeClr val="lt1"/>
+          </a:fontRef>
+        </p:style>
+        <p:txBody>
+          <a:bodyPr rtlCol="0" anchor="ctr"/>
+          <a:lstStyle/>
+          <a:p>
+            <a:pPr algn="ctr"/>
+          </a:p>
+        </p:txBody>
+      </p:sp>
+      <p:sp>
+        <p:nvSpPr>
+          <p:cNvPr id="13" name="TextBox 12"/>
+          <p:cNvSpPr txBox="1"/>
+          <p:nvPr/>
+        </p:nvSpPr>
+        <p:spPr>
+          <a:xfrm>
+            <a:off x="8686800" y="4114800"/>
+            <a:ext cx="2057400" cy="731520"/>
+          </a:xfrm>
+          <a:prstGeom prst="rect">
+            <a:avLst/>
+          </a:prstGeom>
+          <a:noFill/>
+        </p:spPr>
+        <p:txBody>
+          <a:bodyPr wrap="square" lIns="0" tIns="0" rIns="0" bIns="0">
+            <a:spAutoFit/>
+          </a:bodyPr>
+          <a:lstStyle/>
+          <a:p>
+            <a:pPr algn="ctr">
+              <a:defRPr sz="1600" b="1">
+                <a:solidFill>
+                  <a:srgbClr val="0F172A"/>
+                </a:solidFill>
+                <a:latin typeface="Segoe UI"/>
+              </a:defRPr>
+            </a:pPr>
+            <a:r>
+              <a:t>2.8 Meses</a:t>
+            </a:r>
+          </a:p>
+          <a:p>
+            <a:pPr algn="ctr">
+              <a:defRPr sz="950">
+                <a:solidFill>
+                  <a:srgbClr val="64748B"/>
+                </a:solidFill>
+                <a:latin typeface="Segoe UI"/>
+              </a:defRPr>
+            </a:pPr>
+            <a:r>
+              <a:t>Payback</a:t>
+            </a:r>
+          </a:p>
+        </p:txBody>
+      </p:sp>
+      <p:sp>
+        <p:nvSpPr>
+          <p:cNvPr id="14" name="TextBox 13"/>
+          <p:cNvSpPr txBox="1"/>
+          <p:nvPr/>
+        </p:nvSpPr>
+        <p:spPr>
+          <a:xfrm>
+            <a:off x="1188720" y="5303520"/>
+            <a:ext cx="9784080" cy="548640"/>
+          </a:xfrm>
+          <a:prstGeom prst="rect">
+            <a:avLst/>
+          </a:prstGeom>
+          <a:noFill/>
+        </p:spPr>
+        <p:txBody>
+          <a:bodyPr wrap="square" lIns="0" tIns="0" rIns="0" bIns="0">
+            <a:spAutoFit/>
+          </a:bodyPr>
+          <a:lstStyle/>
+          <a:p>
+            <a:pPr>
+              <a:defRPr sz="1050" b="1">
+                <a:solidFill>
+                  <a:srgbClr val="64748B"/>
+                </a:solidFill>
+                <a:latin typeface="Segoe UI"/>
+              </a:defRPr>
+            </a:pPr>
+            <a:r>
+              <a:t>Autor: Emmanuel Rodríguez Mendoza  |  HR Tech &amp; People Analytics Specialist   •   Caso: MedTech Global Solutions (v1.0.0)</a:t>
             </a:r>
           </a:p>
         </p:txBody>
@@ -3405,7 +3813,7 @@
             <a:pPr>
               <a:defRPr sz="2200" b="1">
                 <a:solidFill>
-                  <a:srgbClr val="1E293B"/>
+                  <a:srgbClr val="0F172A"/>
                 </a:solidFill>
                 <a:latin typeface="Segoe UI"/>
               </a:defRPr>
@@ -3505,7 +3913,7 @@
               </a:spcAft>
               <a:defRPr sz="1200" b="1">
                 <a:solidFill>
-                  <a:srgbClr val="1E293B"/>
+                  <a:srgbClr val="0F172A"/>
                 </a:solidFill>
                 <a:latin typeface="Segoe UI"/>
               </a:defRPr>
@@ -3618,7 +4026,7 @@
               </a:spcAft>
               <a:defRPr sz="1200" b="1">
                 <a:solidFill>
-                  <a:srgbClr val="1E293B"/>
+                  <a:srgbClr val="0F172A"/>
                 </a:solidFill>
                 <a:latin typeface="Segoe UI"/>
               </a:defRPr>
@@ -3731,7 +4139,7 @@
               </a:spcAft>
               <a:defRPr sz="1200" b="1">
                 <a:solidFill>
-                  <a:srgbClr val="1E293B"/>
+                  <a:srgbClr val="0F172A"/>
                 </a:solidFill>
                 <a:latin typeface="Segoe UI"/>
               </a:defRPr>
@@ -3828,7 +4236,7 @@
               </a:spcAft>
               <a:defRPr sz="2600" b="1">
                 <a:solidFill>
-                  <a:srgbClr val="1E293B"/>
+                  <a:srgbClr val="0F172A"/>
                 </a:solidFill>
                 <a:latin typeface="Segoe UI"/>
               </a:defRPr>
@@ -3844,7 +4252,7 @@
               </a:spcAft>
               <a:defRPr sz="1200" b="1">
                 <a:solidFill>
-                  <a:srgbClr val="1E293B"/>
+                  <a:srgbClr val="0F172A"/>
                 </a:solidFill>
                 <a:latin typeface="Segoe UI"/>
               </a:defRPr>
@@ -3959,7 +4367,7 @@
             <a:r>
               <a:rPr sz="1100" b="1">
                 <a:solidFill>
-                  <a:srgbClr val="1E293B"/>
+                  <a:srgbClr val="0F172A"/>
                 </a:solidFill>
                 <a:latin typeface="Segoe UI"/>
               </a:rPr>
@@ -3984,7 +4392,7 @@
             <a:r>
               <a:rPr sz="1100" b="1">
                 <a:solidFill>
-                  <a:srgbClr val="1E293B"/>
+                  <a:srgbClr val="0F172A"/>
                 </a:solidFill>
                 <a:latin typeface="Segoe UI"/>
               </a:rPr>
@@ -4009,7 +4417,7 @@
             <a:r>
               <a:rPr sz="1100" b="1">
                 <a:solidFill>
-                  <a:srgbClr val="1E293B"/>
+                  <a:srgbClr val="0F172A"/>
                 </a:solidFill>
                 <a:latin typeface="Segoe UI"/>
               </a:rPr>
@@ -4034,7 +4442,7 @@
             <a:r>
               <a:rPr sz="1100" b="1">
                 <a:solidFill>
-                  <a:srgbClr val="1E293B"/>
+                  <a:srgbClr val="0F172A"/>
                 </a:solidFill>
                 <a:latin typeface="Segoe UI"/>
               </a:rPr>
@@ -4151,7 +4559,7 @@
             <a:pPr>
               <a:defRPr sz="2200" b="1">
                 <a:solidFill>
-                  <a:srgbClr val="1E293B"/>
+                  <a:srgbClr val="0F172A"/>
                 </a:solidFill>
                 <a:latin typeface="Segoe UI"/>
               </a:defRPr>
@@ -4253,7 +4661,7 @@
             <a:r>
               <a:rPr sz="1100" b="1">
                 <a:solidFill>
-                  <a:srgbClr val="1E293B"/>
+                  <a:srgbClr val="0F172A"/>
                 </a:solidFill>
                 <a:latin typeface="Segoe UI"/>
               </a:rPr>
@@ -4278,7 +4686,7 @@
             <a:r>
               <a:rPr sz="1100" b="1">
                 <a:solidFill>
-                  <a:srgbClr val="1E293B"/>
+                  <a:srgbClr val="0F172A"/>
                 </a:solidFill>
                 <a:latin typeface="Segoe UI"/>
               </a:rPr>
@@ -4303,7 +4711,7 @@
             <a:r>
               <a:rPr sz="1100" b="1">
                 <a:solidFill>
-                  <a:srgbClr val="1E293B"/>
+                  <a:srgbClr val="0F172A"/>
                 </a:solidFill>
                 <a:latin typeface="Segoe UI"/>
               </a:rPr>
@@ -4328,7 +4736,7 @@
             <a:r>
               <a:rPr sz="1100" b="1">
                 <a:solidFill>
-                  <a:srgbClr val="1E293B"/>
+                  <a:srgbClr val="0F172A"/>
                 </a:solidFill>
                 <a:latin typeface="Segoe UI"/>
               </a:rPr>
@@ -4437,7 +4845,7 @@
             <a:r>
               <a:rPr sz="1100" b="1">
                 <a:solidFill>
-                  <a:srgbClr val="1E293B"/>
+                  <a:srgbClr val="0F172A"/>
                 </a:solidFill>
                 <a:latin typeface="Segoe UI"/>
               </a:rPr>
@@ -4462,7 +4870,7 @@
             <a:r>
               <a:rPr sz="1100" b="1">
                 <a:solidFill>
-                  <a:srgbClr val="1E293B"/>
+                  <a:srgbClr val="0F172A"/>
                 </a:solidFill>
                 <a:latin typeface="Segoe UI"/>
               </a:rPr>
@@ -4487,7 +4895,7 @@
             <a:r>
               <a:rPr sz="1100" b="1">
                 <a:solidFill>
-                  <a:srgbClr val="1E293B"/>
+                  <a:srgbClr val="0F172A"/>
                 </a:solidFill>
                 <a:latin typeface="Segoe UI"/>
               </a:rPr>
@@ -4512,7 +4920,7 @@
             <a:r>
               <a:rPr sz="1100" b="1">
                 <a:solidFill>
-                  <a:srgbClr val="1E293B"/>
+                  <a:srgbClr val="0F172A"/>
                 </a:solidFill>
                 <a:latin typeface="Segoe UI"/>
               </a:rPr>
@@ -4629,7 +5037,7 @@
             <a:pPr>
               <a:defRPr sz="2200" b="1">
                 <a:solidFill>
-                  <a:srgbClr val="1E293B"/>
+                  <a:srgbClr val="0F172A"/>
                 </a:solidFill>
                 <a:latin typeface="Segoe UI"/>
               </a:defRPr>
@@ -4731,7 +5139,7 @@
             <a:r>
               <a:rPr sz="1050" b="1">
                 <a:solidFill>
-                  <a:srgbClr val="1E293B"/>
+                  <a:srgbClr val="0F172A"/>
                 </a:solidFill>
                 <a:latin typeface="Segoe UI"/>
               </a:rPr>
@@ -4756,7 +5164,7 @@
             <a:r>
               <a:rPr sz="1050" b="1">
                 <a:solidFill>
-                  <a:srgbClr val="1E293B"/>
+                  <a:srgbClr val="0F172A"/>
                 </a:solidFill>
                 <a:latin typeface="Segoe UI"/>
               </a:rPr>
@@ -4781,7 +5189,7 @@
             <a:r>
               <a:rPr sz="1050" b="1">
                 <a:solidFill>
-                  <a:srgbClr val="1E293B"/>
+                  <a:srgbClr val="0F172A"/>
                 </a:solidFill>
                 <a:latin typeface="Segoe UI"/>
               </a:rPr>
@@ -4806,7 +5214,7 @@
             <a:r>
               <a:rPr sz="1050" b="1">
                 <a:solidFill>
-                  <a:srgbClr val="1E293B"/>
+                  <a:srgbClr val="0F172A"/>
                 </a:solidFill>
                 <a:latin typeface="Segoe UI"/>
               </a:rPr>
@@ -4915,7 +5323,7 @@
             <a:r>
               <a:rPr sz="1050" b="1">
                 <a:solidFill>
-                  <a:srgbClr val="1E293B"/>
+                  <a:srgbClr val="0F172A"/>
                 </a:solidFill>
                 <a:latin typeface="Segoe UI"/>
               </a:rPr>
@@ -4940,7 +5348,7 @@
             <a:r>
               <a:rPr sz="1050" b="1">
                 <a:solidFill>
-                  <a:srgbClr val="1E293B"/>
+                  <a:srgbClr val="0F172A"/>
                 </a:solidFill>
                 <a:latin typeface="Segoe UI"/>
               </a:rPr>
@@ -4965,7 +5373,7 @@
             <a:r>
               <a:rPr sz="1050" b="1">
                 <a:solidFill>
-                  <a:srgbClr val="1E293B"/>
+                  <a:srgbClr val="0F172A"/>
                 </a:solidFill>
                 <a:latin typeface="Segoe UI"/>
               </a:rPr>
@@ -4990,7 +5398,7 @@
             <a:r>
               <a:rPr sz="1050" b="1">
                 <a:solidFill>
-                  <a:srgbClr val="1E293B"/>
+                  <a:srgbClr val="0F172A"/>
                 </a:solidFill>
                 <a:latin typeface="Segoe UI"/>
               </a:rPr>
@@ -5255,7 +5663,7 @@
             <a:pPr>
               <a:defRPr sz="2200" b="1">
                 <a:solidFill>
-                  <a:srgbClr val="1E293B"/>
+                  <a:srgbClr val="0F172A"/>
                 </a:solidFill>
                 <a:latin typeface="Segoe UI"/>
               </a:defRPr>
@@ -5381,7 +5789,7 @@
             <a:r>
               <a:rPr sz="1050" b="1">
                 <a:solidFill>
-                  <a:srgbClr val="1E293B"/>
+                  <a:srgbClr val="0F172A"/>
                 </a:solidFill>
                 <a:latin typeface="Segoe UI"/>
               </a:rPr>
@@ -5406,7 +5814,7 @@
             <a:r>
               <a:rPr sz="1050" b="1">
                 <a:solidFill>
-                  <a:srgbClr val="1E293B"/>
+                  <a:srgbClr val="0F172A"/>
                 </a:solidFill>
                 <a:latin typeface="Segoe UI"/>
               </a:rPr>
@@ -5431,7 +5839,7 @@
             <a:r>
               <a:rPr sz="1050" b="1">
                 <a:solidFill>
-                  <a:srgbClr val="1E293B"/>
+                  <a:srgbClr val="0F172A"/>
                 </a:solidFill>
                 <a:latin typeface="Segoe UI"/>
               </a:rPr>
@@ -5456,7 +5864,7 @@
             <a:r>
               <a:rPr sz="1050" b="1">
                 <a:solidFill>
-                  <a:srgbClr val="1E293B"/>
+                  <a:srgbClr val="0F172A"/>
                 </a:solidFill>
                 <a:latin typeface="Segoe UI"/>
               </a:rPr>
@@ -5573,7 +5981,7 @@
             <a:pPr>
               <a:defRPr sz="2200" b="1">
                 <a:solidFill>
-                  <a:srgbClr val="1E293B"/>
+                  <a:srgbClr val="0F172A"/>
                 </a:solidFill>
                 <a:latin typeface="Segoe UI"/>
               </a:defRPr>
@@ -5699,7 +6107,7 @@
             <a:r>
               <a:rPr sz="1050" b="1">
                 <a:solidFill>
-                  <a:srgbClr val="1E293B"/>
+                  <a:srgbClr val="0F172A"/>
                 </a:solidFill>
                 <a:latin typeface="Segoe UI"/>
               </a:rPr>
@@ -5724,7 +6132,7 @@
             <a:r>
               <a:rPr sz="1050" b="1">
                 <a:solidFill>
-                  <a:srgbClr val="1E293B"/>
+                  <a:srgbClr val="0F172A"/>
                 </a:solidFill>
                 <a:latin typeface="Segoe UI"/>
               </a:rPr>
@@ -5749,7 +6157,7 @@
             <a:r>
               <a:rPr sz="1050" b="1">
                 <a:solidFill>
-                  <a:srgbClr val="1E293B"/>
+                  <a:srgbClr val="0F172A"/>
                 </a:solidFill>
                 <a:latin typeface="Segoe UI"/>
               </a:rPr>
@@ -5774,7 +6182,7 @@
             <a:r>
               <a:rPr sz="1050" b="1">
                 <a:solidFill>
-                  <a:srgbClr val="1E293B"/>
+                  <a:srgbClr val="0F172A"/>
                 </a:solidFill>
                 <a:latin typeface="Segoe UI"/>
               </a:rPr>
@@ -5891,7 +6299,7 @@
             <a:pPr>
               <a:defRPr sz="2200" b="1">
                 <a:solidFill>
-                  <a:srgbClr val="1E293B"/>
+                  <a:srgbClr val="0F172A"/>
                 </a:solidFill>
                 <a:latin typeface="Segoe UI"/>
               </a:defRPr>
@@ -6017,7 +6425,7 @@
             <a:r>
               <a:rPr sz="1050" b="1">
                 <a:solidFill>
-                  <a:srgbClr val="1E293B"/>
+                  <a:srgbClr val="0F172A"/>
                 </a:solidFill>
                 <a:latin typeface="Segoe UI"/>
               </a:rPr>
@@ -6042,7 +6450,7 @@
             <a:r>
               <a:rPr sz="1050" b="1">
                 <a:solidFill>
-                  <a:srgbClr val="1E293B"/>
+                  <a:srgbClr val="0F172A"/>
                 </a:solidFill>
                 <a:latin typeface="Segoe UI"/>
               </a:rPr>
@@ -6067,7 +6475,7 @@
             <a:r>
               <a:rPr sz="1050" b="1">
                 <a:solidFill>
-                  <a:srgbClr val="1E293B"/>
+                  <a:srgbClr val="0F172A"/>
                 </a:solidFill>
                 <a:latin typeface="Segoe UI"/>
               </a:rPr>
@@ -6092,7 +6500,7 @@
             <a:r>
               <a:rPr sz="1050" b="1">
                 <a:solidFill>
-                  <a:srgbClr val="1E293B"/>
+                  <a:srgbClr val="0F172A"/>
                 </a:solidFill>
                 <a:latin typeface="Segoe UI"/>
               </a:rPr>
@@ -6209,7 +6617,7 @@
             <a:pPr>
               <a:defRPr sz="2200" b="1">
                 <a:solidFill>
-                  <a:srgbClr val="1E293B"/>
+                  <a:srgbClr val="0F172A"/>
                 </a:solidFill>
                 <a:latin typeface="Segoe UI"/>
               </a:defRPr>
@@ -6309,7 +6717,7 @@
               </a:spcAft>
               <a:defRPr sz="1100">
                 <a:solidFill>
-                  <a:srgbClr val="1E293B"/>
+                  <a:srgbClr val="0F172A"/>
                 </a:solidFill>
                 <a:latin typeface="Segoe UI"/>
               </a:defRPr>
@@ -6438,7 +6846,7 @@
               </a:spcAft>
               <a:defRPr sz="1100">
                 <a:solidFill>
-                  <a:srgbClr val="1E293B"/>
+                  <a:srgbClr val="0F172A"/>
                 </a:solidFill>
                 <a:latin typeface="Segoe UI"/>
               </a:defRPr>
@@ -6567,7 +6975,7 @@
               </a:spcAft>
               <a:defRPr sz="1100">
                 <a:solidFill>
-                  <a:srgbClr val="1E293B"/>
+                  <a:srgbClr val="0F172A"/>
                 </a:solidFill>
                 <a:latin typeface="Segoe UI"/>
               </a:defRPr>
@@ -6622,10 +7030,12 @@
             <a:avLst/>
           </a:prstGeom>
           <a:solidFill>
-            <a:srgbClr val="0F172A"/>
+            <a:srgbClr val="F1F5F9"/>
           </a:solidFill>
-          <a:ln>
-            <a:noFill/>
+          <a:ln w="12700">
+            <a:solidFill>
+              <a:srgbClr val="E2E8F0"/>
+            </a:solidFill>
           </a:ln>
         </p:spPr>
         <p:style>
@@ -6678,7 +7088,7 @@
               </a:spcAft>
               <a:defRPr sz="1100" b="1">
                 <a:solidFill>
-                  <a:srgbClr val="F2C811"/>
+                  <a:srgbClr val="0284C7"/>
                 </a:solidFill>
                 <a:latin typeface="Segoe UI"/>
               </a:defRPr>
@@ -6691,7 +7101,7 @@
             <a:pPr>
               <a:defRPr sz="1200" b="1">
                 <a:solidFill>
-                  <a:srgbClr val="FFFFFF"/>
+                  <a:srgbClr val="0F172A"/>
                 </a:solidFill>
                 <a:latin typeface="Segoe UI"/>
               </a:defRPr>
@@ -6739,7 +7149,7 @@
             <a:avLst/>
           </a:prstGeom>
           <a:solidFill>
-            <a:srgbClr val="0F172A"/>
+            <a:srgbClr val="F8FAFC"/>
           </a:solidFill>
           <a:ln>
             <a:noFill/>
@@ -6775,8 +7185,8 @@
         </p:nvSpPr>
         <p:spPr>
           <a:xfrm>
-            <a:off x="914400" y="1097280"/>
-            <a:ext cx="10332720" cy="4572000"/>
+            <a:off x="731520" y="365760"/>
+            <a:ext cx="10698480" cy="1005840"/>
           </a:xfrm>
           <a:prstGeom prst="rect">
             <a:avLst/>
@@ -6790,42 +7200,104 @@
           <a:lstStyle/>
           <a:p>
             <a:pPr>
-              <a:spcAft>
-                <a:spcPts val="800"/>
-              </a:spcAft>
-              <a:defRPr sz="1200" b="1">
-                <a:solidFill>
-                  <a:srgbClr val="F2C811"/>
-                </a:solidFill>
-                <a:latin typeface="Segoe UI"/>
-              </a:defRPr>
-            </a:pPr>
-            <a:r>
-              <a:t>PERFIL PROFESIONAL &amp; AUTOR DEL PROYECTO</a:t>
-            </a:r>
-          </a:p>
+              <a:defRPr sz="1000" b="1">
+                <a:solidFill>
+                  <a:srgbClr val="0284C7"/>
+                </a:solidFill>
+                <a:latin typeface="Segoe UI"/>
+              </a:defRPr>
+            </a:pPr>
+            <a:r>
+              <a:t>WORKFORCE DYNAMIC LENS | AUTOR DEL PROYECTO</a:t>
+            </a:r>
+          </a:p>
+          <a:p>
+            <a:pPr>
+              <a:defRPr sz="2200" b="1">
+                <a:solidFill>
+                  <a:srgbClr val="0F172A"/>
+                </a:solidFill>
+                <a:latin typeface="Segoe UI"/>
+              </a:defRPr>
+            </a:pPr>
+            <a:r>
+              <a:t>Perfil Profesional &amp; Datos de Contacto</a:t>
+            </a:r>
+          </a:p>
+        </p:txBody>
+      </p:sp>
+      <p:sp>
+        <p:nvSpPr>
+          <p:cNvPr id="4" name="Rounded Rectangle 3"/>
+          <p:cNvSpPr/>
+          <p:nvPr/>
+        </p:nvSpPr>
+        <p:spPr>
+          <a:xfrm>
+            <a:off x="731520" y="1463040"/>
+            <a:ext cx="10725912" cy="4846320"/>
+          </a:xfrm>
+          <a:prstGeom prst="roundRect">
+            <a:avLst/>
+          </a:prstGeom>
+          <a:solidFill>
+            <a:srgbClr val="FFFFFF"/>
+          </a:solidFill>
+          <a:ln w="12700">
+            <a:solidFill>
+              <a:srgbClr val="E2E8F0"/>
+            </a:solidFill>
+          </a:ln>
+        </p:spPr>
+        <p:style>
+          <a:lnRef idx="1">
+            <a:schemeClr val="accent1"/>
+          </a:lnRef>
+          <a:fillRef idx="3">
+            <a:schemeClr val="accent1"/>
+          </a:fillRef>
+          <a:effectRef idx="2">
+            <a:schemeClr val="accent1"/>
+          </a:effectRef>
+          <a:fontRef idx="minor">
+            <a:schemeClr val="lt1"/>
+          </a:fontRef>
+        </p:style>
+        <p:txBody>
+          <a:bodyPr rtlCol="0" anchor="ctr"/>
+          <a:lstStyle/>
+          <a:p>
+            <a:pPr algn="ctr"/>
+          </a:p>
+        </p:txBody>
+      </p:sp>
+      <p:sp>
+        <p:nvSpPr>
+          <p:cNvPr id="5" name="TextBox 4"/>
+          <p:cNvSpPr txBox="1"/>
+          <p:nvPr/>
+        </p:nvSpPr>
+        <p:spPr>
+          <a:xfrm>
+            <a:off x="1097280" y="1737360"/>
+            <a:ext cx="9966960" cy="4297680"/>
+          </a:xfrm>
+          <a:prstGeom prst="rect">
+            <a:avLst/>
+          </a:prstGeom>
+          <a:noFill/>
+        </p:spPr>
+        <p:txBody>
+          <a:bodyPr wrap="square" lIns="0" tIns="0" rIns="0" bIns="0">
+            <a:spAutoFit/>
+          </a:bodyPr>
+          <a:lstStyle/>
           <a:p>
             <a:pPr>
               <a:spcAft>
                 <a:spcPts val="400"/>
               </a:spcAft>
-              <a:defRPr sz="3200" b="1">
-                <a:solidFill>
-                  <a:srgbClr val="FFFFFF"/>
-                </a:solidFill>
-                <a:latin typeface="Segoe UI"/>
-              </a:defRPr>
-            </a:pPr>
-            <a:r>
-              <a:t>Emmanuel Rodríguez Mendoza</a:t>
-            </a:r>
-          </a:p>
-          <a:p>
-            <a:pPr>
-              <a:spcAft>
-                <a:spcPts val="2000"/>
-              </a:spcAft>
-              <a:defRPr sz="1500">
+              <a:defRPr sz="1100" b="1">
                 <a:solidFill>
                   <a:srgbClr val="0284C7"/>
                 </a:solidFill>
@@ -6833,31 +7305,7 @@
               </a:defRPr>
             </a:pPr>
             <a:r>
-              <a:t>HR Tech | People Analytics | BI &amp; SQL Analytics | Software Development</a:t>
-            </a:r>
-            <a:br/>
-            <a:r>
-              <a:t>Transforming Talent Management with Data, SQL &amp; Evidence-Based Decision Making</a:t>
-            </a:r>
-          </a:p>
-          <a:p>
-            <a:pPr>
-              <a:spcAft>
-                <a:spcPts val="2400"/>
-              </a:spcAft>
-              <a:defRPr sz="1200">
-                <a:solidFill>
-                  <a:srgbClr val="CBD5E1"/>
-                </a:solidFill>
-                <a:latin typeface="Segoe UI"/>
-              </a:defRPr>
-            </a:pPr>
-            <a:r>
-              <a:t>Psicólogo Organizacional y Magíster (c) en Dirección de Recursos Humanos (UDIMA, España) con formación en Análisis y Desarrollo de Software.</a:t>
-            </a:r>
-            <a:br/>
-            <a:r>
-              <a:t>Especializado en modelado relacional dimensional (Kimball Star Schema en PostgreSQL), análisis cuantitativo en SQL y visualización ejecutiva con Power BI (DAX).</a:t>
+              <a:t>ESPECIALIDAD PROFESIONAL</a:t>
             </a:r>
           </a:p>
           <a:p>
@@ -6865,24 +7313,55 @@
               <a:spcAft>
                 <a:spcPts val="400"/>
               </a:spcAft>
-            </a:pPr>
-            <a:r>
-              <a:rPr sz="1100" b="1">
-                <a:solidFill>
-                  <a:srgbClr val="F2C811"/>
-                </a:solidFill>
-                <a:latin typeface="Segoe UI"/>
-              </a:rPr>
-              <a:t>LinkedIn:  </a:t>
-            </a:r>
-            <a:r>
-              <a:rPr sz="1100">
-                <a:solidFill>
-                  <a:srgbClr val="FFFFFF"/>
-                </a:solidFill>
-                <a:latin typeface="Segoe UI"/>
-              </a:rPr>
-              <a:t>https://www.linkedin.com/in/emmanuel-rodríguez-mendoza-aa638a220/</a:t>
+              <a:defRPr sz="3000" b="1">
+                <a:solidFill>
+                  <a:srgbClr val="0F172A"/>
+                </a:solidFill>
+                <a:latin typeface="Segoe UI"/>
+              </a:defRPr>
+            </a:pPr>
+            <a:r>
+              <a:t>Emmanuel Rodríguez Mendoza</a:t>
+            </a:r>
+          </a:p>
+          <a:p>
+            <a:pPr>
+              <a:spcAft>
+                <a:spcPts val="1400"/>
+              </a:spcAft>
+              <a:defRPr sz="1400" b="1">
+                <a:solidFill>
+                  <a:srgbClr val="0284C7"/>
+                </a:solidFill>
+                <a:latin typeface="Segoe UI"/>
+              </a:defRPr>
+            </a:pPr>
+            <a:r>
+              <a:t>HR Tech | People Analytics | BI &amp; SQL Analytics | Software Development</a:t>
+            </a:r>
+            <a:br/>
+            <a:r>
+              <a:t>Transforming Talent Management with Data, SQL &amp; Evidence-Based Decision Making</a:t>
+            </a:r>
+          </a:p>
+          <a:p>
+            <a:pPr>
+              <a:spcAft>
+                <a:spcPts val="1800"/>
+              </a:spcAft>
+              <a:defRPr sz="1150">
+                <a:solidFill>
+                  <a:srgbClr val="1E293B"/>
+                </a:solidFill>
+                <a:latin typeface="Segoe UI"/>
+              </a:defRPr>
+            </a:pPr>
+            <a:r>
+              <a:t>Psicólogo Organizacional y Magíster (c) en Dirección de Recursos Humanos (UDIMA, España) con formación en Análisis y Desarrollo de Software.</a:t>
+            </a:r>
+            <a:br/>
+            <a:r>
+              <a:t>Especializado en modelado relacional dimensional (Kimball Star Schema en PostgreSQL), análisis cuantitativo en SQL y visualización ejecutiva con Power BI (DAX).</a:t>
             </a:r>
           </a:p>
           <a:p>
@@ -6894,20 +7373,20 @@
             <a:r>
               <a:rPr sz="1100" b="1">
                 <a:solidFill>
-                  <a:srgbClr val="F2C811"/>
+                  <a:srgbClr val="0284C7"/>
                 </a:solidFill>
                 <a:latin typeface="Segoe UI"/>
               </a:rPr>
-              <a:t>GitHub:    </a:t>
+              <a:t>• LinkedIn: </a:t>
             </a:r>
             <a:r>
               <a:rPr sz="1100">
                 <a:solidFill>
-                  <a:srgbClr val="FFFFFF"/>
+                  <a:srgbClr val="0F172A"/>
                 </a:solidFill>
                 <a:latin typeface="Segoe UI"/>
               </a:rPr>
-              <a:t>https://github.com/rodriguezmendozaemmanuel5</a:t>
+              <a:t>https://www.linkedin.com/in/emmanuel-rodríguez-mendoza-aa638a220/</a:t>
             </a:r>
           </a:p>
           <a:p>
@@ -6919,20 +7398,20 @@
             <a:r>
               <a:rPr sz="1100" b="1">
                 <a:solidFill>
-                  <a:srgbClr val="F2C811"/>
+                  <a:srgbClr val="0284C7"/>
                 </a:solidFill>
                 <a:latin typeface="Segoe UI"/>
               </a:rPr>
-              <a:t>Email:     </a:t>
+              <a:t>• GitHub: </a:t>
             </a:r>
             <a:r>
               <a:rPr sz="1100">
                 <a:solidFill>
-                  <a:srgbClr val="FFFFFF"/>
+                  <a:srgbClr val="0F172A"/>
                 </a:solidFill>
                 <a:latin typeface="Segoe UI"/>
               </a:rPr>
-              <a:t>mendozarm2308@gmail.com</a:t>
+              <a:t>https://github.com/rodriguezmendozaemmanuel5</a:t>
             </a:r>
           </a:p>
           <a:p>
@@ -6944,16 +7423,41 @@
             <a:r>
               <a:rPr sz="1100" b="1">
                 <a:solidFill>
-                  <a:srgbClr val="F2C811"/>
+                  <a:srgbClr val="0284C7"/>
                 </a:solidFill>
                 <a:latin typeface="Segoe UI"/>
               </a:rPr>
-              <a:t>Proyecto:  </a:t>
+              <a:t>• Email: </a:t>
             </a:r>
             <a:r>
               <a:rPr sz="1100">
                 <a:solidFill>
-                  <a:srgbClr val="FFFFFF"/>
+                  <a:srgbClr val="0F172A"/>
+                </a:solidFill>
+                <a:latin typeface="Segoe UI"/>
+              </a:rPr>
+              <a:t>mendozarm2308@gmail.com</a:t>
+            </a:r>
+          </a:p>
+          <a:p>
+            <a:pPr>
+              <a:spcAft>
+                <a:spcPts val="400"/>
+              </a:spcAft>
+            </a:pPr>
+            <a:r>
+              <a:rPr sz="1100" b="1">
+                <a:solidFill>
+                  <a:srgbClr val="0284C7"/>
+                </a:solidFill>
+                <a:latin typeface="Segoe UI"/>
+              </a:rPr>
+              <a:t>• Repositorio: </a:t>
+            </a:r>
+            <a:r>
+              <a:rPr sz="1100">
+                <a:solidFill>
+                  <a:srgbClr val="0F172A"/>
                 </a:solidFill>
                 <a:latin typeface="Segoe UI"/>
               </a:rPr>

</xml_diff>

<commit_message>
style(presentations): apply clean boardroom consulting standard with pure white canvas and oxford navy
</commit_message>
<xml_diff>
--- a/presentations/Executive_Presentation.pptx
+++ b/presentations/Executive_Presentation.pptx
@@ -3111,7 +3111,7 @@
             <a:avLst/>
           </a:prstGeom>
           <a:solidFill>
-            <a:srgbClr val="F8FAFC"/>
+            <a:srgbClr val="FFFFFF"/>
           </a:solidFill>
           <a:ln>
             <a:noFill/>
@@ -3141,20 +3141,135 @@
       </p:sp>
       <p:sp>
         <p:nvSpPr>
-          <p:cNvPr id="3" name="Rounded Rectangle 2"/>
+          <p:cNvPr id="3" name="Rectangle 2"/>
           <p:cNvSpPr/>
           <p:nvPr/>
         </p:nvSpPr>
         <p:spPr>
           <a:xfrm>
-            <a:off x="731520" y="731520"/>
-            <a:ext cx="10725912" cy="5394960"/>
-          </a:xfrm>
-          <a:prstGeom prst="roundRect">
+            <a:off x="731520" y="1097280"/>
+            <a:ext cx="109728" cy="4663440"/>
+          </a:xfrm>
+          <a:prstGeom prst="rect">
             <a:avLst/>
           </a:prstGeom>
           <a:solidFill>
-            <a:srgbClr val="FFFFFF"/>
+            <a:srgbClr val="1D4ED8"/>
+          </a:solidFill>
+          <a:ln>
+            <a:noFill/>
+          </a:ln>
+        </p:spPr>
+        <p:style>
+          <a:lnRef idx="1">
+            <a:schemeClr val="accent1"/>
+          </a:lnRef>
+          <a:fillRef idx="3">
+            <a:schemeClr val="accent1"/>
+          </a:fillRef>
+          <a:effectRef idx="2">
+            <a:schemeClr val="accent1"/>
+          </a:effectRef>
+          <a:fontRef idx="minor">
+            <a:schemeClr val="lt1"/>
+          </a:fontRef>
+        </p:style>
+        <p:txBody>
+          <a:bodyPr rtlCol="0" anchor="ctr"/>
+          <a:lstStyle/>
+          <a:p>
+            <a:pPr algn="ctr"/>
+          </a:p>
+        </p:txBody>
+      </p:sp>
+      <p:sp>
+        <p:nvSpPr>
+          <p:cNvPr id="4" name="TextBox 3"/>
+          <p:cNvSpPr txBox="1"/>
+          <p:nvPr/>
+        </p:nvSpPr>
+        <p:spPr>
+          <a:xfrm>
+            <a:off x="1097280" y="1097280"/>
+            <a:ext cx="10362895" cy="2743200"/>
+          </a:xfrm>
+          <a:prstGeom prst="rect">
+            <a:avLst/>
+          </a:prstGeom>
+          <a:noFill/>
+        </p:spPr>
+        <p:txBody>
+          <a:bodyPr wrap="square" lIns="0" tIns="0" rIns="0" bIns="0">
+            <a:spAutoFit/>
+          </a:bodyPr>
+          <a:lstStyle/>
+          <a:p>
+            <a:pPr>
+              <a:spcAft>
+                <a:spcPts val="800"/>
+              </a:spcAft>
+              <a:defRPr sz="1100" b="1">
+                <a:solidFill>
+                  <a:srgbClr val="1D4ED8"/>
+                </a:solidFill>
+                <a:latin typeface="Segoe UI"/>
+              </a:defRPr>
+            </a:pPr>
+            <a:r>
+              <a:t>INFORME EJECUTIVO DE CONSULTORÍA &amp; PEOPLE ANALYTICS</a:t>
+            </a:r>
+          </a:p>
+          <a:p>
+            <a:pPr>
+              <a:spcAft>
+                <a:spcPts val="1000"/>
+              </a:spcAft>
+              <a:defRPr sz="4000" b="1">
+                <a:solidFill>
+                  <a:srgbClr val="0A2540"/>
+                </a:solidFill>
+                <a:latin typeface="Segoe UI"/>
+              </a:defRPr>
+            </a:pPr>
+            <a:r>
+              <a:t>Workforce Dynamic Lens</a:t>
+            </a:r>
+          </a:p>
+          <a:p>
+            <a:pPr>
+              <a:defRPr sz="1500">
+                <a:solidFill>
+                  <a:srgbClr val="64748B"/>
+                </a:solidFill>
+                <a:latin typeface="Segoe UI"/>
+              </a:defRPr>
+            </a:pPr>
+            <a:r>
+              <a:t>Conectando la Gestión del Capital Humano con el Estado de Resultados (P&amp;L)</a:t>
+            </a:r>
+            <a:br/>
+            <a:r>
+              <a:t>Diagnóstico de Rotación Crítica en I+D, Ausentismo y Mitigación de $6.44M USD en Riesgo Operativo</a:t>
+            </a:r>
+          </a:p>
+        </p:txBody>
+      </p:sp>
+      <p:sp>
+        <p:nvSpPr>
+          <p:cNvPr id="5" name="Rectangle 4"/>
+          <p:cNvSpPr/>
+          <p:nvPr/>
+        </p:nvSpPr>
+        <p:spPr>
+          <a:xfrm>
+            <a:off x="1097280" y="3931920"/>
+            <a:ext cx="2514600" cy="1051560"/>
+          </a:xfrm>
+          <a:prstGeom prst="rect">
+            <a:avLst/>
+          </a:prstGeom>
+          <a:solidFill>
+            <a:srgbClr val="F8FAFC"/>
           </a:solidFill>
           <a:ln w="12700">
             <a:solidFill>
@@ -3186,57 +3301,14 @@
       </p:sp>
       <p:sp>
         <p:nvSpPr>
-          <p:cNvPr id="4" name="Rectangle 3"/>
-          <p:cNvSpPr/>
-          <p:nvPr/>
-        </p:nvSpPr>
-        <p:spPr>
-          <a:xfrm>
-            <a:off x="731520" y="731520"/>
-            <a:ext cx="10725912" cy="109728"/>
-          </a:xfrm>
-          <a:prstGeom prst="rect">
-            <a:avLst/>
-          </a:prstGeom>
-          <a:solidFill>
-            <a:srgbClr val="0284C7"/>
-          </a:solidFill>
-          <a:ln>
-            <a:noFill/>
-          </a:ln>
-        </p:spPr>
-        <p:style>
-          <a:lnRef idx="1">
-            <a:schemeClr val="accent1"/>
-          </a:lnRef>
-          <a:fillRef idx="3">
-            <a:schemeClr val="accent1"/>
-          </a:fillRef>
-          <a:effectRef idx="2">
-            <a:schemeClr val="accent1"/>
-          </a:effectRef>
-          <a:fontRef idx="minor">
-            <a:schemeClr val="lt1"/>
-          </a:fontRef>
-        </p:style>
-        <p:txBody>
-          <a:bodyPr rtlCol="0" anchor="ctr"/>
-          <a:lstStyle/>
-          <a:p>
-            <a:pPr algn="ctr"/>
-          </a:p>
-        </p:txBody>
-      </p:sp>
-      <p:sp>
-        <p:nvSpPr>
-          <p:cNvPr id="5" name="TextBox 4"/>
+          <p:cNvPr id="6" name="TextBox 5"/>
           <p:cNvSpPr txBox="1"/>
           <p:nvPr/>
         </p:nvSpPr>
         <p:spPr>
           <a:xfrm>
-            <a:off x="1188720" y="1188720"/>
-            <a:ext cx="9784080" cy="2926080"/>
+            <a:off x="1234439" y="4041648"/>
+            <a:ext cx="2240280" cy="822960"/>
           </a:xfrm>
           <a:prstGeom prst="rect">
             <a:avLst/>
@@ -3250,42 +3322,20 @@
           <a:lstStyle/>
           <a:p>
             <a:pPr>
-              <a:spcAft>
-                <a:spcPts val="800"/>
-              </a:spcAft>
-              <a:defRPr sz="1200" b="1">
-                <a:solidFill>
-                  <a:srgbClr val="0284C7"/>
-                </a:solidFill>
-                <a:latin typeface="Segoe UI"/>
-              </a:defRPr>
-            </a:pPr>
-            <a:r>
-              <a:t>PEOPLE ANALYTICS &amp; HR FINANCIAL OPTIMIZATION SUITE</a:t>
-            </a:r>
-          </a:p>
-          <a:p>
-            <a:pPr>
-              <a:spcAft>
-                <a:spcPts val="1000"/>
-              </a:spcAft>
-              <a:defRPr sz="4000" b="1">
-                <a:solidFill>
-                  <a:srgbClr val="0F172A"/>
-                </a:solidFill>
-                <a:latin typeface="Segoe UI"/>
-              </a:defRPr>
-            </a:pPr>
-            <a:r>
-              <a:t>Workforce Dynamic Lens</a:t>
-            </a:r>
-          </a:p>
-          <a:p>
-            <a:pPr>
-              <a:spcAft>
-                <a:spcPts val="2000"/>
-              </a:spcAft>
-              <a:defRPr sz="1600">
+              <a:defRPr sz="2000" b="1">
+                <a:solidFill>
+                  <a:srgbClr val="BE123C"/>
+                </a:solidFill>
+                <a:latin typeface="Segoe UI"/>
+              </a:defRPr>
+            </a:pPr>
+            <a:r>
+              <a:t>$6.44M USD</a:t>
+            </a:r>
+          </a:p>
+          <a:p>
+            <a:pPr>
+              <a:defRPr sz="950" b="1">
                 <a:solidFill>
                   <a:srgbClr val="64748B"/>
                 </a:solidFill>
@@ -3293,31 +3343,27 @@
               </a:defRPr>
             </a:pPr>
             <a:r>
-              <a:t>Conectando la Gestión de Talento con el P&amp;L: Diagnóstico de Rotación Voluntaria,</a:t>
-            </a:r>
-            <a:br/>
-            <a:r>
-              <a:t>Ausentismo Crónico y Mitigación de $6.44M USD en Riesgo Operativo</a:t>
-            </a:r>
-          </a:p>
-        </p:txBody>
-      </p:sp>
-      <p:sp>
-        <p:nvSpPr>
-          <p:cNvPr id="6" name="Rounded Rectangle 5"/>
+              <a:t>Exposición Total P&amp;L</a:t>
+            </a:r>
+          </a:p>
+        </p:txBody>
+      </p:sp>
+      <p:sp>
+        <p:nvSpPr>
+          <p:cNvPr id="7" name="Rectangle 6"/>
           <p:cNvSpPr/>
           <p:nvPr/>
         </p:nvSpPr>
         <p:spPr>
           <a:xfrm>
-            <a:off x="1188720" y="4023360"/>
-            <a:ext cx="2240280" cy="914400"/>
-          </a:xfrm>
-          <a:prstGeom prst="roundRect">
+            <a:off x="3831336" y="3931920"/>
+            <a:ext cx="2514600" cy="1051560"/>
+          </a:xfrm>
+          <a:prstGeom prst="rect">
             <a:avLst/>
           </a:prstGeom>
           <a:solidFill>
-            <a:srgbClr val="F1F5F9"/>
+            <a:srgbClr val="F8FAFC"/>
           </a:solidFill>
           <a:ln w="12700">
             <a:solidFill>
@@ -3349,14 +3395,14 @@
       </p:sp>
       <p:sp>
         <p:nvSpPr>
-          <p:cNvPr id="7" name="TextBox 6"/>
+          <p:cNvPr id="8" name="TextBox 7"/>
           <p:cNvSpPr txBox="1"/>
           <p:nvPr/>
         </p:nvSpPr>
         <p:spPr>
           <a:xfrm>
-            <a:off x="1280160" y="4114800"/>
-            <a:ext cx="2057400" cy="731520"/>
+            <a:off x="3968496" y="4041648"/>
+            <a:ext cx="2240280" cy="822960"/>
           </a:xfrm>
           <a:prstGeom prst="rect">
             <a:avLst/>
@@ -3369,21 +3415,21 @@
           </a:bodyPr>
           <a:lstStyle/>
           <a:p>
-            <a:pPr algn="ctr">
-              <a:defRPr sz="1600" b="1">
-                <a:solidFill>
-                  <a:srgbClr val="E11D48"/>
-                </a:solidFill>
-                <a:latin typeface="Segoe UI"/>
-              </a:defRPr>
-            </a:pPr>
-            <a:r>
-              <a:t>$6.44M USD</a:t>
-            </a:r>
-          </a:p>
-          <a:p>
-            <a:pPr algn="ctr">
-              <a:defRPr sz="950">
+            <a:pPr>
+              <a:defRPr sz="2000" b="1">
+                <a:solidFill>
+                  <a:srgbClr val="1D4ED8"/>
+                </a:solidFill>
+                <a:latin typeface="Segoe UI"/>
+              </a:defRPr>
+            </a:pPr>
+            <a:r>
+              <a:t>4,500</a:t>
+            </a:r>
+          </a:p>
+          <a:p>
+            <a:pPr>
+              <a:defRPr sz="950" b="1">
                 <a:solidFill>
                   <a:srgbClr val="64748B"/>
                 </a:solidFill>
@@ -3391,27 +3437,27 @@
               </a:defRPr>
             </a:pPr>
             <a:r>
-              <a:t>Exposición P&amp;L</a:t>
-            </a:r>
-          </a:p>
-        </p:txBody>
-      </p:sp>
-      <p:sp>
-        <p:nvSpPr>
-          <p:cNvPr id="8" name="Rounded Rectangle 7"/>
+              <a:t>Colaboradores Analizados</a:t>
+            </a:r>
+          </a:p>
+        </p:txBody>
+      </p:sp>
+      <p:sp>
+        <p:nvSpPr>
+          <p:cNvPr id="9" name="Rectangle 8"/>
           <p:cNvSpPr/>
           <p:nvPr/>
         </p:nvSpPr>
         <p:spPr>
           <a:xfrm>
-            <a:off x="3657600" y="4023360"/>
-            <a:ext cx="2240280" cy="914400"/>
-          </a:xfrm>
-          <a:prstGeom prst="roundRect">
+            <a:off x="6565392" y="3931920"/>
+            <a:ext cx="2514600" cy="1051560"/>
+          </a:xfrm>
+          <a:prstGeom prst="rect">
             <a:avLst/>
           </a:prstGeom>
           <a:solidFill>
-            <a:srgbClr val="F1F5F9"/>
+            <a:srgbClr val="F8FAFC"/>
           </a:solidFill>
           <a:ln w="12700">
             <a:solidFill>
@@ -3443,14 +3489,14 @@
       </p:sp>
       <p:sp>
         <p:nvSpPr>
-          <p:cNvPr id="9" name="TextBox 8"/>
+          <p:cNvPr id="10" name="TextBox 9"/>
           <p:cNvSpPr txBox="1"/>
           <p:nvPr/>
         </p:nvSpPr>
         <p:spPr>
           <a:xfrm>
-            <a:off x="3749039" y="4114800"/>
-            <a:ext cx="2057400" cy="731520"/>
+            <a:off x="6702552" y="4041648"/>
+            <a:ext cx="2240280" cy="822960"/>
           </a:xfrm>
           <a:prstGeom prst="rect">
             <a:avLst/>
@@ -3463,21 +3509,21 @@
           </a:bodyPr>
           <a:lstStyle/>
           <a:p>
-            <a:pPr algn="ctr">
-              <a:defRPr sz="1600" b="1">
-                <a:solidFill>
-                  <a:srgbClr val="0284C7"/>
-                </a:solidFill>
-                <a:latin typeface="Segoe UI"/>
-              </a:defRPr>
-            </a:pPr>
-            <a:r>
-              <a:t>4,500</a:t>
-            </a:r>
-          </a:p>
-          <a:p>
-            <a:pPr algn="ctr">
-              <a:defRPr sz="950">
+            <a:pPr>
+              <a:defRPr sz="2000" b="1">
+                <a:solidFill>
+                  <a:srgbClr val="059669"/>
+                </a:solidFill>
+                <a:latin typeface="Segoe UI"/>
+              </a:defRPr>
+            </a:pPr>
+            <a:r>
+              <a:t>535%</a:t>
+            </a:r>
+          </a:p>
+          <a:p>
+            <a:pPr>
+              <a:defRPr sz="950" b="1">
                 <a:solidFill>
                   <a:srgbClr val="64748B"/>
                 </a:solidFill>
@@ -3485,27 +3531,27 @@
               </a:defRPr>
             </a:pPr>
             <a:r>
-              <a:t>Colaboradores</a:t>
-            </a:r>
-          </a:p>
-        </p:txBody>
-      </p:sp>
-      <p:sp>
-        <p:nvSpPr>
-          <p:cNvPr id="10" name="Rounded Rectangle 9"/>
+              <a:t>Retorno de Inversión (ROI)</a:t>
+            </a:r>
+          </a:p>
+        </p:txBody>
+      </p:sp>
+      <p:sp>
+        <p:nvSpPr>
+          <p:cNvPr id="11" name="Rectangle 10"/>
           <p:cNvSpPr/>
           <p:nvPr/>
         </p:nvSpPr>
         <p:spPr>
           <a:xfrm>
-            <a:off x="6126480" y="4023360"/>
-            <a:ext cx="2240280" cy="914400"/>
-          </a:xfrm>
-          <a:prstGeom prst="roundRect">
+            <a:off x="9299448" y="3931920"/>
+            <a:ext cx="2514600" cy="1051560"/>
+          </a:xfrm>
+          <a:prstGeom prst="rect">
             <a:avLst/>
           </a:prstGeom>
           <a:solidFill>
-            <a:srgbClr val="F1F5F9"/>
+            <a:srgbClr val="F8FAFC"/>
           </a:solidFill>
           <a:ln w="12700">
             <a:solidFill>
@@ -3537,14 +3583,14 @@
       </p:sp>
       <p:sp>
         <p:nvSpPr>
-          <p:cNvPr id="11" name="TextBox 10"/>
+          <p:cNvPr id="12" name="TextBox 11"/>
           <p:cNvSpPr txBox="1"/>
           <p:nvPr/>
         </p:nvSpPr>
         <p:spPr>
           <a:xfrm>
-            <a:off x="6217920" y="4114800"/>
-            <a:ext cx="2057400" cy="731520"/>
+            <a:off x="9436608" y="4041648"/>
+            <a:ext cx="2240280" cy="822960"/>
           </a:xfrm>
           <a:prstGeom prst="rect">
             <a:avLst/>
@@ -3557,21 +3603,21 @@
           </a:bodyPr>
           <a:lstStyle/>
           <a:p>
-            <a:pPr algn="ctr">
-              <a:defRPr sz="1600" b="1">
-                <a:solidFill>
-                  <a:srgbClr val="10B981"/>
-                </a:solidFill>
-                <a:latin typeface="Segoe UI"/>
-              </a:defRPr>
-            </a:pPr>
-            <a:r>
-              <a:t>535%</a:t>
-            </a:r>
-          </a:p>
-          <a:p>
-            <a:pPr algn="ctr">
-              <a:defRPr sz="950">
+            <a:pPr>
+              <a:defRPr sz="2000" b="1">
+                <a:solidFill>
+                  <a:srgbClr val="0A2540"/>
+                </a:solidFill>
+                <a:latin typeface="Segoe UI"/>
+              </a:defRPr>
+            </a:pPr>
+            <a:r>
+              <a:t>2.8 Meses</a:t>
+            </a:r>
+          </a:p>
+          <a:p>
+            <a:pPr>
+              <a:defRPr sz="950" b="1">
                 <a:solidFill>
                   <a:srgbClr val="64748B"/>
                 </a:solidFill>
@@ -3579,53 +3625,8 @@
               </a:defRPr>
             </a:pPr>
             <a:r>
-              <a:t>ROI Proyectado</a:t>
-            </a:r>
-          </a:p>
-        </p:txBody>
-      </p:sp>
-      <p:sp>
-        <p:nvSpPr>
-          <p:cNvPr id="12" name="Rounded Rectangle 11"/>
-          <p:cNvSpPr/>
-          <p:nvPr/>
-        </p:nvSpPr>
-        <p:spPr>
-          <a:xfrm>
-            <a:off x="8595360" y="4023360"/>
-            <a:ext cx="2240280" cy="914400"/>
-          </a:xfrm>
-          <a:prstGeom prst="roundRect">
-            <a:avLst/>
-          </a:prstGeom>
-          <a:solidFill>
-            <a:srgbClr val="F1F5F9"/>
-          </a:solidFill>
-          <a:ln w="12700">
-            <a:solidFill>
-              <a:srgbClr val="E2E8F0"/>
-            </a:solidFill>
-          </a:ln>
-        </p:spPr>
-        <p:style>
-          <a:lnRef idx="1">
-            <a:schemeClr val="accent1"/>
-          </a:lnRef>
-          <a:fillRef idx="3">
-            <a:schemeClr val="accent1"/>
-          </a:fillRef>
-          <a:effectRef idx="2">
-            <a:schemeClr val="accent1"/>
-          </a:effectRef>
-          <a:fontRef idx="minor">
-            <a:schemeClr val="lt1"/>
-          </a:fontRef>
-        </p:style>
-        <p:txBody>
-          <a:bodyPr rtlCol="0" anchor="ctr"/>
-          <a:lstStyle/>
-          <a:p>
-            <a:pPr algn="ctr"/>
+              <a:t>Punto de Equilibrio</a:t>
+            </a:r>
           </a:p>
         </p:txBody>
       </p:sp>
@@ -3637,8 +3638,8 @@
         </p:nvSpPr>
         <p:spPr>
           <a:xfrm>
-            <a:off x="8686800" y="4114800"/>
-            <a:ext cx="2057400" cy="731520"/>
+            <a:off x="1097280" y="5394960"/>
+            <a:ext cx="10362895" cy="731520"/>
           </a:xfrm>
           <a:prstGeom prst="rect">
             <a:avLst/>
@@ -3651,21 +3652,21 @@
           </a:bodyPr>
           <a:lstStyle/>
           <a:p>
-            <a:pPr algn="ctr">
-              <a:defRPr sz="1600" b="1">
-                <a:solidFill>
-                  <a:srgbClr val="0F172A"/>
-                </a:solidFill>
-                <a:latin typeface="Segoe UI"/>
-              </a:defRPr>
-            </a:pPr>
-            <a:r>
-              <a:t>2.8 Meses</a:t>
-            </a:r>
-          </a:p>
-          <a:p>
-            <a:pPr algn="ctr">
-              <a:defRPr sz="950">
+            <a:pPr>
+              <a:defRPr sz="1100" b="1">
+                <a:solidFill>
+                  <a:srgbClr val="0A2540"/>
+                </a:solidFill>
+                <a:latin typeface="Segoe UI"/>
+              </a:defRPr>
+            </a:pPr>
+            <a:r>
+              <a:t>Autor: Emmanuel Rodríguez Mendoza  |  HR Tech &amp; People Analytics Specialist</a:t>
+            </a:r>
+          </a:p>
+          <a:p>
+            <a:pPr>
+              <a:defRPr sz="1000">
                 <a:solidFill>
                   <a:srgbClr val="64748B"/>
                 </a:solidFill>
@@ -3673,43 +3674,7 @@
               </a:defRPr>
             </a:pPr>
             <a:r>
-              <a:t>Payback</a:t>
-            </a:r>
-          </a:p>
-        </p:txBody>
-      </p:sp>
-      <p:sp>
-        <p:nvSpPr>
-          <p:cNvPr id="14" name="TextBox 13"/>
-          <p:cNvSpPr txBox="1"/>
-          <p:nvPr/>
-        </p:nvSpPr>
-        <p:spPr>
-          <a:xfrm>
-            <a:off x="1188720" y="5303520"/>
-            <a:ext cx="9784080" cy="548640"/>
-          </a:xfrm>
-          <a:prstGeom prst="rect">
-            <a:avLst/>
-          </a:prstGeom>
-          <a:noFill/>
-        </p:spPr>
-        <p:txBody>
-          <a:bodyPr wrap="square" lIns="0" tIns="0" rIns="0" bIns="0">
-            <a:spAutoFit/>
-          </a:bodyPr>
-          <a:lstStyle/>
-          <a:p>
-            <a:pPr>
-              <a:defRPr sz="1050" b="1">
-                <a:solidFill>
-                  <a:srgbClr val="64748B"/>
-                </a:solidFill>
-                <a:latin typeface="Segoe UI"/>
-              </a:defRPr>
-            </a:pPr>
-            <a:r>
-              <a:t>Autor: Emmanuel Rodríguez Mendoza  |  HR Tech &amp; People Analytics Specialist   •   Caso: MedTech Global Solutions (v1.0.0)</a:t>
+              <a:t>Organización: MedTech Global Solutions (México, Colombia, España, Brasil, Alemania)  •  Release Oficial v1.0.0</a:t>
             </a:r>
           </a:p>
         </p:txBody>
@@ -3747,7 +3712,7 @@
             <a:avLst/>
           </a:prstGeom>
           <a:solidFill>
-            <a:srgbClr val="F8FAFC"/>
+            <a:srgbClr val="FFFFFF"/>
           </a:solidFill>
           <a:ln>
             <a:noFill/>
@@ -3777,14 +3742,129 @@
       </p:sp>
       <p:sp>
         <p:nvSpPr>
-          <p:cNvPr id="3" name="TextBox 2"/>
+          <p:cNvPr id="3" name="Rectangle 2"/>
+          <p:cNvSpPr/>
+          <p:nvPr/>
+        </p:nvSpPr>
+        <p:spPr>
+          <a:xfrm>
+            <a:off x="731520" y="6263640"/>
+            <a:ext cx="10728655" cy="13716"/>
+          </a:xfrm>
+          <a:prstGeom prst="rect">
+            <a:avLst/>
+          </a:prstGeom>
+          <a:solidFill>
+            <a:srgbClr val="E2E8F0"/>
+          </a:solidFill>
+          <a:ln>
+            <a:noFill/>
+          </a:ln>
+        </p:spPr>
+        <p:style>
+          <a:lnRef idx="1">
+            <a:schemeClr val="accent1"/>
+          </a:lnRef>
+          <a:fillRef idx="3">
+            <a:schemeClr val="accent1"/>
+          </a:fillRef>
+          <a:effectRef idx="2">
+            <a:schemeClr val="accent1"/>
+          </a:effectRef>
+          <a:fontRef idx="minor">
+            <a:schemeClr val="lt1"/>
+          </a:fontRef>
+        </p:style>
+        <p:txBody>
+          <a:bodyPr rtlCol="0" anchor="ctr"/>
+          <a:lstStyle/>
+          <a:p>
+            <a:pPr algn="ctr"/>
+          </a:p>
+        </p:txBody>
+      </p:sp>
+      <p:sp>
+        <p:nvSpPr>
+          <p:cNvPr id="4" name="TextBox 3"/>
           <p:cNvSpPr txBox="1"/>
           <p:nvPr/>
         </p:nvSpPr>
         <p:spPr>
           <a:xfrm>
-            <a:off x="731520" y="365760"/>
-            <a:ext cx="10698480" cy="1005840"/>
+            <a:off x="731520" y="6327648"/>
+            <a:ext cx="7315200" cy="365760"/>
+          </a:xfrm>
+          <a:prstGeom prst="rect">
+            <a:avLst/>
+          </a:prstGeom>
+          <a:noFill/>
+        </p:spPr>
+        <p:txBody>
+          <a:bodyPr wrap="none" lIns="0" tIns="0" rIns="0" bIns="0">
+            <a:spAutoFit/>
+          </a:bodyPr>
+          <a:lstStyle/>
+          <a:p>
+            <a:pPr>
+              <a:defRPr sz="900">
+                <a:solidFill>
+                  <a:srgbClr val="64748B"/>
+                </a:solidFill>
+                <a:latin typeface="Segoe UI"/>
+              </a:defRPr>
+            </a:pPr>
+            <a:r>
+              <a:t>Workforce Dynamic Lens v1.0.0  •  MedTech Global Solutions  •  Executive Analytics Briefing</a:t>
+            </a:r>
+          </a:p>
+        </p:txBody>
+      </p:sp>
+      <p:sp>
+        <p:nvSpPr>
+          <p:cNvPr id="5" name="TextBox 4"/>
+          <p:cNvSpPr txBox="1"/>
+          <p:nvPr/>
+        </p:nvSpPr>
+        <p:spPr>
+          <a:xfrm>
+            <a:off x="9631375" y="6327648"/>
+            <a:ext cx="1828800" cy="365760"/>
+          </a:xfrm>
+          <a:prstGeom prst="rect">
+            <a:avLst/>
+          </a:prstGeom>
+          <a:noFill/>
+        </p:spPr>
+        <p:txBody>
+          <a:bodyPr wrap="none" lIns="0" tIns="0" rIns="0" bIns="0">
+            <a:spAutoFit/>
+          </a:bodyPr>
+          <a:lstStyle/>
+          <a:p>
+            <a:pPr algn="r">
+              <a:defRPr sz="900" b="1">
+                <a:solidFill>
+                  <a:srgbClr val="64748B"/>
+                </a:solidFill>
+                <a:latin typeface="Segoe UI"/>
+              </a:defRPr>
+            </a:pPr>
+            <a:r>
+              <a:t>02 / 09</a:t>
+            </a:r>
+          </a:p>
+        </p:txBody>
+      </p:sp>
+      <p:sp>
+        <p:nvSpPr>
+          <p:cNvPr id="6" name="TextBox 5"/>
+          <p:cNvSpPr txBox="1"/>
+          <p:nvPr/>
+        </p:nvSpPr>
+        <p:spPr>
+          <a:xfrm>
+            <a:off x="731520" y="384048"/>
+            <a:ext cx="10728655" cy="777240"/>
           </a:xfrm>
           <a:prstGeom prst="rect">
             <a:avLst/>
@@ -3798,22 +3878,25 @@
           <a:lstStyle/>
           <a:p>
             <a:pPr>
-              <a:defRPr sz="1000" b="1">
-                <a:solidFill>
-                  <a:srgbClr val="0284C7"/>
-                </a:solidFill>
-                <a:latin typeface="Segoe UI"/>
-              </a:defRPr>
-            </a:pPr>
-            <a:r>
-              <a:t>WORKFORCE DYNAMIC LENS | EXECUTIVE BRIEFING</a:t>
-            </a:r>
-          </a:p>
-          <a:p>
-            <a:pPr>
-              <a:defRPr sz="2200" b="1">
-                <a:solidFill>
-                  <a:srgbClr val="0F172A"/>
+              <a:spcAft>
+                <a:spcPts val="200"/>
+              </a:spcAft>
+              <a:defRPr sz="950" b="1">
+                <a:solidFill>
+                  <a:srgbClr val="1D4ED8"/>
+                </a:solidFill>
+                <a:latin typeface="Segoe UI"/>
+              </a:defRPr>
+            </a:pPr>
+            <a:r>
+              <a:t>MEDTECH GLOBAL SOLUTIONS  |  PEOPLE ANALYTICS</a:t>
+            </a:r>
+          </a:p>
+          <a:p>
+            <a:pPr>
+              <a:defRPr sz="2000" b="1">
+                <a:solidFill>
+                  <a:srgbClr val="0A2540"/>
                 </a:solidFill>
                 <a:latin typeface="Segoe UI"/>
               </a:defRPr>
@@ -3826,20 +3909,63 @@
       </p:sp>
       <p:sp>
         <p:nvSpPr>
-          <p:cNvPr id="4" name="Rounded Rectangle 3"/>
+          <p:cNvPr id="7" name="Rectangle 6"/>
           <p:cNvSpPr/>
           <p:nvPr/>
         </p:nvSpPr>
         <p:spPr>
           <a:xfrm>
+            <a:off x="731520" y="1234440"/>
+            <a:ext cx="10728655" cy="13716"/>
+          </a:xfrm>
+          <a:prstGeom prst="rect">
+            <a:avLst/>
+          </a:prstGeom>
+          <a:solidFill>
+            <a:srgbClr val="E2E8F0"/>
+          </a:solidFill>
+          <a:ln>
+            <a:noFill/>
+          </a:ln>
+        </p:spPr>
+        <p:style>
+          <a:lnRef idx="1">
+            <a:schemeClr val="accent1"/>
+          </a:lnRef>
+          <a:fillRef idx="3">
+            <a:schemeClr val="accent1"/>
+          </a:fillRef>
+          <a:effectRef idx="2">
+            <a:schemeClr val="accent1"/>
+          </a:effectRef>
+          <a:fontRef idx="minor">
+            <a:schemeClr val="lt1"/>
+          </a:fontRef>
+        </p:style>
+        <p:txBody>
+          <a:bodyPr rtlCol="0" anchor="ctr"/>
+          <a:lstStyle/>
+          <a:p>
+            <a:pPr algn="ctr"/>
+          </a:p>
+        </p:txBody>
+      </p:sp>
+      <p:sp>
+        <p:nvSpPr>
+          <p:cNvPr id="8" name="Rectangle 7"/>
+          <p:cNvSpPr/>
+          <p:nvPr/>
+        </p:nvSpPr>
+        <p:spPr>
+          <a:xfrm>
             <a:off x="731520" y="1463040"/>
-            <a:ext cx="2514600" cy="2011680"/>
-          </a:xfrm>
-          <a:prstGeom prst="roundRect">
+            <a:ext cx="2514600" cy="1920240"/>
+          </a:xfrm>
+          <a:prstGeom prst="rect">
             <a:avLst/>
           </a:prstGeom>
           <a:solidFill>
-            <a:srgbClr val="FFFFFF"/>
+            <a:srgbClr val="F8FAFC"/>
           </a:solidFill>
           <a:ln w="12700">
             <a:solidFill>
@@ -3871,14 +3997,14 @@
       </p:sp>
       <p:sp>
         <p:nvSpPr>
-          <p:cNvPr id="5" name="TextBox 4"/>
+          <p:cNvPr id="9" name="TextBox 8"/>
           <p:cNvSpPr txBox="1"/>
           <p:nvPr/>
         </p:nvSpPr>
         <p:spPr>
           <a:xfrm>
-            <a:off x="868680" y="1600200"/>
-            <a:ext cx="2240280" cy="1737360"/>
+            <a:off x="896112" y="1627632"/>
+            <a:ext cx="2185416" cy="1600200"/>
           </a:xfrm>
           <a:prstGeom prst="rect">
             <a:avLst/>
@@ -3895,9 +4021,9 @@
               <a:spcAft>
                 <a:spcPts val="400"/>
               </a:spcAft>
-              <a:defRPr sz="2600" b="1">
-                <a:solidFill>
-                  <a:srgbClr val="E11D48"/>
+              <a:defRPr sz="2400" b="1">
+                <a:solidFill>
+                  <a:srgbClr val="BE123C"/>
                 </a:solidFill>
                 <a:latin typeface="Segoe UI"/>
               </a:defRPr>
@@ -3911,9 +4037,9 @@
               <a:spcAft>
                 <a:spcPts val="600"/>
               </a:spcAft>
-              <a:defRPr sz="1200" b="1">
-                <a:solidFill>
-                  <a:srgbClr val="0F172A"/>
+              <a:defRPr sz="1150" b="1">
+                <a:solidFill>
+                  <a:srgbClr val="0A2540"/>
                 </a:solidFill>
                 <a:latin typeface="Segoe UI"/>
               </a:defRPr>
@@ -3932,27 +4058,27 @@
               </a:defRPr>
             </a:pPr>
             <a:r>
-              <a:t>Costos de vacancia en I+D, multas de SLA y rotación voluntaria</a:t>
-            </a:r>
-          </a:p>
-        </p:txBody>
-      </p:sp>
-      <p:sp>
-        <p:nvSpPr>
-          <p:cNvPr id="6" name="Rounded Rectangle 5"/>
+              <a:t>Costos de vacancia en I+D, multas contractuales de SLA y rotación voluntaria.</a:t>
+            </a:r>
+          </a:p>
+        </p:txBody>
+      </p:sp>
+      <p:sp>
+        <p:nvSpPr>
+          <p:cNvPr id="10" name="Rectangle 9"/>
           <p:cNvSpPr/>
           <p:nvPr/>
         </p:nvSpPr>
         <p:spPr>
           <a:xfrm>
-            <a:off x="3456432" y="1463040"/>
-            <a:ext cx="2514600" cy="2011680"/>
-          </a:xfrm>
-          <a:prstGeom prst="roundRect">
+            <a:off x="3465576" y="1463040"/>
+            <a:ext cx="2514600" cy="1920240"/>
+          </a:xfrm>
+          <a:prstGeom prst="rect">
             <a:avLst/>
           </a:prstGeom>
           <a:solidFill>
-            <a:srgbClr val="FFFFFF"/>
+            <a:srgbClr val="F8FAFC"/>
           </a:solidFill>
           <a:ln w="12700">
             <a:solidFill>
@@ -3984,14 +4110,14 @@
       </p:sp>
       <p:sp>
         <p:nvSpPr>
-          <p:cNvPr id="7" name="TextBox 6"/>
+          <p:cNvPr id="11" name="TextBox 10"/>
           <p:cNvSpPr txBox="1"/>
           <p:nvPr/>
         </p:nvSpPr>
         <p:spPr>
           <a:xfrm>
-            <a:off x="3593592" y="1600200"/>
-            <a:ext cx="2240280" cy="1737360"/>
+            <a:off x="3630168" y="1627632"/>
+            <a:ext cx="2185416" cy="1600200"/>
           </a:xfrm>
           <a:prstGeom prst="rect">
             <a:avLst/>
@@ -4008,9 +4134,9 @@
               <a:spcAft>
                 <a:spcPts val="400"/>
               </a:spcAft>
-              <a:defRPr sz="2600" b="1">
-                <a:solidFill>
-                  <a:srgbClr val="0284C7"/>
+              <a:defRPr sz="2400" b="1">
+                <a:solidFill>
+                  <a:srgbClr val="1D4ED8"/>
                 </a:solidFill>
                 <a:latin typeface="Segoe UI"/>
               </a:defRPr>
@@ -4024,9 +4150,9 @@
               <a:spcAft>
                 <a:spcPts val="600"/>
               </a:spcAft>
-              <a:defRPr sz="1200" b="1">
-                <a:solidFill>
-                  <a:srgbClr val="0F172A"/>
+              <a:defRPr sz="1150" b="1">
+                <a:solidFill>
+                  <a:srgbClr val="0A2540"/>
                 </a:solidFill>
                 <a:latin typeface="Segoe UI"/>
               </a:defRPr>
@@ -4045,27 +4171,27 @@
               </a:defRPr>
             </a:pPr>
             <a:r>
-              <a:t>3,300 Activos / 1,200 Bajas históricas en 5 países clave</a:t>
-            </a:r>
-          </a:p>
-        </p:txBody>
-      </p:sp>
-      <p:sp>
-        <p:nvSpPr>
-          <p:cNvPr id="8" name="Rounded Rectangle 7"/>
+              <a:t>3,300 Activos / 1,200 Bajas históricas en 5 países clave (2020-2025).</a:t>
+            </a:r>
+          </a:p>
+        </p:txBody>
+      </p:sp>
+      <p:sp>
+        <p:nvSpPr>
+          <p:cNvPr id="12" name="Rectangle 11"/>
           <p:cNvSpPr/>
           <p:nvPr/>
         </p:nvSpPr>
         <p:spPr>
           <a:xfrm>
-            <a:off x="6181344" y="1463040"/>
-            <a:ext cx="2514600" cy="2011680"/>
-          </a:xfrm>
-          <a:prstGeom prst="roundRect">
+            <a:off x="6199632" y="1463040"/>
+            <a:ext cx="2514600" cy="1920240"/>
+          </a:xfrm>
+          <a:prstGeom prst="rect">
             <a:avLst/>
           </a:prstGeom>
           <a:solidFill>
-            <a:srgbClr val="FFFFFF"/>
+            <a:srgbClr val="F8FAFC"/>
           </a:solidFill>
           <a:ln w="12700">
             <a:solidFill>
@@ -4097,14 +4223,14 @@
       </p:sp>
       <p:sp>
         <p:nvSpPr>
-          <p:cNvPr id="9" name="TextBox 8"/>
+          <p:cNvPr id="13" name="TextBox 12"/>
           <p:cNvSpPr txBox="1"/>
           <p:nvPr/>
         </p:nvSpPr>
         <p:spPr>
           <a:xfrm>
-            <a:off x="6318504" y="1600200"/>
-            <a:ext cx="2240280" cy="1737360"/>
+            <a:off x="6364224" y="1627632"/>
+            <a:ext cx="2185416" cy="1600200"/>
           </a:xfrm>
           <a:prstGeom prst="rect">
             <a:avLst/>
@@ -4121,9 +4247,9 @@
               <a:spcAft>
                 <a:spcPts val="400"/>
               </a:spcAft>
-              <a:defRPr sz="2600" b="1">
-                <a:solidFill>
-                  <a:srgbClr val="10B981"/>
+              <a:defRPr sz="2400" b="1">
+                <a:solidFill>
+                  <a:srgbClr val="059669"/>
                 </a:solidFill>
                 <a:latin typeface="Segoe UI"/>
               </a:defRPr>
@@ -4137,9 +4263,9 @@
               <a:spcAft>
                 <a:spcPts val="600"/>
               </a:spcAft>
-              <a:defRPr sz="1200" b="1">
-                <a:solidFill>
-                  <a:srgbClr val="0F172A"/>
+              <a:defRPr sz="1150" b="1">
+                <a:solidFill>
+                  <a:srgbClr val="0A2540"/>
                 </a:solidFill>
                 <a:latin typeface="Segoe UI"/>
               </a:defRPr>
@@ -4158,27 +4284,27 @@
               </a:defRPr>
             </a:pPr>
             <a:r>
-              <a:t>$455,000 USD de beneficio neto en Año 1 con inversión de $85k USD</a:t>
-            </a:r>
-          </a:p>
-        </p:txBody>
-      </p:sp>
-      <p:sp>
-        <p:nvSpPr>
-          <p:cNvPr id="10" name="Rounded Rectangle 9"/>
+              <a:t>$455,000 USD de beneficio neto en Año 1 frente a $85,000 USD de inversión.</a:t>
+            </a:r>
+          </a:p>
+        </p:txBody>
+      </p:sp>
+      <p:sp>
+        <p:nvSpPr>
+          <p:cNvPr id="14" name="Rectangle 13"/>
           <p:cNvSpPr/>
           <p:nvPr/>
         </p:nvSpPr>
         <p:spPr>
           <a:xfrm>
-            <a:off x="8906256" y="1463040"/>
-            <a:ext cx="2514600" cy="2011680"/>
-          </a:xfrm>
-          <a:prstGeom prst="roundRect">
+            <a:off x="8933688" y="1463040"/>
+            <a:ext cx="2514600" cy="1920240"/>
+          </a:xfrm>
+          <a:prstGeom prst="rect">
             <a:avLst/>
           </a:prstGeom>
           <a:solidFill>
-            <a:srgbClr val="FFFFFF"/>
+            <a:srgbClr val="F8FAFC"/>
           </a:solidFill>
           <a:ln w="12700">
             <a:solidFill>
@@ -4210,14 +4336,14 @@
       </p:sp>
       <p:sp>
         <p:nvSpPr>
-          <p:cNvPr id="11" name="TextBox 10"/>
+          <p:cNvPr id="15" name="TextBox 14"/>
           <p:cNvSpPr txBox="1"/>
           <p:nvPr/>
         </p:nvSpPr>
         <p:spPr>
           <a:xfrm>
-            <a:off x="9043416" y="1600200"/>
-            <a:ext cx="2240280" cy="1737360"/>
+            <a:off x="9098280" y="1627632"/>
+            <a:ext cx="2185416" cy="1600200"/>
           </a:xfrm>
           <a:prstGeom prst="rect">
             <a:avLst/>
@@ -4234,9 +4360,9 @@
               <a:spcAft>
                 <a:spcPts val="400"/>
               </a:spcAft>
-              <a:defRPr sz="2600" b="1">
-                <a:solidFill>
-                  <a:srgbClr val="0F172A"/>
+              <a:defRPr sz="2400" b="1">
+                <a:solidFill>
+                  <a:srgbClr val="0A2540"/>
                 </a:solidFill>
                 <a:latin typeface="Segoe UI"/>
               </a:defRPr>
@@ -4250,9 +4376,9 @@
               <a:spcAft>
                 <a:spcPts val="600"/>
               </a:spcAft>
-              <a:defRPr sz="1200" b="1">
-                <a:solidFill>
-                  <a:srgbClr val="0F172A"/>
+              <a:defRPr sz="1150" b="1">
+                <a:solidFill>
+                  <a:srgbClr val="0A2540"/>
                 </a:solidFill>
                 <a:latin typeface="Segoe UI"/>
               </a:defRPr>
@@ -4271,27 +4397,27 @@
               </a:defRPr>
             </a:pPr>
             <a:r>
-              <a:t>Punto de equilibrio financiero post-implementación del plan de retención</a:t>
-            </a:r>
-          </a:p>
-        </p:txBody>
-      </p:sp>
-      <p:sp>
-        <p:nvSpPr>
-          <p:cNvPr id="12" name="Rounded Rectangle 11"/>
+              <a:t>Punto de equilibrio financiero post-implementación del plan de intervención.</a:t>
+            </a:r>
+          </a:p>
+        </p:txBody>
+      </p:sp>
+      <p:sp>
+        <p:nvSpPr>
+          <p:cNvPr id="16" name="Rectangle 15"/>
           <p:cNvSpPr/>
           <p:nvPr/>
         </p:nvSpPr>
         <p:spPr>
           <a:xfrm>
-            <a:off x="731520" y="3749039"/>
-            <a:ext cx="10725912" cy="2560320"/>
-          </a:xfrm>
-          <a:prstGeom prst="roundRect">
+            <a:off x="731520" y="3611880"/>
+            <a:ext cx="10728655" cy="2423160"/>
+          </a:xfrm>
+          <a:prstGeom prst="rect">
             <a:avLst/>
           </a:prstGeom>
           <a:solidFill>
-            <a:srgbClr val="FFFFFF"/>
+            <a:srgbClr val="F8FAFC"/>
           </a:solidFill>
           <a:ln w="12700">
             <a:solidFill>
@@ -4323,14 +4449,14 @@
       </p:sp>
       <p:sp>
         <p:nvSpPr>
-          <p:cNvPr id="13" name="TextBox 12"/>
+          <p:cNvPr id="17" name="TextBox 16"/>
           <p:cNvSpPr txBox="1"/>
           <p:nvPr/>
         </p:nvSpPr>
         <p:spPr>
           <a:xfrm>
-            <a:off x="1005840" y="3931920"/>
-            <a:ext cx="10149840" cy="2194560"/>
+            <a:off x="1005840" y="3794760"/>
+            <a:ext cx="10180015" cy="2103120"/>
           </a:xfrm>
           <a:prstGeom prst="rect">
             <a:avLst/>
@@ -4347,15 +4473,15 @@
               <a:spcAft>
                 <a:spcPts val="800"/>
               </a:spcAft>
-              <a:defRPr sz="1100" b="1">
-                <a:solidFill>
-                  <a:srgbClr val="0284C7"/>
-                </a:solidFill>
-                <a:latin typeface="Segoe UI"/>
-              </a:defRPr>
-            </a:pPr>
-            <a:r>
-              <a:t>ALCANCE DE LA CONSULTORÍA ANALÍTICA</a:t>
+              <a:defRPr sz="1050" b="1">
+                <a:solidFill>
+                  <a:srgbClr val="1D4ED8"/>
+                </a:solidFill>
+                <a:latin typeface="Segoe UI"/>
+              </a:defRPr>
+            </a:pPr>
+            <a:r>
+              <a:t>ALCANCE DE LA CONSULTORÍA ANALÍTICA &amp; ESTRATEGIA DE TALENTO</a:t>
             </a:r>
           </a:p>
           <a:p>
@@ -4365,18 +4491,18 @@
               </a:spcAft>
             </a:pPr>
             <a:r>
-              <a:rPr sz="1100" b="1">
-                <a:solidFill>
-                  <a:srgbClr val="0F172A"/>
+              <a:rPr sz="1050" b="1">
+                <a:solidFill>
+                  <a:srgbClr val="0A2540"/>
                 </a:solidFill>
                 <a:latin typeface="Segoe UI"/>
               </a:rPr>
               <a:t>•  Presencia Multinacional: </a:t>
             </a:r>
             <a:r>
-              <a:rPr sz="1100">
-                <a:solidFill>
-                  <a:srgbClr val="64748B"/>
+              <a:rPr sz="1050">
+                <a:solidFill>
+                  <a:srgbClr val="1E293B"/>
                 </a:solidFill>
                 <a:latin typeface="Segoe UI"/>
               </a:rPr>
@@ -4390,18 +4516,18 @@
               </a:spcAft>
             </a:pPr>
             <a:r>
-              <a:rPr sz="1100" b="1">
-                <a:solidFill>
-                  <a:srgbClr val="0F172A"/>
+              <a:rPr sz="1050" b="1">
+                <a:solidFill>
+                  <a:srgbClr val="0A2540"/>
                 </a:solidFill>
                 <a:latin typeface="Segoe UI"/>
               </a:rPr>
               <a:t>•  Desconexión Tradicional de RR. HH.: </a:t>
             </a:r>
             <a:r>
-              <a:rPr sz="1100">
-                <a:solidFill>
-                  <a:srgbClr val="64748B"/>
+              <a:rPr sz="1050">
+                <a:solidFill>
+                  <a:srgbClr val="1E293B"/>
                 </a:solidFill>
                 <a:latin typeface="Segoe UI"/>
               </a:rPr>
@@ -4415,22 +4541,22 @@
               </a:spcAft>
             </a:pPr>
             <a:r>
-              <a:rPr sz="1100" b="1">
-                <a:solidFill>
-                  <a:srgbClr val="0F172A"/>
+              <a:rPr sz="1050" b="1">
+                <a:solidFill>
+                  <a:srgbClr val="0A2540"/>
                 </a:solidFill>
                 <a:latin typeface="Segoe UI"/>
               </a:rPr>
               <a:t>•  Solución Integrada: </a:t>
             </a:r>
             <a:r>
-              <a:rPr sz="1100">
-                <a:solidFill>
-                  <a:srgbClr val="64748B"/>
+              <a:rPr sz="1050">
+                <a:solidFill>
+                  <a:srgbClr val="1E293B"/>
                 </a:solidFill>
                 <a:latin typeface="Segoe UI"/>
               </a:rPr>
-              <a:t>Unificación de datos relacionales en PostgreSQL (Kimball Star Schema), análisis analítico en SQL y visualización ejecutiva en Power BI con simulador dinámico What-If.</a:t>
+              <a:t>Unificación de datos relacionales en PostgreSQL (Kimball Star Schema), análisis en SQL y visualización ejecutiva en Power BI con simulador dinámico What-If.</a:t>
             </a:r>
           </a:p>
           <a:p>
@@ -4440,18 +4566,18 @@
               </a:spcAft>
             </a:pPr>
             <a:r>
-              <a:rPr sz="1100" b="1">
-                <a:solidFill>
-                  <a:srgbClr val="0F172A"/>
+              <a:rPr sz="1050" b="1">
+                <a:solidFill>
+                  <a:srgbClr val="0A2540"/>
                 </a:solidFill>
                 <a:latin typeface="Segoe UI"/>
               </a:rPr>
-              <a:t>•  Enfoque en Decisiones Basadas en Evidencia: </a:t>
-            </a:r>
-            <a:r>
-              <a:rPr sz="1100">
-                <a:solidFill>
-                  <a:srgbClr val="64748B"/>
+              <a:t>•  Decisiones Basadas en Evidencia: </a:t>
+            </a:r>
+            <a:r>
+              <a:rPr sz="1050">
+                <a:solidFill>
+                  <a:srgbClr val="1E293B"/>
                 </a:solidFill>
                 <a:latin typeface="Segoe UI"/>
               </a:rPr>
@@ -4493,7 +4619,7 @@
             <a:avLst/>
           </a:prstGeom>
           <a:solidFill>
-            <a:srgbClr val="F8FAFC"/>
+            <a:srgbClr val="FFFFFF"/>
           </a:solidFill>
           <a:ln>
             <a:noFill/>
@@ -4523,14 +4649,129 @@
       </p:sp>
       <p:sp>
         <p:nvSpPr>
-          <p:cNvPr id="3" name="TextBox 2"/>
+          <p:cNvPr id="3" name="Rectangle 2"/>
+          <p:cNvSpPr/>
+          <p:nvPr/>
+        </p:nvSpPr>
+        <p:spPr>
+          <a:xfrm>
+            <a:off x="731520" y="6263640"/>
+            <a:ext cx="10728655" cy="13716"/>
+          </a:xfrm>
+          <a:prstGeom prst="rect">
+            <a:avLst/>
+          </a:prstGeom>
+          <a:solidFill>
+            <a:srgbClr val="E2E8F0"/>
+          </a:solidFill>
+          <a:ln>
+            <a:noFill/>
+          </a:ln>
+        </p:spPr>
+        <p:style>
+          <a:lnRef idx="1">
+            <a:schemeClr val="accent1"/>
+          </a:lnRef>
+          <a:fillRef idx="3">
+            <a:schemeClr val="accent1"/>
+          </a:fillRef>
+          <a:effectRef idx="2">
+            <a:schemeClr val="accent1"/>
+          </a:effectRef>
+          <a:fontRef idx="minor">
+            <a:schemeClr val="lt1"/>
+          </a:fontRef>
+        </p:style>
+        <p:txBody>
+          <a:bodyPr rtlCol="0" anchor="ctr"/>
+          <a:lstStyle/>
+          <a:p>
+            <a:pPr algn="ctr"/>
+          </a:p>
+        </p:txBody>
+      </p:sp>
+      <p:sp>
+        <p:nvSpPr>
+          <p:cNvPr id="4" name="TextBox 3"/>
           <p:cNvSpPr txBox="1"/>
           <p:nvPr/>
         </p:nvSpPr>
         <p:spPr>
           <a:xfrm>
-            <a:off x="731520" y="365760"/>
-            <a:ext cx="10698480" cy="1005840"/>
+            <a:off x="731520" y="6327648"/>
+            <a:ext cx="7315200" cy="365760"/>
+          </a:xfrm>
+          <a:prstGeom prst="rect">
+            <a:avLst/>
+          </a:prstGeom>
+          <a:noFill/>
+        </p:spPr>
+        <p:txBody>
+          <a:bodyPr wrap="none" lIns="0" tIns="0" rIns="0" bIns="0">
+            <a:spAutoFit/>
+          </a:bodyPr>
+          <a:lstStyle/>
+          <a:p>
+            <a:pPr>
+              <a:defRPr sz="900">
+                <a:solidFill>
+                  <a:srgbClr val="64748B"/>
+                </a:solidFill>
+                <a:latin typeface="Segoe UI"/>
+              </a:defRPr>
+            </a:pPr>
+            <a:r>
+              <a:t>Workforce Dynamic Lens v1.0.0  •  MedTech Global Solutions  •  Executive Analytics Briefing</a:t>
+            </a:r>
+          </a:p>
+        </p:txBody>
+      </p:sp>
+      <p:sp>
+        <p:nvSpPr>
+          <p:cNvPr id="5" name="TextBox 4"/>
+          <p:cNvSpPr txBox="1"/>
+          <p:nvPr/>
+        </p:nvSpPr>
+        <p:spPr>
+          <a:xfrm>
+            <a:off x="9631375" y="6327648"/>
+            <a:ext cx="1828800" cy="365760"/>
+          </a:xfrm>
+          <a:prstGeom prst="rect">
+            <a:avLst/>
+          </a:prstGeom>
+          <a:noFill/>
+        </p:spPr>
+        <p:txBody>
+          <a:bodyPr wrap="none" lIns="0" tIns="0" rIns="0" bIns="0">
+            <a:spAutoFit/>
+          </a:bodyPr>
+          <a:lstStyle/>
+          <a:p>
+            <a:pPr algn="r">
+              <a:defRPr sz="900" b="1">
+                <a:solidFill>
+                  <a:srgbClr val="64748B"/>
+                </a:solidFill>
+                <a:latin typeface="Segoe UI"/>
+              </a:defRPr>
+            </a:pPr>
+            <a:r>
+              <a:t>03 / 09</a:t>
+            </a:r>
+          </a:p>
+        </p:txBody>
+      </p:sp>
+      <p:sp>
+        <p:nvSpPr>
+          <p:cNvPr id="6" name="TextBox 5"/>
+          <p:cNvSpPr txBox="1"/>
+          <p:nvPr/>
+        </p:nvSpPr>
+        <p:spPr>
+          <a:xfrm>
+            <a:off x="731520" y="384048"/>
+            <a:ext cx="10728655" cy="777240"/>
           </a:xfrm>
           <a:prstGeom prst="rect">
             <a:avLst/>
@@ -4544,48 +4785,94 @@
           <a:lstStyle/>
           <a:p>
             <a:pPr>
-              <a:defRPr sz="1000" b="1">
-                <a:solidFill>
-                  <a:srgbClr val="0284C7"/>
-                </a:solidFill>
-                <a:latin typeface="Segoe UI"/>
-              </a:defRPr>
-            </a:pPr>
-            <a:r>
-              <a:t>WORKFORCE DYNAMIC LENS | EXECUTIVE BRIEFING</a:t>
-            </a:r>
-          </a:p>
-          <a:p>
-            <a:pPr>
-              <a:defRPr sz="2200" b="1">
-                <a:solidFill>
-                  <a:srgbClr val="0F172A"/>
-                </a:solidFill>
-                <a:latin typeface="Segoe UI"/>
-              </a:defRPr>
-            </a:pPr>
-            <a:r>
-              <a:t>Diagnóstico: Los Dos Cuellos de Botella en MedTech Global</a:t>
-            </a:r>
-          </a:p>
-        </p:txBody>
-      </p:sp>
-      <p:sp>
-        <p:nvSpPr>
-          <p:cNvPr id="4" name="Rounded Rectangle 3"/>
+              <a:spcAft>
+                <a:spcPts val="200"/>
+              </a:spcAft>
+              <a:defRPr sz="950" b="1">
+                <a:solidFill>
+                  <a:srgbClr val="1D4ED8"/>
+                </a:solidFill>
+                <a:latin typeface="Segoe UI"/>
+              </a:defRPr>
+            </a:pPr>
+            <a:r>
+              <a:t>MEDTECH GLOBAL SOLUTIONS  |  PEOPLE ANALYTICS</a:t>
+            </a:r>
+          </a:p>
+          <a:p>
+            <a:pPr>
+              <a:defRPr sz="2000" b="1">
+                <a:solidFill>
+                  <a:srgbClr val="0A2540"/>
+                </a:solidFill>
+                <a:latin typeface="Segoe UI"/>
+              </a:defRPr>
+            </a:pPr>
+            <a:r>
+              <a:t>Diagnóstico de Cuellos de Botella: Fuga de Talento y Ausentismo</a:t>
+            </a:r>
+          </a:p>
+        </p:txBody>
+      </p:sp>
+      <p:sp>
+        <p:nvSpPr>
+          <p:cNvPr id="7" name="Rectangle 6"/>
           <p:cNvSpPr/>
           <p:nvPr/>
         </p:nvSpPr>
         <p:spPr>
           <a:xfrm>
+            <a:off x="731520" y="1234440"/>
+            <a:ext cx="10728655" cy="13716"/>
+          </a:xfrm>
+          <a:prstGeom prst="rect">
+            <a:avLst/>
+          </a:prstGeom>
+          <a:solidFill>
+            <a:srgbClr val="E2E8F0"/>
+          </a:solidFill>
+          <a:ln>
+            <a:noFill/>
+          </a:ln>
+        </p:spPr>
+        <p:style>
+          <a:lnRef idx="1">
+            <a:schemeClr val="accent1"/>
+          </a:lnRef>
+          <a:fillRef idx="3">
+            <a:schemeClr val="accent1"/>
+          </a:fillRef>
+          <a:effectRef idx="2">
+            <a:schemeClr val="accent1"/>
+          </a:effectRef>
+          <a:fontRef idx="minor">
+            <a:schemeClr val="lt1"/>
+          </a:fontRef>
+        </p:style>
+        <p:txBody>
+          <a:bodyPr rtlCol="0" anchor="ctr"/>
+          <a:lstStyle/>
+          <a:p>
+            <a:pPr algn="ctr"/>
+          </a:p>
+        </p:txBody>
+      </p:sp>
+      <p:sp>
+        <p:nvSpPr>
+          <p:cNvPr id="8" name="Rectangle 7"/>
+          <p:cNvSpPr/>
+          <p:nvPr/>
+        </p:nvSpPr>
+        <p:spPr>
+          <a:xfrm>
             <a:off x="731520" y="1463040"/>
-            <a:ext cx="5212080" cy="4846320"/>
-          </a:xfrm>
-          <a:prstGeom prst="roundRect">
+            <a:ext cx="5230368" cy="4572000"/>
+          </a:xfrm>
+          <a:prstGeom prst="rect">
             <a:avLst/>
           </a:prstGeom>
           <a:solidFill>
-            <a:srgbClr val="FFFFFF"/>
+            <a:srgbClr val="F8FAFC"/>
           </a:solidFill>
           <a:ln w="12700">
             <a:solidFill>
@@ -4617,14 +4904,14 @@
       </p:sp>
       <p:sp>
         <p:nvSpPr>
-          <p:cNvPr id="5" name="TextBox 4"/>
+          <p:cNvPr id="9" name="TextBox 8"/>
           <p:cNvSpPr txBox="1"/>
           <p:nvPr/>
         </p:nvSpPr>
         <p:spPr>
           <a:xfrm>
-            <a:off x="1005840" y="1737360"/>
-            <a:ext cx="4663440" cy="4297680"/>
+            <a:off x="960120" y="1691640"/>
+            <a:ext cx="4773168" cy="4114800"/>
           </a:xfrm>
           <a:prstGeom prst="rect">
             <a:avLst/>
@@ -4641,9 +4928,9 @@
               <a:spcAft>
                 <a:spcPts val="1000"/>
               </a:spcAft>
-              <a:defRPr sz="1300" b="1">
-                <a:solidFill>
-                  <a:srgbClr val="E11D48"/>
+              <a:defRPr sz="1200" b="1">
+                <a:solidFill>
+                  <a:srgbClr val="BE123C"/>
                 </a:solidFill>
                 <a:latin typeface="Segoe UI"/>
               </a:defRPr>
@@ -4659,18 +4946,18 @@
               </a:spcAft>
             </a:pPr>
             <a:r>
-              <a:rPr sz="1100" b="1">
-                <a:solidFill>
-                  <a:srgbClr val="0F172A"/>
+              <a:rPr sz="1050" b="1">
+                <a:solidFill>
+                  <a:srgbClr val="0A2540"/>
                 </a:solidFill>
                 <a:latin typeface="Segoe UI"/>
               </a:rPr>
               <a:t>• Síntoma: </a:t>
             </a:r>
             <a:r>
-              <a:rPr sz="1050">
-                <a:solidFill>
-                  <a:srgbClr val="64748B"/>
+              <a:rPr sz="1000">
+                <a:solidFill>
+                  <a:srgbClr val="1E293B"/>
                 </a:solidFill>
                 <a:latin typeface="Segoe UI"/>
               </a:rPr>
@@ -4684,22 +4971,22 @@
               </a:spcAft>
             </a:pPr>
             <a:r>
-              <a:rPr sz="1100" b="1">
-                <a:solidFill>
-                  <a:srgbClr val="0F172A"/>
+              <a:rPr sz="1050" b="1">
+                <a:solidFill>
+                  <a:srgbClr val="0A2540"/>
                 </a:solidFill>
                 <a:latin typeface="Segoe UI"/>
               </a:rPr>
               <a:t>• Causa Raíz Revelada: </a:t>
             </a:r>
             <a:r>
-              <a:rPr sz="1050">
-                <a:solidFill>
-                  <a:srgbClr val="64748B"/>
+              <a:rPr sz="1000">
+                <a:solidFill>
+                  <a:srgbClr val="1E293B"/>
                 </a:solidFill>
                 <a:latin typeface="Segoe UI"/>
               </a:rPr>
-              <a:t>Desalineación frente a mercado (Compa-Ratio &lt; 0.85). Las entrevistas de salida registraban 'Desarrollo Profesional', enmascarando una brecha salarial del 15% al 20%.</a:t>
+              <a:t>Desalineación salarial severa frente al mercado (Compa-Ratio &lt; 0.85). Las entrevistas de salida registraban 'Desarrollo Profesional', enmascarando una brecha de competitividad salarial.</a:t>
             </a:r>
           </a:p>
           <a:p>
@@ -4709,18 +4996,18 @@
               </a:spcAft>
             </a:pPr>
             <a:r>
-              <a:rPr sz="1100" b="1">
-                <a:solidFill>
-                  <a:srgbClr val="0F172A"/>
+              <a:rPr sz="1050" b="1">
+                <a:solidFill>
+                  <a:srgbClr val="0A2540"/>
                 </a:solidFill>
                 <a:latin typeface="Segoe UI"/>
               </a:rPr>
               <a:t>• Impacto en Negocio: </a:t>
             </a:r>
             <a:r>
-              <a:rPr sz="1050">
-                <a:solidFill>
-                  <a:srgbClr val="64748B"/>
+              <a:rPr sz="1000">
+                <a:solidFill>
+                  <a:srgbClr val="1E293B"/>
                 </a:solidFill>
                 <a:latin typeface="Segoe UI"/>
               </a:rPr>
@@ -4734,42 +5021,42 @@
               </a:spcAft>
             </a:pPr>
             <a:r>
-              <a:rPr sz="1100" b="1">
-                <a:solidFill>
-                  <a:srgbClr val="0F172A"/>
+              <a:rPr sz="1050" b="1">
+                <a:solidFill>
+                  <a:srgbClr val="0A2540"/>
                 </a:solidFill>
                 <a:latin typeface="Segoe UI"/>
               </a:rPr>
               <a:t>• Consecuencia en P&amp;L: </a:t>
             </a:r>
             <a:r>
-              <a:rPr sz="1050">
-                <a:solidFill>
-                  <a:srgbClr val="64748B"/>
+              <a:rPr sz="1000">
+                <a:solidFill>
+                  <a:srgbClr val="1E293B"/>
                 </a:solidFill>
                 <a:latin typeface="Segoe UI"/>
               </a:rPr>
-              <a:t>Caída del 12% en velocidad de lanzamiento de software clínico y sobrecosto por vacancia de $1.2M USD.</a:t>
-            </a:r>
-          </a:p>
-        </p:txBody>
-      </p:sp>
-      <p:sp>
-        <p:nvSpPr>
-          <p:cNvPr id="6" name="Rounded Rectangle 5"/>
+              <a:t>Caída del 12% en velocidad de lanzamiento de software clínico y sobrecosto por vacancia ponderada de $1.2M USD.</a:t>
+            </a:r>
+          </a:p>
+        </p:txBody>
+      </p:sp>
+      <p:sp>
+        <p:nvSpPr>
+          <p:cNvPr id="10" name="Rectangle 9"/>
           <p:cNvSpPr/>
           <p:nvPr/>
         </p:nvSpPr>
         <p:spPr>
           <a:xfrm>
-            <a:off x="6217920" y="1463040"/>
-            <a:ext cx="5212080" cy="4846320"/>
-          </a:xfrm>
-          <a:prstGeom prst="roundRect">
+            <a:off x="6229807" y="1463040"/>
+            <a:ext cx="5230368" cy="4572000"/>
+          </a:xfrm>
+          <a:prstGeom prst="rect">
             <a:avLst/>
           </a:prstGeom>
           <a:solidFill>
-            <a:srgbClr val="FFFFFF"/>
+            <a:srgbClr val="F8FAFC"/>
           </a:solidFill>
           <a:ln w="12700">
             <a:solidFill>
@@ -4801,14 +5088,14 @@
       </p:sp>
       <p:sp>
         <p:nvSpPr>
-          <p:cNvPr id="7" name="TextBox 6"/>
+          <p:cNvPr id="11" name="TextBox 10"/>
           <p:cNvSpPr txBox="1"/>
           <p:nvPr/>
         </p:nvSpPr>
         <p:spPr>
           <a:xfrm>
-            <a:off x="6492240" y="1737360"/>
-            <a:ext cx="4663440" cy="4297680"/>
+            <a:off x="6458407" y="1691640"/>
+            <a:ext cx="4773168" cy="4114800"/>
           </a:xfrm>
           <a:prstGeom prst="rect">
             <a:avLst/>
@@ -4825,15 +5112,15 @@
               <a:spcAft>
                 <a:spcPts val="1000"/>
               </a:spcAft>
-              <a:defRPr sz="1300" b="1">
-                <a:solidFill>
-                  <a:srgbClr val="E11D48"/>
-                </a:solidFill>
-                <a:latin typeface="Segoe UI"/>
-              </a:defRPr>
-            </a:pPr>
-            <a:r>
-              <a:t>FOCO 2: AUSENTISMO CRÓNICO &amp; MULTAS SLA</a:t>
+              <a:defRPr sz="1200" b="1">
+                <a:solidFill>
+                  <a:srgbClr val="BE123C"/>
+                </a:solidFill>
+                <a:latin typeface="Segoe UI"/>
+              </a:defRPr>
+            </a:pPr>
+            <a:r>
+              <a:t>FOCO 2: AUSENTISMO CRÓNICO &amp; MULTAS DE SLA</a:t>
             </a:r>
           </a:p>
           <a:p>
@@ -4843,22 +5130,22 @@
               </a:spcAft>
             </a:pPr>
             <a:r>
-              <a:rPr sz="1100" b="1">
-                <a:solidFill>
-                  <a:srgbClr val="0F172A"/>
+              <a:rPr sz="1050" b="1">
+                <a:solidFill>
+                  <a:srgbClr val="0A2540"/>
                 </a:solidFill>
                 <a:latin typeface="Segoe UI"/>
               </a:rPr>
               <a:t>• Síntoma: </a:t>
             </a:r>
             <a:r>
-              <a:rPr sz="1050">
-                <a:solidFill>
-                  <a:srgbClr val="64748B"/>
+              <a:rPr sz="1000">
+                <a:solidFill>
+                  <a:srgbClr val="1E293B"/>
                 </a:solidFill>
                 <a:latin typeface="Segoe UI"/>
               </a:rPr>
-              <a:t>Micro-ausencias imprevistas frecuentes de 1 a 2 días adyacentes a fines de semana y descansos en soporte 24/7.</a:t>
+              <a:t>Micro-ausencias imprevistas frecuentes de 1 a 2 días adyacentes a fines de semana y descansos en soporte clínico 24/7.</a:t>
             </a:r>
           </a:p>
           <a:p>
@@ -4868,18 +5155,18 @@
               </a:spcAft>
             </a:pPr>
             <a:r>
-              <a:rPr sz="1100" b="1">
-                <a:solidFill>
-                  <a:srgbClr val="0F172A"/>
+              <a:rPr sz="1050" b="1">
+                <a:solidFill>
+                  <a:srgbClr val="0A2540"/>
                 </a:solidFill>
                 <a:latin typeface="Segoe UI"/>
               </a:rPr>
               <a:t>• Causa Raíz Revelada: </a:t>
             </a:r>
             <a:r>
-              <a:rPr sz="1050">
-                <a:solidFill>
-                  <a:srgbClr val="64748B"/>
+              <a:rPr sz="1000">
+                <a:solidFill>
+                  <a:srgbClr val="1E293B"/>
                 </a:solidFill>
                 <a:latin typeface="Segoe UI"/>
               </a:rPr>
@@ -4893,18 +5180,18 @@
               </a:spcAft>
             </a:pPr>
             <a:r>
-              <a:rPr sz="1100" b="1">
-                <a:solidFill>
-                  <a:srgbClr val="0F172A"/>
+              <a:rPr sz="1050" b="1">
+                <a:solidFill>
+                  <a:srgbClr val="0A2540"/>
                 </a:solidFill>
                 <a:latin typeface="Segoe UI"/>
               </a:rPr>
               <a:t>• Factor de Bradford: </a:t>
             </a:r>
             <a:r>
-              <a:rPr sz="1050">
-                <a:solidFill>
-                  <a:srgbClr val="64748B"/>
+              <a:rPr sz="1000">
+                <a:solidFill>
+                  <a:srgbClr val="1E293B"/>
                 </a:solidFill>
                 <a:latin typeface="Segoe UI"/>
               </a:rPr>
@@ -4918,18 +5205,18 @@
               </a:spcAft>
             </a:pPr>
             <a:r>
-              <a:rPr sz="1100" b="1">
-                <a:solidFill>
-                  <a:srgbClr val="0F172A"/>
+              <a:rPr sz="1050" b="1">
+                <a:solidFill>
+                  <a:srgbClr val="0A2540"/>
                 </a:solidFill>
                 <a:latin typeface="Segoe UI"/>
               </a:rPr>
               <a:t>• Consecuencia en P&amp;L: </a:t>
             </a:r>
             <a:r>
-              <a:rPr sz="1050">
-                <a:solidFill>
-                  <a:srgbClr val="64748B"/>
+              <a:rPr sz="1000">
+                <a:solidFill>
+                  <a:srgbClr val="1E293B"/>
                 </a:solidFill>
                 <a:latin typeface="Segoe UI"/>
               </a:rPr>
@@ -4971,7 +5258,7 @@
             <a:avLst/>
           </a:prstGeom>
           <a:solidFill>
-            <a:srgbClr val="F8FAFC"/>
+            <a:srgbClr val="FFFFFF"/>
           </a:solidFill>
           <a:ln>
             <a:noFill/>
@@ -5001,14 +5288,129 @@
       </p:sp>
       <p:sp>
         <p:nvSpPr>
-          <p:cNvPr id="3" name="TextBox 2"/>
+          <p:cNvPr id="3" name="Rectangle 2"/>
+          <p:cNvSpPr/>
+          <p:nvPr/>
+        </p:nvSpPr>
+        <p:spPr>
+          <a:xfrm>
+            <a:off x="731520" y="6263640"/>
+            <a:ext cx="10728655" cy="13716"/>
+          </a:xfrm>
+          <a:prstGeom prst="rect">
+            <a:avLst/>
+          </a:prstGeom>
+          <a:solidFill>
+            <a:srgbClr val="E2E8F0"/>
+          </a:solidFill>
+          <a:ln>
+            <a:noFill/>
+          </a:ln>
+        </p:spPr>
+        <p:style>
+          <a:lnRef idx="1">
+            <a:schemeClr val="accent1"/>
+          </a:lnRef>
+          <a:fillRef idx="3">
+            <a:schemeClr val="accent1"/>
+          </a:fillRef>
+          <a:effectRef idx="2">
+            <a:schemeClr val="accent1"/>
+          </a:effectRef>
+          <a:fontRef idx="minor">
+            <a:schemeClr val="lt1"/>
+          </a:fontRef>
+        </p:style>
+        <p:txBody>
+          <a:bodyPr rtlCol="0" anchor="ctr"/>
+          <a:lstStyle/>
+          <a:p>
+            <a:pPr algn="ctr"/>
+          </a:p>
+        </p:txBody>
+      </p:sp>
+      <p:sp>
+        <p:nvSpPr>
+          <p:cNvPr id="4" name="TextBox 3"/>
           <p:cNvSpPr txBox="1"/>
           <p:nvPr/>
         </p:nvSpPr>
         <p:spPr>
           <a:xfrm>
-            <a:off x="731520" y="365760"/>
-            <a:ext cx="10698480" cy="1005840"/>
+            <a:off x="731520" y="6327648"/>
+            <a:ext cx="7315200" cy="365760"/>
+          </a:xfrm>
+          <a:prstGeom prst="rect">
+            <a:avLst/>
+          </a:prstGeom>
+          <a:noFill/>
+        </p:spPr>
+        <p:txBody>
+          <a:bodyPr wrap="none" lIns="0" tIns="0" rIns="0" bIns="0">
+            <a:spAutoFit/>
+          </a:bodyPr>
+          <a:lstStyle/>
+          <a:p>
+            <a:pPr>
+              <a:defRPr sz="900">
+                <a:solidFill>
+                  <a:srgbClr val="64748B"/>
+                </a:solidFill>
+                <a:latin typeface="Segoe UI"/>
+              </a:defRPr>
+            </a:pPr>
+            <a:r>
+              <a:t>Workforce Dynamic Lens v1.0.0  •  MedTech Global Solutions  •  Executive Analytics Briefing</a:t>
+            </a:r>
+          </a:p>
+        </p:txBody>
+      </p:sp>
+      <p:sp>
+        <p:nvSpPr>
+          <p:cNvPr id="5" name="TextBox 4"/>
+          <p:cNvSpPr txBox="1"/>
+          <p:nvPr/>
+        </p:nvSpPr>
+        <p:spPr>
+          <a:xfrm>
+            <a:off x="9631375" y="6327648"/>
+            <a:ext cx="1828800" cy="365760"/>
+          </a:xfrm>
+          <a:prstGeom prst="rect">
+            <a:avLst/>
+          </a:prstGeom>
+          <a:noFill/>
+        </p:spPr>
+        <p:txBody>
+          <a:bodyPr wrap="none" lIns="0" tIns="0" rIns="0" bIns="0">
+            <a:spAutoFit/>
+          </a:bodyPr>
+          <a:lstStyle/>
+          <a:p>
+            <a:pPr algn="r">
+              <a:defRPr sz="900" b="1">
+                <a:solidFill>
+                  <a:srgbClr val="64748B"/>
+                </a:solidFill>
+                <a:latin typeface="Segoe UI"/>
+              </a:defRPr>
+            </a:pPr>
+            <a:r>
+              <a:t>04 / 09</a:t>
+            </a:r>
+          </a:p>
+        </p:txBody>
+      </p:sp>
+      <p:sp>
+        <p:nvSpPr>
+          <p:cNvPr id="6" name="TextBox 5"/>
+          <p:cNvSpPr txBox="1"/>
+          <p:nvPr/>
+        </p:nvSpPr>
+        <p:spPr>
+          <a:xfrm>
+            <a:off x="731520" y="384048"/>
+            <a:ext cx="10728655" cy="777240"/>
           </a:xfrm>
           <a:prstGeom prst="rect">
             <a:avLst/>
@@ -5022,22 +5424,25 @@
           <a:lstStyle/>
           <a:p>
             <a:pPr>
-              <a:defRPr sz="1000" b="1">
-                <a:solidFill>
-                  <a:srgbClr val="0284C7"/>
-                </a:solidFill>
-                <a:latin typeface="Segoe UI"/>
-              </a:defRPr>
-            </a:pPr>
-            <a:r>
-              <a:t>WORKFORCE DYNAMIC LENS | EXECUTIVE BRIEFING</a:t>
-            </a:r>
-          </a:p>
-          <a:p>
-            <a:pPr>
-              <a:defRPr sz="2200" b="1">
-                <a:solidFill>
-                  <a:srgbClr val="0F172A"/>
+              <a:spcAft>
+                <a:spcPts val="200"/>
+              </a:spcAft>
+              <a:defRPr sz="950" b="1">
+                <a:solidFill>
+                  <a:srgbClr val="1D4ED8"/>
+                </a:solidFill>
+                <a:latin typeface="Segoe UI"/>
+              </a:defRPr>
+            </a:pPr>
+            <a:r>
+              <a:t>MEDTECH GLOBAL SOLUTIONS  |  PEOPLE ANALYTICS</a:t>
+            </a:r>
+          </a:p>
+          <a:p>
+            <a:pPr>
+              <a:defRPr sz="2000" b="1">
+                <a:solidFill>
+                  <a:srgbClr val="0A2540"/>
                 </a:solidFill>
                 <a:latin typeface="Segoe UI"/>
               </a:defRPr>
@@ -5050,20 +5455,63 @@
       </p:sp>
       <p:sp>
         <p:nvSpPr>
-          <p:cNvPr id="4" name="Rounded Rectangle 3"/>
+          <p:cNvPr id="7" name="Rectangle 6"/>
           <p:cNvSpPr/>
           <p:nvPr/>
         </p:nvSpPr>
         <p:spPr>
           <a:xfrm>
+            <a:off x="731520" y="1234440"/>
+            <a:ext cx="10728655" cy="13716"/>
+          </a:xfrm>
+          <a:prstGeom prst="rect">
+            <a:avLst/>
+          </a:prstGeom>
+          <a:solidFill>
+            <a:srgbClr val="E2E8F0"/>
+          </a:solidFill>
+          <a:ln>
+            <a:noFill/>
+          </a:ln>
+        </p:spPr>
+        <p:style>
+          <a:lnRef idx="1">
+            <a:schemeClr val="accent1"/>
+          </a:lnRef>
+          <a:fillRef idx="3">
+            <a:schemeClr val="accent1"/>
+          </a:fillRef>
+          <a:effectRef idx="2">
+            <a:schemeClr val="accent1"/>
+          </a:effectRef>
+          <a:fontRef idx="minor">
+            <a:schemeClr val="lt1"/>
+          </a:fontRef>
+        </p:style>
+        <p:txBody>
+          <a:bodyPr rtlCol="0" anchor="ctr"/>
+          <a:lstStyle/>
+          <a:p>
+            <a:pPr algn="ctr"/>
+          </a:p>
+        </p:txBody>
+      </p:sp>
+      <p:sp>
+        <p:nvSpPr>
+          <p:cNvPr id="8" name="Rectangle 7"/>
+          <p:cNvSpPr/>
+          <p:nvPr/>
+        </p:nvSpPr>
+        <p:spPr>
+          <a:xfrm>
             <a:off x="731520" y="1463040"/>
-            <a:ext cx="3429000" cy="4846320"/>
-          </a:xfrm>
-          <a:prstGeom prst="roundRect">
+            <a:ext cx="3429000" cy="4572000"/>
+          </a:xfrm>
+          <a:prstGeom prst="rect">
             <a:avLst/>
           </a:prstGeom>
           <a:solidFill>
-            <a:srgbClr val="FFFFFF"/>
+            <a:srgbClr val="F8FAFC"/>
           </a:solidFill>
           <a:ln w="12700">
             <a:solidFill>
@@ -5095,14 +5543,14 @@
       </p:sp>
       <p:sp>
         <p:nvSpPr>
-          <p:cNvPr id="5" name="TextBox 4"/>
+          <p:cNvPr id="9" name="TextBox 8"/>
           <p:cNvSpPr txBox="1"/>
           <p:nvPr/>
         </p:nvSpPr>
         <p:spPr>
           <a:xfrm>
             <a:off x="914400" y="1691640"/>
-            <a:ext cx="3063240" cy="4389120"/>
+            <a:ext cx="3063240" cy="4114800"/>
           </a:xfrm>
           <a:prstGeom prst="rect">
             <a:avLst/>
@@ -5119,9 +5567,9 @@
               <a:spcAft>
                 <a:spcPts val="1200"/>
               </a:spcAft>
-              <a:defRPr sz="1200" b="1">
-                <a:solidFill>
-                  <a:srgbClr val="0284C7"/>
+              <a:defRPr sz="1150" b="1">
+                <a:solidFill>
+                  <a:srgbClr val="1D4ED8"/>
                 </a:solidFill>
                 <a:latin typeface="Segoe UI"/>
               </a:defRPr>
@@ -5137,18 +5585,18 @@
               </a:spcAft>
             </a:pPr>
             <a:r>
-              <a:rPr sz="1050" b="1">
-                <a:solidFill>
-                  <a:srgbClr val="0F172A"/>
+              <a:rPr sz="1000" b="1">
+                <a:solidFill>
+                  <a:srgbClr val="0A2540"/>
                 </a:solidFill>
                 <a:latin typeface="Segoe UI"/>
               </a:rPr>
               <a:t>• Motor:</a:t>
             </a:r>
             <a:r>
-              <a:rPr sz="1000">
-                <a:solidFill>
-                  <a:srgbClr val="64748B"/>
+              <a:rPr sz="950">
+                <a:solidFill>
+                  <a:srgbClr val="1E293B"/>
                 </a:solidFill>
                 <a:latin typeface="Segoe UI"/>
               </a:rPr>
@@ -5162,18 +5610,18 @@
               </a:spcAft>
             </a:pPr>
             <a:r>
-              <a:rPr sz="1050" b="1">
-                <a:solidFill>
-                  <a:srgbClr val="0F172A"/>
+              <a:rPr sz="1000" b="1">
+                <a:solidFill>
+                  <a:srgbClr val="0A2540"/>
                 </a:solidFill>
                 <a:latin typeface="Segoe UI"/>
               </a:rPr>
-              <a:t>• Dimensiones Conformadas:</a:t>
-            </a:r>
-            <a:r>
-              <a:rPr sz="1000">
-                <a:solidFill>
-                  <a:srgbClr val="64748B"/>
+              <a:t>• Dimensiones:</a:t>
+            </a:r>
+            <a:r>
+              <a:rPr sz="950">
+                <a:solidFill>
+                  <a:srgbClr val="1E293B"/>
                 </a:solidFill>
                 <a:latin typeface="Segoe UI"/>
               </a:rPr>
@@ -5187,18 +5635,18 @@
               </a:spcAft>
             </a:pPr>
             <a:r>
-              <a:rPr sz="1050" b="1">
-                <a:solidFill>
-                  <a:srgbClr val="0F172A"/>
+              <a:rPr sz="1000" b="1">
+                <a:solidFill>
+                  <a:srgbClr val="0A2540"/>
                 </a:solidFill>
                 <a:latin typeface="Segoe UI"/>
               </a:rPr>
               <a:t>• Tablas de Hechos:</a:t>
             </a:r>
             <a:r>
-              <a:rPr sz="1000">
-                <a:solidFill>
-                  <a:srgbClr val="64748B"/>
+              <a:rPr sz="950">
+                <a:solidFill>
+                  <a:srgbClr val="1E293B"/>
                 </a:solidFill>
                 <a:latin typeface="Segoe UI"/>
               </a:rPr>
@@ -5212,42 +5660,42 @@
               </a:spcAft>
             </a:pPr>
             <a:r>
-              <a:rPr sz="1050" b="1">
-                <a:solidFill>
-                  <a:srgbClr val="0F172A"/>
+              <a:rPr sz="1000" b="1">
+                <a:solidFill>
+                  <a:srgbClr val="0A2540"/>
                 </a:solidFill>
                 <a:latin typeface="Segoe UI"/>
               </a:rPr>
               <a:t>• Integridad:</a:t>
             </a:r>
             <a:r>
-              <a:rPr sz="1000">
-                <a:solidFill>
-                  <a:srgbClr val="64748B"/>
+              <a:rPr sz="950">
+                <a:solidFill>
+                  <a:srgbClr val="1E293B"/>
                 </a:solidFill>
                 <a:latin typeface="Segoe UI"/>
               </a:rPr>
-              <a:t> 0 registros huérfanos y 100% de consistencia relacional.</a:t>
-            </a:r>
-          </a:p>
-        </p:txBody>
-      </p:sp>
-      <p:sp>
-        <p:nvSpPr>
-          <p:cNvPr id="6" name="Rounded Rectangle 5"/>
+              <a:t> 0 registros huérfanos y 100% de consistencia relacional certificada en SQL.</a:t>
+            </a:r>
+          </a:p>
+        </p:txBody>
+      </p:sp>
+      <p:sp>
+        <p:nvSpPr>
+          <p:cNvPr id="10" name="Rectangle 9"/>
           <p:cNvSpPr/>
           <p:nvPr/>
         </p:nvSpPr>
         <p:spPr>
           <a:xfrm>
             <a:off x="4379976" y="1463040"/>
-            <a:ext cx="3429000" cy="4846320"/>
-          </a:xfrm>
-          <a:prstGeom prst="roundRect">
+            <a:ext cx="3429000" cy="4572000"/>
+          </a:xfrm>
+          <a:prstGeom prst="rect">
             <a:avLst/>
           </a:prstGeom>
           <a:solidFill>
-            <a:srgbClr val="FFFFFF"/>
+            <a:srgbClr val="F8FAFC"/>
           </a:solidFill>
           <a:ln w="12700">
             <a:solidFill>
@@ -5279,14 +5727,14 @@
       </p:sp>
       <p:sp>
         <p:nvSpPr>
-          <p:cNvPr id="7" name="TextBox 6"/>
+          <p:cNvPr id="11" name="TextBox 10"/>
           <p:cNvSpPr txBox="1"/>
           <p:nvPr/>
         </p:nvSpPr>
         <p:spPr>
           <a:xfrm>
             <a:off x="4562856" y="1691640"/>
-            <a:ext cx="3063240" cy="4389120"/>
+            <a:ext cx="3063240" cy="4114800"/>
           </a:xfrm>
           <a:prstGeom prst="rect">
             <a:avLst/>
@@ -5303,9 +5751,9 @@
               <a:spcAft>
                 <a:spcPts val="1200"/>
               </a:spcAft>
-              <a:defRPr sz="1200" b="1">
-                <a:solidFill>
-                  <a:srgbClr val="0284C7"/>
+              <a:defRPr sz="1150" b="1">
+                <a:solidFill>
+                  <a:srgbClr val="1D4ED8"/>
                 </a:solidFill>
                 <a:latin typeface="Segoe UI"/>
               </a:defRPr>
@@ -5321,18 +5769,18 @@
               </a:spcAft>
             </a:pPr>
             <a:r>
-              <a:rPr sz="1050" b="1">
-                <a:solidFill>
-                  <a:srgbClr val="0F172A"/>
+              <a:rPr sz="1000" b="1">
+                <a:solidFill>
+                  <a:srgbClr val="0A2540"/>
                 </a:solidFill>
                 <a:latin typeface="Segoe UI"/>
               </a:rPr>
               <a:t>• Vistas Maestras:</a:t>
             </a:r>
             <a:r>
-              <a:rPr sz="1000">
-                <a:solidFill>
-                  <a:srgbClr val="64748B"/>
+              <a:rPr sz="950">
+                <a:solidFill>
+                  <a:srgbClr val="1E293B"/>
                 </a:solidFill>
                 <a:latin typeface="Segoe UI"/>
               </a:rPr>
@@ -5346,22 +5794,22 @@
               </a:spcAft>
             </a:pPr>
             <a:r>
-              <a:rPr sz="1050" b="1">
-                <a:solidFill>
-                  <a:srgbClr val="0F172A"/>
+              <a:rPr sz="1000" b="1">
+                <a:solidFill>
+                  <a:srgbClr val="0A2540"/>
                 </a:solidFill>
                 <a:latin typeface="Segoe UI"/>
               </a:rPr>
               <a:t>• Cálculo Bradford Móvil:</a:t>
             </a:r>
             <a:r>
-              <a:rPr sz="1000">
-                <a:solidFill>
-                  <a:srgbClr val="64748B"/>
+              <a:rPr sz="950">
+                <a:solidFill>
+                  <a:srgbClr val="1E293B"/>
                 </a:solidFill>
                 <a:latin typeface="Segoe UI"/>
               </a:rPr>
-              <a:t> Ventana móvil de 12 meses (S^2 x D).</a:t>
+              <a:t> Ventana móvil de 12 meses (S^2 x D) para aislar micro-ausencias.</a:t>
             </a:r>
           </a:p>
           <a:p>
@@ -5371,22 +5819,22 @@
               </a:spcAft>
             </a:pPr>
             <a:r>
-              <a:rPr sz="1050" b="1">
-                <a:solidFill>
-                  <a:srgbClr val="0F172A"/>
+              <a:rPr sz="1000" b="1">
+                <a:solidFill>
+                  <a:srgbClr val="0A2540"/>
                 </a:solidFill>
                 <a:latin typeface="Segoe UI"/>
               </a:rPr>
               <a:t>• Reconciliación Histórica:</a:t>
             </a:r>
             <a:r>
-              <a:rPr sz="1000">
-                <a:solidFill>
-                  <a:srgbClr val="64748B"/>
+              <a:rPr sz="950">
+                <a:solidFill>
+                  <a:srgbClr val="1E293B"/>
                 </a:solidFill>
                 <a:latin typeface="Segoe UI"/>
               </a:rPr>
-              <a:t> Filtrado estricto is_current_row = TRUE para evitar duplicaciones en headcount.</a:t>
+              <a:t> Filtrado estricto is_current_row = TRUE para eliminar duplicaciones.</a:t>
             </a:r>
           </a:p>
           <a:p>
@@ -5396,18 +5844,18 @@
               </a:spcAft>
             </a:pPr>
             <a:r>
-              <a:rPr sz="1050" b="1">
-                <a:solidFill>
-                  <a:srgbClr val="0F172A"/>
+              <a:rPr sz="1000" b="1">
+                <a:solidFill>
+                  <a:srgbClr val="0A2540"/>
                 </a:solidFill>
                 <a:latin typeface="Segoe UI"/>
               </a:rPr>
               <a:t>• Scoring Multifactorial:</a:t>
             </a:r>
             <a:r>
-              <a:rPr sz="1000">
-                <a:solidFill>
-                  <a:srgbClr val="64748B"/>
+              <a:rPr sz="950">
+                <a:solidFill>
+                  <a:srgbClr val="1E293B"/>
                 </a:solidFill>
                 <a:latin typeface="Segoe UI"/>
               </a:rPr>
@@ -5418,20 +5866,20 @@
       </p:sp>
       <p:sp>
         <p:nvSpPr>
-          <p:cNvPr id="8" name="Rounded Rectangle 7"/>
+          <p:cNvPr id="12" name="Rectangle 11"/>
           <p:cNvSpPr/>
           <p:nvPr/>
         </p:nvSpPr>
         <p:spPr>
           <a:xfrm>
             <a:off x="8028432" y="1463040"/>
-            <a:ext cx="3429000" cy="4846320"/>
-          </a:xfrm>
-          <a:prstGeom prst="roundRect">
+            <a:ext cx="3429000" cy="4572000"/>
+          </a:xfrm>
+          <a:prstGeom prst="rect">
             <a:avLst/>
           </a:prstGeom>
           <a:solidFill>
-            <a:srgbClr val="FFFFFF"/>
+            <a:srgbClr val="F8FAFC"/>
           </a:solidFill>
           <a:ln w="12700">
             <a:solidFill>
@@ -5463,14 +5911,14 @@
       </p:sp>
       <p:sp>
         <p:nvSpPr>
-          <p:cNvPr id="9" name="TextBox 8"/>
+          <p:cNvPr id="13" name="TextBox 12"/>
           <p:cNvSpPr txBox="1"/>
           <p:nvPr/>
         </p:nvSpPr>
         <p:spPr>
           <a:xfrm>
             <a:off x="8211312" y="1691640"/>
-            <a:ext cx="3063240" cy="4389120"/>
+            <a:ext cx="3063240" cy="4114800"/>
           </a:xfrm>
           <a:prstGeom prst="rect">
             <a:avLst/>
@@ -5487,9 +5935,9 @@
               <a:spcAft>
                 <a:spcPts val="1200"/>
               </a:spcAft>
-              <a:defRPr sz="1200" b="1">
-                <a:solidFill>
-                  <a:srgbClr val="0284C7"/>
+              <a:defRPr sz="1150" b="1">
+                <a:solidFill>
+                  <a:srgbClr val="1D4ED8"/>
                 </a:solidFill>
                 <a:latin typeface="Segoe UI"/>
               </a:defRPr>
@@ -5503,9 +5951,9 @@
               <a:spcAft>
                 <a:spcPts val="800"/>
               </a:spcAft>
-              <a:defRPr sz="1000">
-                <a:solidFill>
-                  <a:srgbClr val="64748B"/>
+              <a:defRPr sz="950">
+                <a:solidFill>
+                  <a:srgbClr val="1E293B"/>
                 </a:solidFill>
                 <a:latin typeface="Segoe UI"/>
               </a:defRPr>
@@ -5519,9 +5967,9 @@
               <a:spcAft>
                 <a:spcPts val="800"/>
               </a:spcAft>
-              <a:defRPr sz="1000">
-                <a:solidFill>
-                  <a:srgbClr val="64748B"/>
+              <a:defRPr sz="950">
+                <a:solidFill>
+                  <a:srgbClr val="1E293B"/>
                 </a:solidFill>
                 <a:latin typeface="Segoe UI"/>
               </a:defRPr>
@@ -5535,9 +5983,9 @@
               <a:spcAft>
                 <a:spcPts val="800"/>
               </a:spcAft>
-              <a:defRPr sz="1000">
-                <a:solidFill>
-                  <a:srgbClr val="64748B"/>
+              <a:defRPr sz="950">
+                <a:solidFill>
+                  <a:srgbClr val="1E293B"/>
                 </a:solidFill>
                 <a:latin typeface="Segoe UI"/>
               </a:defRPr>
@@ -5551,15 +5999,15 @@
               <a:spcAft>
                 <a:spcPts val="800"/>
               </a:spcAft>
-              <a:defRPr sz="1000">
-                <a:solidFill>
-                  <a:srgbClr val="64748B"/>
-                </a:solidFill>
-                <a:latin typeface="Segoe UI"/>
-              </a:defRPr>
-            </a:pPr>
-            <a:r>
-              <a:t>• Visual Storytelling ejecutivo para toma de decisiones de C-Suite.</a:t>
+              <a:defRPr sz="950">
+                <a:solidFill>
+                  <a:srgbClr val="1E293B"/>
+                </a:solidFill>
+                <a:latin typeface="Segoe UI"/>
+              </a:defRPr>
+            </a:pPr>
+            <a:r>
+              <a:t>• Visual Storytelling ejecutivo diseñado para toma de decisiones directivas.</a:t>
             </a:r>
           </a:p>
         </p:txBody>
@@ -5597,7 +6045,7 @@
             <a:avLst/>
           </a:prstGeom>
           <a:solidFill>
-            <a:srgbClr val="F8FAFC"/>
+            <a:srgbClr val="FFFFFF"/>
           </a:solidFill>
           <a:ln>
             <a:noFill/>
@@ -5627,14 +6075,129 @@
       </p:sp>
       <p:sp>
         <p:nvSpPr>
-          <p:cNvPr id="3" name="TextBox 2"/>
+          <p:cNvPr id="3" name="Rectangle 2"/>
+          <p:cNvSpPr/>
+          <p:nvPr/>
+        </p:nvSpPr>
+        <p:spPr>
+          <a:xfrm>
+            <a:off x="731520" y="6263640"/>
+            <a:ext cx="10728655" cy="13716"/>
+          </a:xfrm>
+          <a:prstGeom prst="rect">
+            <a:avLst/>
+          </a:prstGeom>
+          <a:solidFill>
+            <a:srgbClr val="E2E8F0"/>
+          </a:solidFill>
+          <a:ln>
+            <a:noFill/>
+          </a:ln>
+        </p:spPr>
+        <p:style>
+          <a:lnRef idx="1">
+            <a:schemeClr val="accent1"/>
+          </a:lnRef>
+          <a:fillRef idx="3">
+            <a:schemeClr val="accent1"/>
+          </a:fillRef>
+          <a:effectRef idx="2">
+            <a:schemeClr val="accent1"/>
+          </a:effectRef>
+          <a:fontRef idx="minor">
+            <a:schemeClr val="lt1"/>
+          </a:fontRef>
+        </p:style>
+        <p:txBody>
+          <a:bodyPr rtlCol="0" anchor="ctr"/>
+          <a:lstStyle/>
+          <a:p>
+            <a:pPr algn="ctr"/>
+          </a:p>
+        </p:txBody>
+      </p:sp>
+      <p:sp>
+        <p:nvSpPr>
+          <p:cNvPr id="4" name="TextBox 3"/>
           <p:cNvSpPr txBox="1"/>
           <p:nvPr/>
         </p:nvSpPr>
         <p:spPr>
           <a:xfrm>
-            <a:off x="731520" y="365760"/>
-            <a:ext cx="10698480" cy="1005840"/>
+            <a:off x="731520" y="6327648"/>
+            <a:ext cx="7315200" cy="365760"/>
+          </a:xfrm>
+          <a:prstGeom prst="rect">
+            <a:avLst/>
+          </a:prstGeom>
+          <a:noFill/>
+        </p:spPr>
+        <p:txBody>
+          <a:bodyPr wrap="none" lIns="0" tIns="0" rIns="0" bIns="0">
+            <a:spAutoFit/>
+          </a:bodyPr>
+          <a:lstStyle/>
+          <a:p>
+            <a:pPr>
+              <a:defRPr sz="900">
+                <a:solidFill>
+                  <a:srgbClr val="64748B"/>
+                </a:solidFill>
+                <a:latin typeface="Segoe UI"/>
+              </a:defRPr>
+            </a:pPr>
+            <a:r>
+              <a:t>Workforce Dynamic Lens v1.0.0  •  MedTech Global Solutions  •  Executive Analytics Briefing</a:t>
+            </a:r>
+          </a:p>
+        </p:txBody>
+      </p:sp>
+      <p:sp>
+        <p:nvSpPr>
+          <p:cNvPr id="5" name="TextBox 4"/>
+          <p:cNvSpPr txBox="1"/>
+          <p:nvPr/>
+        </p:nvSpPr>
+        <p:spPr>
+          <a:xfrm>
+            <a:off x="9631375" y="6327648"/>
+            <a:ext cx="1828800" cy="365760"/>
+          </a:xfrm>
+          <a:prstGeom prst="rect">
+            <a:avLst/>
+          </a:prstGeom>
+          <a:noFill/>
+        </p:spPr>
+        <p:txBody>
+          <a:bodyPr wrap="none" lIns="0" tIns="0" rIns="0" bIns="0">
+            <a:spAutoFit/>
+          </a:bodyPr>
+          <a:lstStyle/>
+          <a:p>
+            <a:pPr algn="r">
+              <a:defRPr sz="900" b="1">
+                <a:solidFill>
+                  <a:srgbClr val="64748B"/>
+                </a:solidFill>
+                <a:latin typeface="Segoe UI"/>
+              </a:defRPr>
+            </a:pPr>
+            <a:r>
+              <a:t>05 / 09</a:t>
+            </a:r>
+          </a:p>
+        </p:txBody>
+      </p:sp>
+      <p:sp>
+        <p:nvSpPr>
+          <p:cNvPr id="6" name="TextBox 5"/>
+          <p:cNvSpPr txBox="1"/>
+          <p:nvPr/>
+        </p:nvSpPr>
+        <p:spPr>
+          <a:xfrm>
+            <a:off x="731520" y="384048"/>
+            <a:ext cx="10728655" cy="777240"/>
           </a:xfrm>
           <a:prstGeom prst="rect">
             <a:avLst/>
@@ -5648,22 +6211,25 @@
           <a:lstStyle/>
           <a:p>
             <a:pPr>
-              <a:defRPr sz="1000" b="1">
-                <a:solidFill>
-                  <a:srgbClr val="0284C7"/>
-                </a:solidFill>
-                <a:latin typeface="Segoe UI"/>
-              </a:defRPr>
-            </a:pPr>
-            <a:r>
-              <a:t>WORKFORCE DYNAMIC LENS | EXECUTIVE BRIEFING</a:t>
-            </a:r>
-          </a:p>
-          <a:p>
-            <a:pPr>
-              <a:defRPr sz="2200" b="1">
-                <a:solidFill>
-                  <a:srgbClr val="0F172A"/>
+              <a:spcAft>
+                <a:spcPts val="200"/>
+              </a:spcAft>
+              <a:defRPr sz="950" b="1">
+                <a:solidFill>
+                  <a:srgbClr val="1D4ED8"/>
+                </a:solidFill>
+                <a:latin typeface="Segoe UI"/>
+              </a:defRPr>
+            </a:pPr>
+            <a:r>
+              <a:t>MEDTECH GLOBAL SOLUTIONS  |  PEOPLE ANALYTICS</a:t>
+            </a:r>
+          </a:p>
+          <a:p>
+            <a:pPr>
+              <a:defRPr sz="2000" b="1">
+                <a:solidFill>
+                  <a:srgbClr val="0A2540"/>
                 </a:solidFill>
                 <a:latin typeface="Segoe UI"/>
               </a:defRPr>
@@ -5671,12 +6237,55 @@
             <a:r>
               <a:t>Dashboard 1: Executive HR Overview &amp; Demographics</a:t>
             </a:r>
+          </a:p>
+        </p:txBody>
+      </p:sp>
+      <p:sp>
+        <p:nvSpPr>
+          <p:cNvPr id="7" name="Rectangle 6"/>
+          <p:cNvSpPr/>
+          <p:nvPr/>
+        </p:nvSpPr>
+        <p:spPr>
+          <a:xfrm>
+            <a:off x="731520" y="1234440"/>
+            <a:ext cx="10728655" cy="13716"/>
+          </a:xfrm>
+          <a:prstGeom prst="rect">
+            <a:avLst/>
+          </a:prstGeom>
+          <a:solidFill>
+            <a:srgbClr val="E2E8F0"/>
+          </a:solidFill>
+          <a:ln>
+            <a:noFill/>
+          </a:ln>
+        </p:spPr>
+        <p:style>
+          <a:lnRef idx="1">
+            <a:schemeClr val="accent1"/>
+          </a:lnRef>
+          <a:fillRef idx="3">
+            <a:schemeClr val="accent1"/>
+          </a:fillRef>
+          <a:effectRef idx="2">
+            <a:schemeClr val="accent1"/>
+          </a:effectRef>
+          <a:fontRef idx="minor">
+            <a:schemeClr val="lt1"/>
+          </a:fontRef>
+        </p:style>
+        <p:txBody>
+          <a:bodyPr rtlCol="0" anchor="ctr"/>
+          <a:lstStyle/>
+          <a:p>
+            <a:pPr algn="ctr"/>
           </a:p>
         </p:txBody>
       </p:sp>
       <p:pic>
         <p:nvPicPr>
-          <p:cNvPr id="4" name="Picture 3" descr="dashboard_01_hr_overview.png"/>
+          <p:cNvPr id="8" name="Picture 7" descr="dashboard_01_hr_overview.png"/>
           <p:cNvPicPr>
             <a:picLocks noChangeAspect="1"/>
           </p:cNvPicPr>
@@ -5696,24 +6305,29 @@
           <a:prstGeom prst="rect">
             <a:avLst/>
           </a:prstGeom>
+          <a:ln w="12700">
+            <a:solidFill>
+              <a:srgbClr val="E2E8F0"/>
+            </a:solidFill>
+          </a:ln>
         </p:spPr>
       </p:pic>
       <p:sp>
         <p:nvSpPr>
-          <p:cNvPr id="5" name="Rounded Rectangle 4"/>
+          <p:cNvPr id="9" name="Rectangle 8"/>
           <p:cNvSpPr/>
           <p:nvPr/>
         </p:nvSpPr>
         <p:spPr>
           <a:xfrm>
             <a:off x="8046720" y="1463040"/>
-            <a:ext cx="3410712" cy="4846320"/>
-          </a:xfrm>
-          <a:prstGeom prst="roundRect">
+            <a:ext cx="3413455" cy="4572000"/>
+          </a:xfrm>
+          <a:prstGeom prst="rect">
             <a:avLst/>
           </a:prstGeom>
           <a:solidFill>
-            <a:srgbClr val="FFFFFF"/>
+            <a:srgbClr val="F8FAFC"/>
           </a:solidFill>
           <a:ln w="12700">
             <a:solidFill>
@@ -5745,14 +6359,14 @@
       </p:sp>
       <p:sp>
         <p:nvSpPr>
-          <p:cNvPr id="6" name="TextBox 5"/>
+          <p:cNvPr id="10" name="TextBox 9"/>
           <p:cNvSpPr txBox="1"/>
           <p:nvPr/>
         </p:nvSpPr>
         <p:spPr>
           <a:xfrm>
             <a:off x="8229600" y="1691640"/>
-            <a:ext cx="3044952" cy="4389120"/>
+            <a:ext cx="3047695" cy="4114800"/>
           </a:xfrm>
           <a:prstGeom prst="rect">
             <a:avLst/>
@@ -5769,9 +6383,9 @@
               <a:spcAft>
                 <a:spcPts val="1200"/>
               </a:spcAft>
-              <a:defRPr sz="1200" b="1">
-                <a:solidFill>
-                  <a:srgbClr val="0284C7"/>
+              <a:defRPr sz="1150" b="1">
+                <a:solidFill>
+                  <a:srgbClr val="1D4ED8"/>
                 </a:solidFill>
                 <a:latin typeface="Segoe UI"/>
               </a:defRPr>
@@ -5787,22 +6401,22 @@
               </a:spcAft>
             </a:pPr>
             <a:r>
-              <a:rPr sz="1050" b="1">
-                <a:solidFill>
-                  <a:srgbClr val="0F172A"/>
+              <a:rPr sz="1000" b="1">
+                <a:solidFill>
+                  <a:srgbClr val="0A2540"/>
                 </a:solidFill>
                 <a:latin typeface="Segoe UI"/>
               </a:rPr>
               <a:t>• Headcount Global: </a:t>
             </a:r>
             <a:r>
-              <a:rPr sz="1000">
-                <a:solidFill>
-                  <a:srgbClr val="64748B"/>
+              <a:rPr sz="950">
+                <a:solidFill>
+                  <a:srgbClr val="1E293B"/>
                 </a:solidFill>
                 <a:latin typeface="Segoe UI"/>
               </a:rPr>
-              <a:t>3,300 colaboradores activos distribuidos en México, Colombia, España, Brasil y Alemania.</a:t>
+              <a:t>3,300 colaboradores activos distribuidos en México (34%), Colombia (20%), España (16%), Brasil (15%) y Alemania (14%).</a:t>
             </a:r>
           </a:p>
           <a:p>
@@ -5812,22 +6426,22 @@
               </a:spcAft>
             </a:pPr>
             <a:r>
-              <a:rPr sz="1050" b="1">
-                <a:solidFill>
-                  <a:srgbClr val="0F172A"/>
+              <a:rPr sz="1000" b="1">
+                <a:solidFill>
+                  <a:srgbClr val="0A2540"/>
                 </a:solidFill>
                 <a:latin typeface="Segoe UI"/>
               </a:rPr>
               <a:t>• Distribución por Género: </a:t>
             </a:r>
             <a:r>
-              <a:rPr sz="1000">
-                <a:solidFill>
-                  <a:srgbClr val="64748B"/>
+              <a:rPr sz="950">
+                <a:solidFill>
+                  <a:srgbClr val="1E293B"/>
                 </a:solidFill>
                 <a:latin typeface="Segoe UI"/>
               </a:rPr>
-              <a:t>Equidad general balanceada (52% Mujeres / 48% Hombres), con brecha de representación en I+D.</a:t>
+              <a:t>Equidad general balanceada (52% Mujeres / 48% Hombres), con brecha de representación técnica en I+D.</a:t>
             </a:r>
           </a:p>
           <a:p>
@@ -5837,22 +6451,22 @@
               </a:spcAft>
             </a:pPr>
             <a:r>
-              <a:rPr sz="1050" b="1">
-                <a:solidFill>
-                  <a:srgbClr val="0F172A"/>
+              <a:rPr sz="1000" b="1">
+                <a:solidFill>
+                  <a:srgbClr val="0A2540"/>
                 </a:solidFill>
                 <a:latin typeface="Segoe UI"/>
               </a:rPr>
               <a:t>• Rotación Voluntaria: </a:t>
             </a:r>
             <a:r>
-              <a:rPr sz="1000">
-                <a:solidFill>
-                  <a:srgbClr val="64748B"/>
+              <a:rPr sz="950">
+                <a:solidFill>
+                  <a:srgbClr val="1E293B"/>
                 </a:solidFill>
                 <a:latin typeface="Segoe UI"/>
               </a:rPr>
-              <a:t>Tasa anualizada del 14.8%, concentrada atípicamente en el primer y segundo año de antigüedad.</a:t>
+              <a:t>Tasa anualizada del 14.8%, concentrada atípicamente en el primer y segundo año de antigüedad laboral.</a:t>
             </a:r>
           </a:p>
           <a:p>
@@ -5862,18 +6476,18 @@
               </a:spcAft>
             </a:pPr>
             <a:r>
-              <a:rPr sz="1050" b="1">
-                <a:solidFill>
-                  <a:srgbClr val="0F172A"/>
+              <a:rPr sz="1000" b="1">
+                <a:solidFill>
+                  <a:srgbClr val="0A2540"/>
                 </a:solidFill>
                 <a:latin typeface="Segoe UI"/>
               </a:rPr>
-              <a:t>• Costo de Masa Salarial: </a:t>
-            </a:r>
-            <a:r>
-              <a:rPr sz="1000">
-                <a:solidFill>
-                  <a:srgbClr val="64748B"/>
+              <a:t>• Masa Salarial: </a:t>
+            </a:r>
+            <a:r>
+              <a:rPr sz="950">
+                <a:solidFill>
+                  <a:srgbClr val="1E293B"/>
                 </a:solidFill>
                 <a:latin typeface="Segoe UI"/>
               </a:rPr>
@@ -5915,7 +6529,7 @@
             <a:avLst/>
           </a:prstGeom>
           <a:solidFill>
-            <a:srgbClr val="F8FAFC"/>
+            <a:srgbClr val="FFFFFF"/>
           </a:solidFill>
           <a:ln>
             <a:noFill/>
@@ -5945,14 +6559,129 @@
       </p:sp>
       <p:sp>
         <p:nvSpPr>
-          <p:cNvPr id="3" name="TextBox 2"/>
+          <p:cNvPr id="3" name="Rectangle 2"/>
+          <p:cNvSpPr/>
+          <p:nvPr/>
+        </p:nvSpPr>
+        <p:spPr>
+          <a:xfrm>
+            <a:off x="731520" y="6263640"/>
+            <a:ext cx="10728655" cy="13716"/>
+          </a:xfrm>
+          <a:prstGeom prst="rect">
+            <a:avLst/>
+          </a:prstGeom>
+          <a:solidFill>
+            <a:srgbClr val="E2E8F0"/>
+          </a:solidFill>
+          <a:ln>
+            <a:noFill/>
+          </a:ln>
+        </p:spPr>
+        <p:style>
+          <a:lnRef idx="1">
+            <a:schemeClr val="accent1"/>
+          </a:lnRef>
+          <a:fillRef idx="3">
+            <a:schemeClr val="accent1"/>
+          </a:fillRef>
+          <a:effectRef idx="2">
+            <a:schemeClr val="accent1"/>
+          </a:effectRef>
+          <a:fontRef idx="minor">
+            <a:schemeClr val="lt1"/>
+          </a:fontRef>
+        </p:style>
+        <p:txBody>
+          <a:bodyPr rtlCol="0" anchor="ctr"/>
+          <a:lstStyle/>
+          <a:p>
+            <a:pPr algn="ctr"/>
+          </a:p>
+        </p:txBody>
+      </p:sp>
+      <p:sp>
+        <p:nvSpPr>
+          <p:cNvPr id="4" name="TextBox 3"/>
           <p:cNvSpPr txBox="1"/>
           <p:nvPr/>
         </p:nvSpPr>
         <p:spPr>
           <a:xfrm>
-            <a:off x="731520" y="365760"/>
-            <a:ext cx="10698480" cy="1005840"/>
+            <a:off x="731520" y="6327648"/>
+            <a:ext cx="7315200" cy="365760"/>
+          </a:xfrm>
+          <a:prstGeom prst="rect">
+            <a:avLst/>
+          </a:prstGeom>
+          <a:noFill/>
+        </p:spPr>
+        <p:txBody>
+          <a:bodyPr wrap="none" lIns="0" tIns="0" rIns="0" bIns="0">
+            <a:spAutoFit/>
+          </a:bodyPr>
+          <a:lstStyle/>
+          <a:p>
+            <a:pPr>
+              <a:defRPr sz="900">
+                <a:solidFill>
+                  <a:srgbClr val="64748B"/>
+                </a:solidFill>
+                <a:latin typeface="Segoe UI"/>
+              </a:defRPr>
+            </a:pPr>
+            <a:r>
+              <a:t>Workforce Dynamic Lens v1.0.0  •  MedTech Global Solutions  •  Executive Analytics Briefing</a:t>
+            </a:r>
+          </a:p>
+        </p:txBody>
+      </p:sp>
+      <p:sp>
+        <p:nvSpPr>
+          <p:cNvPr id="5" name="TextBox 4"/>
+          <p:cNvSpPr txBox="1"/>
+          <p:nvPr/>
+        </p:nvSpPr>
+        <p:spPr>
+          <a:xfrm>
+            <a:off x="9631375" y="6327648"/>
+            <a:ext cx="1828800" cy="365760"/>
+          </a:xfrm>
+          <a:prstGeom prst="rect">
+            <a:avLst/>
+          </a:prstGeom>
+          <a:noFill/>
+        </p:spPr>
+        <p:txBody>
+          <a:bodyPr wrap="none" lIns="0" tIns="0" rIns="0" bIns="0">
+            <a:spAutoFit/>
+          </a:bodyPr>
+          <a:lstStyle/>
+          <a:p>
+            <a:pPr algn="r">
+              <a:defRPr sz="900" b="1">
+                <a:solidFill>
+                  <a:srgbClr val="64748B"/>
+                </a:solidFill>
+                <a:latin typeface="Segoe UI"/>
+              </a:defRPr>
+            </a:pPr>
+            <a:r>
+              <a:t>06 / 09</a:t>
+            </a:r>
+          </a:p>
+        </p:txBody>
+      </p:sp>
+      <p:sp>
+        <p:nvSpPr>
+          <p:cNvPr id="6" name="TextBox 5"/>
+          <p:cNvSpPr txBox="1"/>
+          <p:nvPr/>
+        </p:nvSpPr>
+        <p:spPr>
+          <a:xfrm>
+            <a:off x="731520" y="384048"/>
+            <a:ext cx="10728655" cy="777240"/>
           </a:xfrm>
           <a:prstGeom prst="rect">
             <a:avLst/>
@@ -5966,22 +6695,25 @@
           <a:lstStyle/>
           <a:p>
             <a:pPr>
-              <a:defRPr sz="1000" b="1">
-                <a:solidFill>
-                  <a:srgbClr val="0284C7"/>
-                </a:solidFill>
-                <a:latin typeface="Segoe UI"/>
-              </a:defRPr>
-            </a:pPr>
-            <a:r>
-              <a:t>WORKFORCE DYNAMIC LENS | EXECUTIVE BRIEFING</a:t>
-            </a:r>
-          </a:p>
-          <a:p>
-            <a:pPr>
-              <a:defRPr sz="2200" b="1">
-                <a:solidFill>
-                  <a:srgbClr val="0F172A"/>
+              <a:spcAft>
+                <a:spcPts val="200"/>
+              </a:spcAft>
+              <a:defRPr sz="950" b="1">
+                <a:solidFill>
+                  <a:srgbClr val="1D4ED8"/>
+                </a:solidFill>
+                <a:latin typeface="Segoe UI"/>
+              </a:defRPr>
+            </a:pPr>
+            <a:r>
+              <a:t>MEDTECH GLOBAL SOLUTIONS  |  PEOPLE ANALYTICS</a:t>
+            </a:r>
+          </a:p>
+          <a:p>
+            <a:pPr>
+              <a:defRPr sz="2000" b="1">
+                <a:solidFill>
+                  <a:srgbClr val="0A2540"/>
                 </a:solidFill>
                 <a:latin typeface="Segoe UI"/>
               </a:defRPr>
@@ -5989,12 +6721,55 @@
             <a:r>
               <a:t>Dashboard 2: Absenteeism Diagnostic &amp; SLA Impact</a:t>
             </a:r>
+          </a:p>
+        </p:txBody>
+      </p:sp>
+      <p:sp>
+        <p:nvSpPr>
+          <p:cNvPr id="7" name="Rectangle 6"/>
+          <p:cNvSpPr/>
+          <p:nvPr/>
+        </p:nvSpPr>
+        <p:spPr>
+          <a:xfrm>
+            <a:off x="731520" y="1234440"/>
+            <a:ext cx="10728655" cy="13716"/>
+          </a:xfrm>
+          <a:prstGeom prst="rect">
+            <a:avLst/>
+          </a:prstGeom>
+          <a:solidFill>
+            <a:srgbClr val="E2E8F0"/>
+          </a:solidFill>
+          <a:ln>
+            <a:noFill/>
+          </a:ln>
+        </p:spPr>
+        <p:style>
+          <a:lnRef idx="1">
+            <a:schemeClr val="accent1"/>
+          </a:lnRef>
+          <a:fillRef idx="3">
+            <a:schemeClr val="accent1"/>
+          </a:fillRef>
+          <a:effectRef idx="2">
+            <a:schemeClr val="accent1"/>
+          </a:effectRef>
+          <a:fontRef idx="minor">
+            <a:schemeClr val="lt1"/>
+          </a:fontRef>
+        </p:style>
+        <p:txBody>
+          <a:bodyPr rtlCol="0" anchor="ctr"/>
+          <a:lstStyle/>
+          <a:p>
+            <a:pPr algn="ctr"/>
           </a:p>
         </p:txBody>
       </p:sp>
       <p:pic>
         <p:nvPicPr>
-          <p:cNvPr id="4" name="Picture 3" descr="dashboard_02_absenteeism_diagnostic.png"/>
+          <p:cNvPr id="8" name="Picture 7" descr="dashboard_02_absenteeism_diagnostic.png"/>
           <p:cNvPicPr>
             <a:picLocks noChangeAspect="1"/>
           </p:cNvPicPr>
@@ -6014,24 +6789,29 @@
           <a:prstGeom prst="rect">
             <a:avLst/>
           </a:prstGeom>
+          <a:ln w="12700">
+            <a:solidFill>
+              <a:srgbClr val="E2E8F0"/>
+            </a:solidFill>
+          </a:ln>
         </p:spPr>
       </p:pic>
       <p:sp>
         <p:nvSpPr>
-          <p:cNvPr id="5" name="Rounded Rectangle 4"/>
+          <p:cNvPr id="9" name="Rectangle 8"/>
           <p:cNvSpPr/>
           <p:nvPr/>
         </p:nvSpPr>
         <p:spPr>
           <a:xfrm>
             <a:off x="8046720" y="1463040"/>
-            <a:ext cx="3410712" cy="4846320"/>
-          </a:xfrm>
-          <a:prstGeom prst="roundRect">
+            <a:ext cx="3413455" cy="4572000"/>
+          </a:xfrm>
+          <a:prstGeom prst="rect">
             <a:avLst/>
           </a:prstGeom>
           <a:solidFill>
-            <a:srgbClr val="FFFFFF"/>
+            <a:srgbClr val="F8FAFC"/>
           </a:solidFill>
           <a:ln w="12700">
             <a:solidFill>
@@ -6063,14 +6843,14 @@
       </p:sp>
       <p:sp>
         <p:nvSpPr>
-          <p:cNvPr id="6" name="TextBox 5"/>
+          <p:cNvPr id="10" name="TextBox 9"/>
           <p:cNvSpPr txBox="1"/>
           <p:nvPr/>
         </p:nvSpPr>
         <p:spPr>
           <a:xfrm>
             <a:off x="8229600" y="1691640"/>
-            <a:ext cx="3044952" cy="4389120"/>
+            <a:ext cx="3047695" cy="4114800"/>
           </a:xfrm>
           <a:prstGeom prst="rect">
             <a:avLst/>
@@ -6087,9 +6867,9 @@
               <a:spcAft>
                 <a:spcPts val="1200"/>
               </a:spcAft>
-              <a:defRPr sz="1200" b="1">
-                <a:solidFill>
-                  <a:srgbClr val="0284C7"/>
+              <a:defRPr sz="1150" b="1">
+                <a:solidFill>
+                  <a:srgbClr val="1D4ED8"/>
                 </a:solidFill>
                 <a:latin typeface="Segoe UI"/>
               </a:defRPr>
@@ -6105,18 +6885,18 @@
               </a:spcAft>
             </a:pPr>
             <a:r>
-              <a:rPr sz="1050" b="1">
-                <a:solidFill>
-                  <a:srgbClr val="0F172A"/>
+              <a:rPr sz="1000" b="1">
+                <a:solidFill>
+                  <a:srgbClr val="0A2540"/>
                 </a:solidFill>
                 <a:latin typeface="Segoe UI"/>
               </a:rPr>
               <a:t>• Factor de Bradford: </a:t>
             </a:r>
             <a:r>
-              <a:rPr sz="1000">
-                <a:solidFill>
-                  <a:srgbClr val="64748B"/>
+              <a:rPr sz="950">
+                <a:solidFill>
+                  <a:srgbClr val="1E293B"/>
                 </a:solidFill>
                 <a:latin typeface="Segoe UI"/>
               </a:rPr>
@@ -6130,18 +6910,18 @@
               </a:spcAft>
             </a:pPr>
             <a:r>
-              <a:rPr sz="1050" b="1">
-                <a:solidFill>
-                  <a:srgbClr val="0F172A"/>
+              <a:rPr sz="1000" b="1">
+                <a:solidFill>
+                  <a:srgbClr val="0A2540"/>
                 </a:solidFill>
                 <a:latin typeface="Segoe UI"/>
               </a:rPr>
               <a:t>• Sobrecarga Horaria: </a:t>
             </a:r>
             <a:r>
-              <a:rPr sz="1000">
-                <a:solidFill>
-                  <a:srgbClr val="64748B"/>
+              <a:rPr sz="950">
+                <a:solidFill>
+                  <a:srgbClr val="1E293B"/>
                 </a:solidFill>
                 <a:latin typeface="Segoe UI"/>
               </a:rPr>
@@ -6155,18 +6935,18 @@
               </a:spcAft>
             </a:pPr>
             <a:r>
-              <a:rPr sz="1050" b="1">
-                <a:solidFill>
-                  <a:srgbClr val="0F172A"/>
+              <a:rPr sz="1000" b="1">
+                <a:solidFill>
+                  <a:srgbClr val="0A2540"/>
                 </a:solidFill>
                 <a:latin typeface="Segoe UI"/>
               </a:rPr>
               <a:t>• Penalizaciones Hospitalarias: </a:t>
             </a:r>
             <a:r>
-              <a:rPr sz="1000">
-                <a:solidFill>
-                  <a:srgbClr val="64748B"/>
+              <a:rPr sz="950">
+                <a:solidFill>
+                  <a:srgbClr val="1E293B"/>
                 </a:solidFill>
                 <a:latin typeface="Segoe UI"/>
               </a:rPr>
@@ -6180,18 +6960,18 @@
               </a:spcAft>
             </a:pPr>
             <a:r>
-              <a:rPr sz="1050" b="1">
-                <a:solidFill>
-                  <a:srgbClr val="0F172A"/>
+              <a:rPr sz="1000" b="1">
+                <a:solidFill>
+                  <a:srgbClr val="0A2540"/>
                 </a:solidFill>
                 <a:latin typeface="Segoe UI"/>
               </a:rPr>
               <a:t>• Acción Operativa: </a:t>
             </a:r>
             <a:r>
-              <a:rPr sz="1000">
-                <a:solidFill>
-                  <a:srgbClr val="64748B"/>
+              <a:rPr sz="950">
+                <a:solidFill>
+                  <a:srgbClr val="1E293B"/>
                 </a:solidFill>
                 <a:latin typeface="Segoe UI"/>
               </a:rPr>
@@ -6233,7 +7013,7 @@
             <a:avLst/>
           </a:prstGeom>
           <a:solidFill>
-            <a:srgbClr val="F8FAFC"/>
+            <a:srgbClr val="FFFFFF"/>
           </a:solidFill>
           <a:ln>
             <a:noFill/>
@@ -6263,14 +7043,129 @@
       </p:sp>
       <p:sp>
         <p:nvSpPr>
-          <p:cNvPr id="3" name="TextBox 2"/>
+          <p:cNvPr id="3" name="Rectangle 2"/>
+          <p:cNvSpPr/>
+          <p:nvPr/>
+        </p:nvSpPr>
+        <p:spPr>
+          <a:xfrm>
+            <a:off x="731520" y="6263640"/>
+            <a:ext cx="10728655" cy="13716"/>
+          </a:xfrm>
+          <a:prstGeom prst="rect">
+            <a:avLst/>
+          </a:prstGeom>
+          <a:solidFill>
+            <a:srgbClr val="E2E8F0"/>
+          </a:solidFill>
+          <a:ln>
+            <a:noFill/>
+          </a:ln>
+        </p:spPr>
+        <p:style>
+          <a:lnRef idx="1">
+            <a:schemeClr val="accent1"/>
+          </a:lnRef>
+          <a:fillRef idx="3">
+            <a:schemeClr val="accent1"/>
+          </a:fillRef>
+          <a:effectRef idx="2">
+            <a:schemeClr val="accent1"/>
+          </a:effectRef>
+          <a:fontRef idx="minor">
+            <a:schemeClr val="lt1"/>
+          </a:fontRef>
+        </p:style>
+        <p:txBody>
+          <a:bodyPr rtlCol="0" anchor="ctr"/>
+          <a:lstStyle/>
+          <a:p>
+            <a:pPr algn="ctr"/>
+          </a:p>
+        </p:txBody>
+      </p:sp>
+      <p:sp>
+        <p:nvSpPr>
+          <p:cNvPr id="4" name="TextBox 3"/>
           <p:cNvSpPr txBox="1"/>
           <p:nvPr/>
         </p:nvSpPr>
         <p:spPr>
           <a:xfrm>
-            <a:off x="731520" y="365760"/>
-            <a:ext cx="10698480" cy="1005840"/>
+            <a:off x="731520" y="6327648"/>
+            <a:ext cx="7315200" cy="365760"/>
+          </a:xfrm>
+          <a:prstGeom prst="rect">
+            <a:avLst/>
+          </a:prstGeom>
+          <a:noFill/>
+        </p:spPr>
+        <p:txBody>
+          <a:bodyPr wrap="none" lIns="0" tIns="0" rIns="0" bIns="0">
+            <a:spAutoFit/>
+          </a:bodyPr>
+          <a:lstStyle/>
+          <a:p>
+            <a:pPr>
+              <a:defRPr sz="900">
+                <a:solidFill>
+                  <a:srgbClr val="64748B"/>
+                </a:solidFill>
+                <a:latin typeface="Segoe UI"/>
+              </a:defRPr>
+            </a:pPr>
+            <a:r>
+              <a:t>Workforce Dynamic Lens v1.0.0  •  MedTech Global Solutions  •  Executive Analytics Briefing</a:t>
+            </a:r>
+          </a:p>
+        </p:txBody>
+      </p:sp>
+      <p:sp>
+        <p:nvSpPr>
+          <p:cNvPr id="5" name="TextBox 4"/>
+          <p:cNvSpPr txBox="1"/>
+          <p:nvPr/>
+        </p:nvSpPr>
+        <p:spPr>
+          <a:xfrm>
+            <a:off x="9631375" y="6327648"/>
+            <a:ext cx="1828800" cy="365760"/>
+          </a:xfrm>
+          <a:prstGeom prst="rect">
+            <a:avLst/>
+          </a:prstGeom>
+          <a:noFill/>
+        </p:spPr>
+        <p:txBody>
+          <a:bodyPr wrap="none" lIns="0" tIns="0" rIns="0" bIns="0">
+            <a:spAutoFit/>
+          </a:bodyPr>
+          <a:lstStyle/>
+          <a:p>
+            <a:pPr algn="r">
+              <a:defRPr sz="900" b="1">
+                <a:solidFill>
+                  <a:srgbClr val="64748B"/>
+                </a:solidFill>
+                <a:latin typeface="Segoe UI"/>
+              </a:defRPr>
+            </a:pPr>
+            <a:r>
+              <a:t>07 / 09</a:t>
+            </a:r>
+          </a:p>
+        </p:txBody>
+      </p:sp>
+      <p:sp>
+        <p:nvSpPr>
+          <p:cNvPr id="6" name="TextBox 5"/>
+          <p:cNvSpPr txBox="1"/>
+          <p:nvPr/>
+        </p:nvSpPr>
+        <p:spPr>
+          <a:xfrm>
+            <a:off x="731520" y="384048"/>
+            <a:ext cx="10728655" cy="777240"/>
           </a:xfrm>
           <a:prstGeom prst="rect">
             <a:avLst/>
@@ -6284,22 +7179,25 @@
           <a:lstStyle/>
           <a:p>
             <a:pPr>
-              <a:defRPr sz="1000" b="1">
-                <a:solidFill>
-                  <a:srgbClr val="0284C7"/>
-                </a:solidFill>
-                <a:latin typeface="Segoe UI"/>
-              </a:defRPr>
-            </a:pPr>
-            <a:r>
-              <a:t>WORKFORCE DYNAMIC LENS | EXECUTIVE BRIEFING</a:t>
-            </a:r>
-          </a:p>
-          <a:p>
-            <a:pPr>
-              <a:defRPr sz="2200" b="1">
-                <a:solidFill>
-                  <a:srgbClr val="0F172A"/>
+              <a:spcAft>
+                <a:spcPts val="200"/>
+              </a:spcAft>
+              <a:defRPr sz="950" b="1">
+                <a:solidFill>
+                  <a:srgbClr val="1D4ED8"/>
+                </a:solidFill>
+                <a:latin typeface="Segoe UI"/>
+              </a:defRPr>
+            </a:pPr>
+            <a:r>
+              <a:t>MEDTECH GLOBAL SOLUTIONS  |  PEOPLE ANALYTICS</a:t>
+            </a:r>
+          </a:p>
+          <a:p>
+            <a:pPr>
+              <a:defRPr sz="2000" b="1">
+                <a:solidFill>
+                  <a:srgbClr val="0A2540"/>
                 </a:solidFill>
                 <a:latin typeface="Segoe UI"/>
               </a:defRPr>
@@ -6307,12 +7205,55 @@
             <a:r>
               <a:t>Dashboard 3: Workforce Risk &amp; Retention Action Center</a:t>
             </a:r>
+          </a:p>
+        </p:txBody>
+      </p:sp>
+      <p:sp>
+        <p:nvSpPr>
+          <p:cNvPr id="7" name="Rectangle 6"/>
+          <p:cNvSpPr/>
+          <p:nvPr/>
+        </p:nvSpPr>
+        <p:spPr>
+          <a:xfrm>
+            <a:off x="731520" y="1234440"/>
+            <a:ext cx="10728655" cy="13716"/>
+          </a:xfrm>
+          <a:prstGeom prst="rect">
+            <a:avLst/>
+          </a:prstGeom>
+          <a:solidFill>
+            <a:srgbClr val="E2E8F0"/>
+          </a:solidFill>
+          <a:ln>
+            <a:noFill/>
+          </a:ln>
+        </p:spPr>
+        <p:style>
+          <a:lnRef idx="1">
+            <a:schemeClr val="accent1"/>
+          </a:lnRef>
+          <a:fillRef idx="3">
+            <a:schemeClr val="accent1"/>
+          </a:fillRef>
+          <a:effectRef idx="2">
+            <a:schemeClr val="accent1"/>
+          </a:effectRef>
+          <a:fontRef idx="minor">
+            <a:schemeClr val="lt1"/>
+          </a:fontRef>
+        </p:style>
+        <p:txBody>
+          <a:bodyPr rtlCol="0" anchor="ctr"/>
+          <a:lstStyle/>
+          <a:p>
+            <a:pPr algn="ctr"/>
           </a:p>
         </p:txBody>
       </p:sp>
       <p:pic>
         <p:nvPicPr>
-          <p:cNvPr id="4" name="Picture 3" descr="dashboard_03_workforce_risk.png"/>
+          <p:cNvPr id="8" name="Picture 7" descr="dashboard_03_workforce_risk.png"/>
           <p:cNvPicPr>
             <a:picLocks noChangeAspect="1"/>
           </p:cNvPicPr>
@@ -6332,24 +7273,29 @@
           <a:prstGeom prst="rect">
             <a:avLst/>
           </a:prstGeom>
+          <a:ln w="12700">
+            <a:solidFill>
+              <a:srgbClr val="E2E8F0"/>
+            </a:solidFill>
+          </a:ln>
         </p:spPr>
       </p:pic>
       <p:sp>
         <p:nvSpPr>
-          <p:cNvPr id="5" name="Rounded Rectangle 4"/>
+          <p:cNvPr id="9" name="Rectangle 8"/>
           <p:cNvSpPr/>
           <p:nvPr/>
         </p:nvSpPr>
         <p:spPr>
           <a:xfrm>
             <a:off x="8046720" y="1463040"/>
-            <a:ext cx="3410712" cy="4846320"/>
-          </a:xfrm>
-          <a:prstGeom prst="roundRect">
+            <a:ext cx="3413455" cy="4572000"/>
+          </a:xfrm>
+          <a:prstGeom prst="rect">
             <a:avLst/>
           </a:prstGeom>
           <a:solidFill>
-            <a:srgbClr val="FFFFFF"/>
+            <a:srgbClr val="F8FAFC"/>
           </a:solidFill>
           <a:ln w="12700">
             <a:solidFill>
@@ -6381,14 +7327,14 @@
       </p:sp>
       <p:sp>
         <p:nvSpPr>
-          <p:cNvPr id="6" name="TextBox 5"/>
+          <p:cNvPr id="10" name="TextBox 9"/>
           <p:cNvSpPr txBox="1"/>
           <p:nvPr/>
         </p:nvSpPr>
         <p:spPr>
           <a:xfrm>
             <a:off x="8229600" y="1691640"/>
-            <a:ext cx="3044952" cy="4389120"/>
+            <a:ext cx="3047695" cy="4114800"/>
           </a:xfrm>
           <a:prstGeom prst="rect">
             <a:avLst/>
@@ -6405,9 +7351,9 @@
               <a:spcAft>
                 <a:spcPts val="1200"/>
               </a:spcAft>
-              <a:defRPr sz="1200" b="1">
-                <a:solidFill>
-                  <a:srgbClr val="0284C7"/>
+              <a:defRPr sz="1150" b="1">
+                <a:solidFill>
+                  <a:srgbClr val="1D4ED8"/>
                 </a:solidFill>
                 <a:latin typeface="Segoe UI"/>
               </a:defRPr>
@@ -6423,18 +7369,18 @@
               </a:spcAft>
             </a:pPr>
             <a:r>
-              <a:rPr sz="1050" b="1">
-                <a:solidFill>
-                  <a:srgbClr val="0F172A"/>
+              <a:rPr sz="1000" b="1">
+                <a:solidFill>
+                  <a:srgbClr val="0A2540"/>
                 </a:solidFill>
                 <a:latin typeface="Segoe UI"/>
               </a:rPr>
               <a:t>• Matriz de Desempeño vs. Fuga: </a:t>
             </a:r>
             <a:r>
-              <a:rPr sz="1000">
-                <a:solidFill>
-                  <a:srgbClr val="64748B"/>
+              <a:rPr sz="950">
+                <a:solidFill>
+                  <a:srgbClr val="1E293B"/>
                 </a:solidFill>
                 <a:latin typeface="Segoe UI"/>
               </a:rPr>
@@ -6448,18 +7394,18 @@
               </a:spcAft>
             </a:pPr>
             <a:r>
-              <a:rPr sz="1050" b="1">
-                <a:solidFill>
-                  <a:srgbClr val="0F172A"/>
+              <a:rPr sz="1000" b="1">
+                <a:solidFill>
+                  <a:srgbClr val="0A2540"/>
                 </a:solidFill>
                 <a:latin typeface="Segoe UI"/>
               </a:rPr>
               <a:t>• Diagnóstico de Compa-Ratio: </a:t>
             </a:r>
             <a:r>
-              <a:rPr sz="1000">
-                <a:solidFill>
-                  <a:srgbClr val="64748B"/>
+              <a:rPr sz="950">
+                <a:solidFill>
+                  <a:srgbClr val="1E293B"/>
                 </a:solidFill>
                 <a:latin typeface="Segoe UI"/>
               </a:rPr>
@@ -6473,18 +7419,18 @@
               </a:spcAft>
             </a:pPr>
             <a:r>
-              <a:rPr sz="1050" b="1">
-                <a:solidFill>
-                  <a:srgbClr val="0F172A"/>
+              <a:rPr sz="1000" b="1">
+                <a:solidFill>
+                  <a:srgbClr val="0A2540"/>
                 </a:solidFill>
                 <a:latin typeface="Segoe UI"/>
               </a:rPr>
               <a:t>• Simulador Financiero What-If: </a:t>
             </a:r>
             <a:r>
-              <a:rPr sz="1000">
-                <a:solidFill>
-                  <a:srgbClr val="64748B"/>
+              <a:rPr sz="950">
+                <a:solidFill>
+                  <a:srgbClr val="1E293B"/>
                 </a:solidFill>
                 <a:latin typeface="Segoe UI"/>
               </a:rPr>
@@ -6498,18 +7444,18 @@
               </a:spcAft>
             </a:pPr>
             <a:r>
-              <a:rPr sz="1050" b="1">
-                <a:solidFill>
-                  <a:srgbClr val="0F172A"/>
+              <a:rPr sz="1000" b="1">
+                <a:solidFill>
+                  <a:srgbClr val="0A2540"/>
                 </a:solidFill>
                 <a:latin typeface="Segoe UI"/>
               </a:rPr>
               <a:t>• Presupuesto de Retención: </a:t>
             </a:r>
             <a:r>
-              <a:rPr sz="1000">
-                <a:solidFill>
-                  <a:srgbClr val="64748B"/>
+              <a:rPr sz="950">
+                <a:solidFill>
+                  <a:srgbClr val="1E293B"/>
                 </a:solidFill>
                 <a:latin typeface="Segoe UI"/>
               </a:rPr>
@@ -6551,7 +7497,7 @@
             <a:avLst/>
           </a:prstGeom>
           <a:solidFill>
-            <a:srgbClr val="F8FAFC"/>
+            <a:srgbClr val="FFFFFF"/>
           </a:solidFill>
           <a:ln>
             <a:noFill/>
@@ -6581,14 +7527,129 @@
       </p:sp>
       <p:sp>
         <p:nvSpPr>
-          <p:cNvPr id="3" name="TextBox 2"/>
+          <p:cNvPr id="3" name="Rectangle 2"/>
+          <p:cNvSpPr/>
+          <p:nvPr/>
+        </p:nvSpPr>
+        <p:spPr>
+          <a:xfrm>
+            <a:off x="731520" y="6263640"/>
+            <a:ext cx="10728655" cy="13716"/>
+          </a:xfrm>
+          <a:prstGeom prst="rect">
+            <a:avLst/>
+          </a:prstGeom>
+          <a:solidFill>
+            <a:srgbClr val="E2E8F0"/>
+          </a:solidFill>
+          <a:ln>
+            <a:noFill/>
+          </a:ln>
+        </p:spPr>
+        <p:style>
+          <a:lnRef idx="1">
+            <a:schemeClr val="accent1"/>
+          </a:lnRef>
+          <a:fillRef idx="3">
+            <a:schemeClr val="accent1"/>
+          </a:fillRef>
+          <a:effectRef idx="2">
+            <a:schemeClr val="accent1"/>
+          </a:effectRef>
+          <a:fontRef idx="minor">
+            <a:schemeClr val="lt1"/>
+          </a:fontRef>
+        </p:style>
+        <p:txBody>
+          <a:bodyPr rtlCol="0" anchor="ctr"/>
+          <a:lstStyle/>
+          <a:p>
+            <a:pPr algn="ctr"/>
+          </a:p>
+        </p:txBody>
+      </p:sp>
+      <p:sp>
+        <p:nvSpPr>
+          <p:cNvPr id="4" name="TextBox 3"/>
           <p:cNvSpPr txBox="1"/>
           <p:nvPr/>
         </p:nvSpPr>
         <p:spPr>
           <a:xfrm>
-            <a:off x="731520" y="365760"/>
-            <a:ext cx="10698480" cy="1005840"/>
+            <a:off x="731520" y="6327648"/>
+            <a:ext cx="7315200" cy="365760"/>
+          </a:xfrm>
+          <a:prstGeom prst="rect">
+            <a:avLst/>
+          </a:prstGeom>
+          <a:noFill/>
+        </p:spPr>
+        <p:txBody>
+          <a:bodyPr wrap="none" lIns="0" tIns="0" rIns="0" bIns="0">
+            <a:spAutoFit/>
+          </a:bodyPr>
+          <a:lstStyle/>
+          <a:p>
+            <a:pPr>
+              <a:defRPr sz="900">
+                <a:solidFill>
+                  <a:srgbClr val="64748B"/>
+                </a:solidFill>
+                <a:latin typeface="Segoe UI"/>
+              </a:defRPr>
+            </a:pPr>
+            <a:r>
+              <a:t>Workforce Dynamic Lens v1.0.0  •  MedTech Global Solutions  •  Executive Analytics Briefing</a:t>
+            </a:r>
+          </a:p>
+        </p:txBody>
+      </p:sp>
+      <p:sp>
+        <p:nvSpPr>
+          <p:cNvPr id="5" name="TextBox 4"/>
+          <p:cNvSpPr txBox="1"/>
+          <p:nvPr/>
+        </p:nvSpPr>
+        <p:spPr>
+          <a:xfrm>
+            <a:off x="9631375" y="6327648"/>
+            <a:ext cx="1828800" cy="365760"/>
+          </a:xfrm>
+          <a:prstGeom prst="rect">
+            <a:avLst/>
+          </a:prstGeom>
+          <a:noFill/>
+        </p:spPr>
+        <p:txBody>
+          <a:bodyPr wrap="none" lIns="0" tIns="0" rIns="0" bIns="0">
+            <a:spAutoFit/>
+          </a:bodyPr>
+          <a:lstStyle/>
+          <a:p>
+            <a:pPr algn="r">
+              <a:defRPr sz="900" b="1">
+                <a:solidFill>
+                  <a:srgbClr val="64748B"/>
+                </a:solidFill>
+                <a:latin typeface="Segoe UI"/>
+              </a:defRPr>
+            </a:pPr>
+            <a:r>
+              <a:t>08 / 09</a:t>
+            </a:r>
+          </a:p>
+        </p:txBody>
+      </p:sp>
+      <p:sp>
+        <p:nvSpPr>
+          <p:cNvPr id="6" name="TextBox 5"/>
+          <p:cNvSpPr txBox="1"/>
+          <p:nvPr/>
+        </p:nvSpPr>
+        <p:spPr>
+          <a:xfrm>
+            <a:off x="731520" y="384048"/>
+            <a:ext cx="10728655" cy="777240"/>
           </a:xfrm>
           <a:prstGeom prst="rect">
             <a:avLst/>
@@ -6602,22 +7663,25 @@
           <a:lstStyle/>
           <a:p>
             <a:pPr>
-              <a:defRPr sz="1000" b="1">
-                <a:solidFill>
-                  <a:srgbClr val="0284C7"/>
-                </a:solidFill>
-                <a:latin typeface="Segoe UI"/>
-              </a:defRPr>
-            </a:pPr>
-            <a:r>
-              <a:t>WORKFORCE DYNAMIC LENS | EXECUTIVE BRIEFING</a:t>
-            </a:r>
-          </a:p>
-          <a:p>
-            <a:pPr>
-              <a:defRPr sz="2200" b="1">
-                <a:solidFill>
-                  <a:srgbClr val="0F172A"/>
+              <a:spcAft>
+                <a:spcPts val="200"/>
+              </a:spcAft>
+              <a:defRPr sz="950" b="1">
+                <a:solidFill>
+                  <a:srgbClr val="1D4ED8"/>
+                </a:solidFill>
+                <a:latin typeface="Segoe UI"/>
+              </a:defRPr>
+            </a:pPr>
+            <a:r>
+              <a:t>MEDTECH GLOBAL SOLUTIONS  |  PEOPLE ANALYTICS</a:t>
+            </a:r>
+          </a:p>
+          <a:p>
+            <a:pPr>
+              <a:defRPr sz="2000" b="1">
+                <a:solidFill>
+                  <a:srgbClr val="0A2540"/>
                 </a:solidFill>
                 <a:latin typeface="Segoe UI"/>
               </a:defRPr>
@@ -6630,20 +7694,63 @@
       </p:sp>
       <p:sp>
         <p:nvSpPr>
-          <p:cNvPr id="4" name="Rounded Rectangle 3"/>
+          <p:cNvPr id="7" name="Rectangle 6"/>
           <p:cNvSpPr/>
           <p:nvPr/>
         </p:nvSpPr>
         <p:spPr>
           <a:xfrm>
+            <a:off x="731520" y="1234440"/>
+            <a:ext cx="10728655" cy="13716"/>
+          </a:xfrm>
+          <a:prstGeom prst="rect">
+            <a:avLst/>
+          </a:prstGeom>
+          <a:solidFill>
+            <a:srgbClr val="E2E8F0"/>
+          </a:solidFill>
+          <a:ln>
+            <a:noFill/>
+          </a:ln>
+        </p:spPr>
+        <p:style>
+          <a:lnRef idx="1">
+            <a:schemeClr val="accent1"/>
+          </a:lnRef>
+          <a:fillRef idx="3">
+            <a:schemeClr val="accent1"/>
+          </a:fillRef>
+          <a:effectRef idx="2">
+            <a:schemeClr val="accent1"/>
+          </a:effectRef>
+          <a:fontRef idx="minor">
+            <a:schemeClr val="lt1"/>
+          </a:fontRef>
+        </p:style>
+        <p:txBody>
+          <a:bodyPr rtlCol="0" anchor="ctr"/>
+          <a:lstStyle/>
+          <a:p>
+            <a:pPr algn="ctr"/>
+          </a:p>
+        </p:txBody>
+      </p:sp>
+      <p:sp>
+        <p:nvSpPr>
+          <p:cNvPr id="8" name="Rectangle 7"/>
+          <p:cNvSpPr/>
+          <p:nvPr/>
+        </p:nvSpPr>
+        <p:spPr>
+          <a:xfrm>
             <a:off x="731520" y="1463040"/>
-            <a:ext cx="3429000" cy="3108960"/>
-          </a:xfrm>
-          <a:prstGeom prst="roundRect">
+            <a:ext cx="3429000" cy="2926080"/>
+          </a:xfrm>
+          <a:prstGeom prst="rect">
             <a:avLst/>
           </a:prstGeom>
           <a:solidFill>
-            <a:srgbClr val="FFFFFF"/>
+            <a:srgbClr val="F8FAFC"/>
           </a:solidFill>
           <a:ln w="12700">
             <a:solidFill>
@@ -6675,14 +7782,14 @@
       </p:sp>
       <p:sp>
         <p:nvSpPr>
-          <p:cNvPr id="5" name="TextBox 4"/>
+          <p:cNvPr id="9" name="TextBox 8"/>
           <p:cNvSpPr txBox="1"/>
           <p:nvPr/>
         </p:nvSpPr>
         <p:spPr>
           <a:xfrm>
             <a:off x="914400" y="1645920"/>
-            <a:ext cx="3063240" cy="2743200"/>
+            <a:ext cx="3063240" cy="2560320"/>
           </a:xfrm>
           <a:prstGeom prst="rect">
             <a:avLst/>
@@ -6699,9 +7806,9 @@
               <a:spcAft>
                 <a:spcPts val="800"/>
               </a:spcAft>
-              <a:defRPr sz="1300" b="1">
-                <a:solidFill>
-                  <a:srgbClr val="E11D48"/>
+              <a:defRPr sz="1200" b="1">
+                <a:solidFill>
+                  <a:srgbClr val="BE123C"/>
                 </a:solidFill>
                 <a:latin typeface="Segoe UI"/>
               </a:defRPr>
@@ -6715,9 +7822,9 @@
               <a:spcAft>
                 <a:spcPts val="1000"/>
               </a:spcAft>
-              <a:defRPr sz="1100">
-                <a:solidFill>
-                  <a:srgbClr val="0F172A"/>
+              <a:defRPr sz="1050">
+                <a:solidFill>
+                  <a:srgbClr val="1E293B"/>
                 </a:solidFill>
                 <a:latin typeface="Segoe UI"/>
               </a:defRPr>
@@ -6731,9 +7838,9 @@
               <a:spcAft>
                 <a:spcPts val="600"/>
               </a:spcAft>
-              <a:defRPr sz="1100" b="1">
-                <a:solidFill>
-                  <a:srgbClr val="0284C7"/>
+              <a:defRPr sz="1050" b="1">
+                <a:solidFill>
+                  <a:srgbClr val="0A2540"/>
                 </a:solidFill>
                 <a:latin typeface="Segoe UI"/>
               </a:defRPr>
@@ -6744,7 +7851,7 @@
           </a:p>
           <a:p>
             <a:pPr>
-              <a:defRPr sz="1000">
+              <a:defRPr sz="950">
                 <a:solidFill>
                   <a:srgbClr val="64748B"/>
                 </a:solidFill>
@@ -6759,20 +7866,20 @@
       </p:sp>
       <p:sp>
         <p:nvSpPr>
-          <p:cNvPr id="6" name="Rounded Rectangle 5"/>
+          <p:cNvPr id="10" name="Rectangle 9"/>
           <p:cNvSpPr/>
           <p:nvPr/>
         </p:nvSpPr>
         <p:spPr>
           <a:xfrm>
             <a:off x="4379976" y="1463040"/>
-            <a:ext cx="3429000" cy="3108960"/>
-          </a:xfrm>
-          <a:prstGeom prst="roundRect">
+            <a:ext cx="3429000" cy="2926080"/>
+          </a:xfrm>
+          <a:prstGeom prst="rect">
             <a:avLst/>
           </a:prstGeom>
           <a:solidFill>
-            <a:srgbClr val="FFFFFF"/>
+            <a:srgbClr val="F8FAFC"/>
           </a:solidFill>
           <a:ln w="12700">
             <a:solidFill>
@@ -6804,14 +7911,14 @@
       </p:sp>
       <p:sp>
         <p:nvSpPr>
-          <p:cNvPr id="7" name="TextBox 6"/>
+          <p:cNvPr id="11" name="TextBox 10"/>
           <p:cNvSpPr txBox="1"/>
           <p:nvPr/>
         </p:nvSpPr>
         <p:spPr>
           <a:xfrm>
             <a:off x="4562856" y="1645920"/>
-            <a:ext cx="3063240" cy="2743200"/>
+            <a:ext cx="3063240" cy="2560320"/>
           </a:xfrm>
           <a:prstGeom prst="rect">
             <a:avLst/>
@@ -6828,9 +7935,9 @@
               <a:spcAft>
                 <a:spcPts val="800"/>
               </a:spcAft>
-              <a:defRPr sz="1300" b="1">
-                <a:solidFill>
-                  <a:srgbClr val="0284C7"/>
+              <a:defRPr sz="1200" b="1">
+                <a:solidFill>
+                  <a:srgbClr val="1D4ED8"/>
                 </a:solidFill>
                 <a:latin typeface="Segoe UI"/>
               </a:defRPr>
@@ -6844,9 +7951,9 @@
               <a:spcAft>
                 <a:spcPts val="1000"/>
               </a:spcAft>
-              <a:defRPr sz="1100">
-                <a:solidFill>
-                  <a:srgbClr val="0F172A"/>
+              <a:defRPr sz="1050">
+                <a:solidFill>
+                  <a:srgbClr val="1E293B"/>
                 </a:solidFill>
                 <a:latin typeface="Segoe UI"/>
               </a:defRPr>
@@ -6860,9 +7967,9 @@
               <a:spcAft>
                 <a:spcPts val="600"/>
               </a:spcAft>
-              <a:defRPr sz="1100" b="1">
-                <a:solidFill>
-                  <a:srgbClr val="0284C7"/>
+              <a:defRPr sz="1050" b="1">
+                <a:solidFill>
+                  <a:srgbClr val="0A2540"/>
                 </a:solidFill>
                 <a:latin typeface="Segoe UI"/>
               </a:defRPr>
@@ -6873,7 +7980,7 @@
           </a:p>
           <a:p>
             <a:pPr>
-              <a:defRPr sz="1000">
+              <a:defRPr sz="950">
                 <a:solidFill>
                   <a:srgbClr val="64748B"/>
                 </a:solidFill>
@@ -6881,27 +7988,27 @@
               </a:defRPr>
             </a:pPr>
             <a:r>
-              <a:t>Impacto: Reducción del 35% en micro-ausentismo y erradicación de multas por SLA hospitalario ($1.3M).</a:t>
-            </a:r>
-          </a:p>
-        </p:txBody>
-      </p:sp>
-      <p:sp>
-        <p:nvSpPr>
-          <p:cNvPr id="8" name="Rounded Rectangle 7"/>
+              <a:t>Impacto: Reducción del 35% en micro-ausentismo y erradicación de multas por SLA ($1.3M).</a:t>
+            </a:r>
+          </a:p>
+        </p:txBody>
+      </p:sp>
+      <p:sp>
+        <p:nvSpPr>
+          <p:cNvPr id="12" name="Rectangle 11"/>
           <p:cNvSpPr/>
           <p:nvPr/>
         </p:nvSpPr>
         <p:spPr>
           <a:xfrm>
             <a:off x="8028432" y="1463040"/>
-            <a:ext cx="3429000" cy="3108960"/>
-          </a:xfrm>
-          <a:prstGeom prst="roundRect">
+            <a:ext cx="3429000" cy="2926080"/>
+          </a:xfrm>
+          <a:prstGeom prst="rect">
             <a:avLst/>
           </a:prstGeom>
           <a:solidFill>
-            <a:srgbClr val="FFFFFF"/>
+            <a:srgbClr val="F8FAFC"/>
           </a:solidFill>
           <a:ln w="12700">
             <a:solidFill>
@@ -6933,14 +8040,14 @@
       </p:sp>
       <p:sp>
         <p:nvSpPr>
-          <p:cNvPr id="9" name="TextBox 8"/>
+          <p:cNvPr id="13" name="TextBox 12"/>
           <p:cNvSpPr txBox="1"/>
           <p:nvPr/>
         </p:nvSpPr>
         <p:spPr>
           <a:xfrm>
             <a:off x="8211312" y="1645920"/>
-            <a:ext cx="3063240" cy="2743200"/>
+            <a:ext cx="3063240" cy="2560320"/>
           </a:xfrm>
           <a:prstGeom prst="rect">
             <a:avLst/>
@@ -6957,9 +8064,9 @@
               <a:spcAft>
                 <a:spcPts val="800"/>
               </a:spcAft>
-              <a:defRPr sz="1300" b="1">
-                <a:solidFill>
-                  <a:srgbClr val="10B981"/>
+              <a:defRPr sz="1200" b="1">
+                <a:solidFill>
+                  <a:srgbClr val="059669"/>
                 </a:solidFill>
                 <a:latin typeface="Segoe UI"/>
               </a:defRPr>
@@ -6973,9 +8080,9 @@
               <a:spcAft>
                 <a:spcPts val="1000"/>
               </a:spcAft>
-              <a:defRPr sz="1100">
-                <a:solidFill>
-                  <a:srgbClr val="0F172A"/>
+              <a:defRPr sz="1050">
+                <a:solidFill>
+                  <a:srgbClr val="1E293B"/>
                 </a:solidFill>
                 <a:latin typeface="Segoe UI"/>
               </a:defRPr>
@@ -6989,9 +8096,9 @@
               <a:spcAft>
                 <a:spcPts val="600"/>
               </a:spcAft>
-              <a:defRPr sz="1100" b="1">
-                <a:solidFill>
-                  <a:srgbClr val="0284C7"/>
+              <a:defRPr sz="1050" b="1">
+                <a:solidFill>
+                  <a:srgbClr val="0A2540"/>
                 </a:solidFill>
                 <a:latin typeface="Segoe UI"/>
               </a:defRPr>
@@ -7002,7 +8109,7 @@
           </a:p>
           <a:p>
             <a:pPr>
-              <a:defRPr sz="1000">
+              <a:defRPr sz="950">
                 <a:solidFill>
                   <a:srgbClr val="64748B"/>
                 </a:solidFill>
@@ -7017,20 +8124,20 @@
       </p:sp>
       <p:sp>
         <p:nvSpPr>
-          <p:cNvPr id="10" name="Rounded Rectangle 9"/>
+          <p:cNvPr id="14" name="Rectangle 13"/>
           <p:cNvSpPr/>
           <p:nvPr/>
         </p:nvSpPr>
         <p:spPr>
           <a:xfrm>
-            <a:off x="731520" y="4754880"/>
-            <a:ext cx="10725912" cy="1554480"/>
-          </a:xfrm>
-          <a:prstGeom prst="roundRect">
+            <a:off x="731520" y="4572000"/>
+            <a:ext cx="10728655" cy="1463040"/>
+          </a:xfrm>
+          <a:prstGeom prst="rect">
             <a:avLst/>
           </a:prstGeom>
           <a:solidFill>
-            <a:srgbClr val="F1F5F9"/>
+            <a:srgbClr val="F8FAFC"/>
           </a:solidFill>
           <a:ln w="12700">
             <a:solidFill>
@@ -7062,14 +8169,14 @@
       </p:sp>
       <p:sp>
         <p:nvSpPr>
-          <p:cNvPr id="11" name="TextBox 10"/>
+          <p:cNvPr id="15" name="TextBox 14"/>
           <p:cNvSpPr txBox="1"/>
           <p:nvPr/>
         </p:nvSpPr>
         <p:spPr>
           <a:xfrm>
-            <a:off x="1005840" y="4892040"/>
-            <a:ext cx="10149840" cy="1280160"/>
+            <a:off x="1005840" y="4709160"/>
+            <a:ext cx="10180015" cy="1188720"/>
           </a:xfrm>
           <a:prstGeom prst="rect">
             <a:avLst/>
@@ -7086,9 +8193,9 @@
               <a:spcAft>
                 <a:spcPts val="600"/>
               </a:spcAft>
-              <a:defRPr sz="1100" b="1">
-                <a:solidFill>
-                  <a:srgbClr val="0284C7"/>
+              <a:defRPr sz="1050" b="1">
+                <a:solidFill>
+                  <a:srgbClr val="1D4ED8"/>
                 </a:solidFill>
                 <a:latin typeface="Segoe UI"/>
               </a:defRPr>
@@ -7099,9 +8206,9 @@
           </a:p>
           <a:p>
             <a:pPr>
-              <a:defRPr sz="1200" b="1">
-                <a:solidFill>
-                  <a:srgbClr val="0F172A"/>
+              <a:defRPr sz="1150" b="1">
+                <a:solidFill>
+                  <a:srgbClr val="0A2540"/>
                 </a:solidFill>
                 <a:latin typeface="Segoe UI"/>
               </a:defRPr>
@@ -7149,7 +8256,7 @@
             <a:avLst/>
           </a:prstGeom>
           <a:solidFill>
-            <a:srgbClr val="F8FAFC"/>
+            <a:srgbClr val="FFFFFF"/>
           </a:solidFill>
           <a:ln>
             <a:noFill/>
@@ -7179,14 +8286,129 @@
       </p:sp>
       <p:sp>
         <p:nvSpPr>
-          <p:cNvPr id="3" name="TextBox 2"/>
+          <p:cNvPr id="3" name="Rectangle 2"/>
+          <p:cNvSpPr/>
+          <p:nvPr/>
+        </p:nvSpPr>
+        <p:spPr>
+          <a:xfrm>
+            <a:off x="731520" y="6263640"/>
+            <a:ext cx="10728655" cy="13716"/>
+          </a:xfrm>
+          <a:prstGeom prst="rect">
+            <a:avLst/>
+          </a:prstGeom>
+          <a:solidFill>
+            <a:srgbClr val="E2E8F0"/>
+          </a:solidFill>
+          <a:ln>
+            <a:noFill/>
+          </a:ln>
+        </p:spPr>
+        <p:style>
+          <a:lnRef idx="1">
+            <a:schemeClr val="accent1"/>
+          </a:lnRef>
+          <a:fillRef idx="3">
+            <a:schemeClr val="accent1"/>
+          </a:fillRef>
+          <a:effectRef idx="2">
+            <a:schemeClr val="accent1"/>
+          </a:effectRef>
+          <a:fontRef idx="minor">
+            <a:schemeClr val="lt1"/>
+          </a:fontRef>
+        </p:style>
+        <p:txBody>
+          <a:bodyPr rtlCol="0" anchor="ctr"/>
+          <a:lstStyle/>
+          <a:p>
+            <a:pPr algn="ctr"/>
+          </a:p>
+        </p:txBody>
+      </p:sp>
+      <p:sp>
+        <p:nvSpPr>
+          <p:cNvPr id="4" name="TextBox 3"/>
           <p:cNvSpPr txBox="1"/>
           <p:nvPr/>
         </p:nvSpPr>
         <p:spPr>
           <a:xfrm>
-            <a:off x="731520" y="365760"/>
-            <a:ext cx="10698480" cy="1005840"/>
+            <a:off x="731520" y="6327648"/>
+            <a:ext cx="7315200" cy="365760"/>
+          </a:xfrm>
+          <a:prstGeom prst="rect">
+            <a:avLst/>
+          </a:prstGeom>
+          <a:noFill/>
+        </p:spPr>
+        <p:txBody>
+          <a:bodyPr wrap="none" lIns="0" tIns="0" rIns="0" bIns="0">
+            <a:spAutoFit/>
+          </a:bodyPr>
+          <a:lstStyle/>
+          <a:p>
+            <a:pPr>
+              <a:defRPr sz="900">
+                <a:solidFill>
+                  <a:srgbClr val="64748B"/>
+                </a:solidFill>
+                <a:latin typeface="Segoe UI"/>
+              </a:defRPr>
+            </a:pPr>
+            <a:r>
+              <a:t>Workforce Dynamic Lens v1.0.0  •  MedTech Global Solutions  •  Executive Analytics Briefing</a:t>
+            </a:r>
+          </a:p>
+        </p:txBody>
+      </p:sp>
+      <p:sp>
+        <p:nvSpPr>
+          <p:cNvPr id="5" name="TextBox 4"/>
+          <p:cNvSpPr txBox="1"/>
+          <p:nvPr/>
+        </p:nvSpPr>
+        <p:spPr>
+          <a:xfrm>
+            <a:off x="9631375" y="6327648"/>
+            <a:ext cx="1828800" cy="365760"/>
+          </a:xfrm>
+          <a:prstGeom prst="rect">
+            <a:avLst/>
+          </a:prstGeom>
+          <a:noFill/>
+        </p:spPr>
+        <p:txBody>
+          <a:bodyPr wrap="none" lIns="0" tIns="0" rIns="0" bIns="0">
+            <a:spAutoFit/>
+          </a:bodyPr>
+          <a:lstStyle/>
+          <a:p>
+            <a:pPr algn="r">
+              <a:defRPr sz="900" b="1">
+                <a:solidFill>
+                  <a:srgbClr val="64748B"/>
+                </a:solidFill>
+                <a:latin typeface="Segoe UI"/>
+              </a:defRPr>
+            </a:pPr>
+            <a:r>
+              <a:t>09 / 09</a:t>
+            </a:r>
+          </a:p>
+        </p:txBody>
+      </p:sp>
+      <p:sp>
+        <p:nvSpPr>
+          <p:cNvPr id="6" name="TextBox 5"/>
+          <p:cNvSpPr txBox="1"/>
+          <p:nvPr/>
+        </p:nvSpPr>
+        <p:spPr>
+          <a:xfrm>
+            <a:off x="731520" y="384048"/>
+            <a:ext cx="10728655" cy="777240"/>
           </a:xfrm>
           <a:prstGeom prst="rect">
             <a:avLst/>
@@ -7200,9 +8422,12 @@
           <a:lstStyle/>
           <a:p>
             <a:pPr>
-              <a:defRPr sz="1000" b="1">
-                <a:solidFill>
-                  <a:srgbClr val="0284C7"/>
+              <a:spcAft>
+                <a:spcPts val="200"/>
+              </a:spcAft>
+              <a:defRPr sz="950" b="1">
+                <a:solidFill>
+                  <a:srgbClr val="1D4ED8"/>
                 </a:solidFill>
                 <a:latin typeface="Segoe UI"/>
               </a:defRPr>
@@ -7213,9 +8438,9 @@
           </a:p>
           <a:p>
             <a:pPr>
-              <a:defRPr sz="2200" b="1">
-                <a:solidFill>
-                  <a:srgbClr val="0F172A"/>
+              <a:defRPr sz="2000" b="1">
+                <a:solidFill>
+                  <a:srgbClr val="0A2540"/>
                 </a:solidFill>
                 <a:latin typeface="Segoe UI"/>
               </a:defRPr>
@@ -7228,20 +8453,63 @@
       </p:sp>
       <p:sp>
         <p:nvSpPr>
-          <p:cNvPr id="4" name="Rounded Rectangle 3"/>
+          <p:cNvPr id="7" name="Rectangle 6"/>
           <p:cNvSpPr/>
           <p:nvPr/>
         </p:nvSpPr>
         <p:spPr>
           <a:xfrm>
+            <a:off x="731520" y="1234440"/>
+            <a:ext cx="10728655" cy="13716"/>
+          </a:xfrm>
+          <a:prstGeom prst="rect">
+            <a:avLst/>
+          </a:prstGeom>
+          <a:solidFill>
+            <a:srgbClr val="E2E8F0"/>
+          </a:solidFill>
+          <a:ln>
+            <a:noFill/>
+          </a:ln>
+        </p:spPr>
+        <p:style>
+          <a:lnRef idx="1">
+            <a:schemeClr val="accent1"/>
+          </a:lnRef>
+          <a:fillRef idx="3">
+            <a:schemeClr val="accent1"/>
+          </a:fillRef>
+          <a:effectRef idx="2">
+            <a:schemeClr val="accent1"/>
+          </a:effectRef>
+          <a:fontRef idx="minor">
+            <a:schemeClr val="lt1"/>
+          </a:fontRef>
+        </p:style>
+        <p:txBody>
+          <a:bodyPr rtlCol="0" anchor="ctr"/>
+          <a:lstStyle/>
+          <a:p>
+            <a:pPr algn="ctr"/>
+          </a:p>
+        </p:txBody>
+      </p:sp>
+      <p:sp>
+        <p:nvSpPr>
+          <p:cNvPr id="8" name="Rectangle 7"/>
+          <p:cNvSpPr/>
+          <p:nvPr/>
+        </p:nvSpPr>
+        <p:spPr>
+          <a:xfrm>
             <a:off x="731520" y="1463040"/>
-            <a:ext cx="10725912" cy="4846320"/>
-          </a:xfrm>
-          <a:prstGeom prst="roundRect">
+            <a:ext cx="10728655" cy="4572000"/>
+          </a:xfrm>
+          <a:prstGeom prst="rect">
             <a:avLst/>
           </a:prstGeom>
           <a:solidFill>
-            <a:srgbClr val="FFFFFF"/>
+            <a:srgbClr val="F8FAFC"/>
           </a:solidFill>
           <a:ln w="12700">
             <a:solidFill>
@@ -7273,14 +8541,14 @@
       </p:sp>
       <p:sp>
         <p:nvSpPr>
-          <p:cNvPr id="5" name="TextBox 4"/>
+          <p:cNvPr id="9" name="TextBox 8"/>
           <p:cNvSpPr txBox="1"/>
           <p:nvPr/>
         </p:nvSpPr>
         <p:spPr>
           <a:xfrm>
-            <a:off x="1097280" y="1737360"/>
-            <a:ext cx="9966960" cy="4297680"/>
+            <a:off x="1097280" y="1691640"/>
+            <a:ext cx="9997135" cy="4114800"/>
           </a:xfrm>
           <a:prstGeom prst="rect">
             <a:avLst/>
@@ -7297,9 +8565,9 @@
               <a:spcAft>
                 <a:spcPts val="400"/>
               </a:spcAft>
-              <a:defRPr sz="1100" b="1">
-                <a:solidFill>
-                  <a:srgbClr val="0284C7"/>
+              <a:defRPr sz="1050" b="1">
+                <a:solidFill>
+                  <a:srgbClr val="1D4ED8"/>
                 </a:solidFill>
                 <a:latin typeface="Segoe UI"/>
               </a:defRPr>
@@ -7313,9 +8581,9 @@
               <a:spcAft>
                 <a:spcPts val="400"/>
               </a:spcAft>
-              <a:defRPr sz="3000" b="1">
-                <a:solidFill>
-                  <a:srgbClr val="0F172A"/>
+              <a:defRPr sz="2800" b="1">
+                <a:solidFill>
+                  <a:srgbClr val="0A2540"/>
                 </a:solidFill>
                 <a:latin typeface="Segoe UI"/>
               </a:defRPr>
@@ -7329,9 +8597,9 @@
               <a:spcAft>
                 <a:spcPts val="1400"/>
               </a:spcAft>
-              <a:defRPr sz="1400" b="1">
-                <a:solidFill>
-                  <a:srgbClr val="0284C7"/>
+              <a:defRPr sz="1300" b="1">
+                <a:solidFill>
+                  <a:srgbClr val="1D4ED8"/>
                 </a:solidFill>
                 <a:latin typeface="Segoe UI"/>
               </a:defRPr>
@@ -7349,7 +8617,7 @@
               <a:spcAft>
                 <a:spcPts val="1800"/>
               </a:spcAft>
-              <a:defRPr sz="1150">
+              <a:defRPr sz="1100">
                 <a:solidFill>
                   <a:srgbClr val="1E293B"/>
                 </a:solidFill>
@@ -7371,18 +8639,18 @@
               </a:spcAft>
             </a:pPr>
             <a:r>
-              <a:rPr sz="1100" b="1">
-                <a:solidFill>
-                  <a:srgbClr val="0284C7"/>
+              <a:rPr sz="1050" b="1">
+                <a:solidFill>
+                  <a:srgbClr val="0A2540"/>
                 </a:solidFill>
                 <a:latin typeface="Segoe UI"/>
               </a:rPr>
               <a:t>• LinkedIn: </a:t>
             </a:r>
             <a:r>
-              <a:rPr sz="1100">
-                <a:solidFill>
-                  <a:srgbClr val="0F172A"/>
+              <a:rPr sz="1050">
+                <a:solidFill>
+                  <a:srgbClr val="1D4ED8"/>
                 </a:solidFill>
                 <a:latin typeface="Segoe UI"/>
               </a:rPr>
@@ -7396,18 +8664,18 @@
               </a:spcAft>
             </a:pPr>
             <a:r>
-              <a:rPr sz="1100" b="1">
-                <a:solidFill>
-                  <a:srgbClr val="0284C7"/>
+              <a:rPr sz="1050" b="1">
+                <a:solidFill>
+                  <a:srgbClr val="0A2540"/>
                 </a:solidFill>
                 <a:latin typeface="Segoe UI"/>
               </a:rPr>
               <a:t>• GitHub: </a:t>
             </a:r>
             <a:r>
-              <a:rPr sz="1100">
-                <a:solidFill>
-                  <a:srgbClr val="0F172A"/>
+              <a:rPr sz="1050">
+                <a:solidFill>
+                  <a:srgbClr val="1D4ED8"/>
                 </a:solidFill>
                 <a:latin typeface="Segoe UI"/>
               </a:rPr>
@@ -7421,18 +8689,18 @@
               </a:spcAft>
             </a:pPr>
             <a:r>
-              <a:rPr sz="1100" b="1">
-                <a:solidFill>
-                  <a:srgbClr val="0284C7"/>
+              <a:rPr sz="1050" b="1">
+                <a:solidFill>
+                  <a:srgbClr val="0A2540"/>
                 </a:solidFill>
                 <a:latin typeface="Segoe UI"/>
               </a:rPr>
               <a:t>• Email: </a:t>
             </a:r>
             <a:r>
-              <a:rPr sz="1100">
-                <a:solidFill>
-                  <a:srgbClr val="0F172A"/>
+              <a:rPr sz="1050">
+                <a:solidFill>
+                  <a:srgbClr val="1D4ED8"/>
                 </a:solidFill>
                 <a:latin typeface="Segoe UI"/>
               </a:rPr>
@@ -7446,18 +8714,18 @@
               </a:spcAft>
             </a:pPr>
             <a:r>
-              <a:rPr sz="1100" b="1">
-                <a:solidFill>
-                  <a:srgbClr val="0284C7"/>
+              <a:rPr sz="1050" b="1">
+                <a:solidFill>
+                  <a:srgbClr val="0A2540"/>
                 </a:solidFill>
                 <a:latin typeface="Segoe UI"/>
               </a:rPr>
               <a:t>• Repositorio: </a:t>
             </a:r>
             <a:r>
-              <a:rPr sz="1100">
-                <a:solidFill>
-                  <a:srgbClr val="0F172A"/>
+              <a:rPr sz="1050">
+                <a:solidFill>
+                  <a:srgbClr val="1D4ED8"/>
                 </a:solidFill>
                 <a:latin typeface="Segoe UI"/>
               </a:rPr>

</xml_diff>